<commit_message>
Add file-trail diagram slide to proposal deck
New slide traces one café (ALkhozama) through the pipeline as files:
raw/places.csv -> processed/places_clean.csv -> standardize splits into
entities_core.csv (facts to filter) and kb_documents.csv (text to embed),
which feed the structured SQLite layer and the semantic vector store
respectively; a note lists the 4 entity-resolution relationship files.
Deck now 11 slides; schema validation passes.

Co-Authored-By: Claude Opus 4.8 <noreply@anthropic.com>
Claude-Session: https://claude.ai/code/session_01NGG3PfYdyeFGmt8xWkYAuk
</commit_message>
<xml_diff>
--- a/docs/Saudi_Digital_Concierge_Proposal.pptx
+++ b/docs/Saudi_Digital_Concierge_Proposal.pptx
@@ -15,9 +15,10 @@
     <p:sldId id="263" r:id="rId9"/>
     <p:sldId id="264" r:id="rId10"/>
     <p:sldId id="265" r:id="rId11"/>
+    <p:sldId id="266" r:id="rId12"/>
   </p:sldIdLst>
   <p:notesMasterIdLst>
-    <p:notesMasterId r:id="rId12"/>
+    <p:notesMasterId r:id="rId13"/>
   </p:notesMasterIdLst>
   <p:sldSz cx="12192000" cy="6858000"/>
   <p:notesSz cx="6858000" cy="12192000"/>
@@ -623,6 +624,94 @@
             <a:fld id="{F7021451-1387-4CA6-816F-3879F97B5CBC}" type="slidenum">
               <a:rPr lang="en-US"/>
               <a:t>10</a:t>
+            </a:fld>
+            <a:endParaRPr lang="en-US"/>
+          </a:p>
+        </p:txBody>
+      </p:sp>
+    </p:spTree>
+    <p:extLst>
+      <p:ext uri="{BB962C8B-B14F-4D97-AF65-F5344CB8AC3E}">
+        <p14:creationId xmlns:p14="http://schemas.microsoft.com/office/powerpoint/2010/main" val="1024086991"/>
+      </p:ext>
+    </p:extLst>
+  </p:cSld>
+  <p:clrMapOvr>
+    <a:masterClrMapping/>
+  </p:clrMapOvr>
+</p:notes>
+</file>
+
+<file path=ppt/notesSlides/notesSlide11.xml><?xml version="1.0" encoding="utf-8"?>
+<p:notes xmlns:a="http://schemas.openxmlformats.org/drawingml/2006/main" xmlns:r="http://schemas.openxmlformats.org/officeDocument/2006/relationships" xmlns:p="http://schemas.openxmlformats.org/presentationml/2006/main">
+  <p:cSld>
+    <p:spTree>
+      <p:nvGrpSpPr>
+        <p:cNvPr id="1" name=""/>
+        <p:cNvGrpSpPr/>
+        <p:nvPr/>
+      </p:nvGrpSpPr>
+      <p:grpSpPr>
+        <a:xfrm>
+          <a:off x="0" y="0"/>
+          <a:ext cx="0" cy="0"/>
+          <a:chOff x="0" y="0"/>
+          <a:chExt cx="0" cy="0"/>
+        </a:xfrm>
+      </p:grpSpPr>
+      <p:sp>
+        <p:nvSpPr>
+          <p:cNvPr id="2" name="Slide Image Placeholder 1"/>
+          <p:cNvSpPr>
+            <a:spLocks noGrp="1" noRot="1" noChangeAspect="1"/>
+          </p:cNvSpPr>
+          <p:nvPr>
+            <p:ph type="sldImg"/>
+          </p:nvPr>
+        </p:nvSpPr>
+        <p:spPr/>
+      </p:sp>
+      <p:sp>
+        <p:nvSpPr>
+          <p:cNvPr id="3" name="Notes Placeholder 2"/>
+          <p:cNvSpPr>
+            <a:spLocks noGrp="1"/>
+          </p:cNvSpPr>
+          <p:nvPr>
+            <p:ph type="body" idx="1"/>
+          </p:nvPr>
+        </p:nvSpPr>
+        <p:spPr/>
+        <p:txBody>
+          <a:bodyPr/>
+          <a:lstStyle/>
+          <a:p>
+            <a:r>
+              <a:rPr lang="en-US" dirty="0"/>
+              <a:t/>
+            </a:r>
+            <a:endParaRPr lang="en-US" dirty="0"/>
+          </a:p>
+        </p:txBody>
+      </p:sp>
+      <p:sp>
+        <p:nvSpPr>
+          <p:cNvPr id="4" name="Slide Number Placeholder 3"/>
+          <p:cNvSpPr>
+            <a:spLocks noGrp="1"/>
+          </p:cNvSpPr>
+          <p:nvPr>
+            <p:ph type="sldNum" sz="quarter" idx="10"/>
+          </p:nvPr>
+        </p:nvSpPr>
+        <p:spPr/>
+        <p:txBody>
+          <a:bodyPr/>
+          <a:lstStyle/>
+          <a:p>
+            <a:fld id="{F7021451-1387-4CA6-816F-3879F97B5CBC}" type="slidenum">
+              <a:rPr lang="en-US"/>
+              <a:t>11</a:t>
             </a:fld>
             <a:endParaRPr lang="en-US"/>
           </a:p>
@@ -1909,6 +1998,1322 @@
     <p:bg>
       <p:bgPr>
         <a:solidFill>
+          <a:srgbClr val="0B3B36"/>
+        </a:solidFill>
+      </p:bgPr>
+    </p:bg>
+    <p:spTree>
+      <p:nvGrpSpPr>
+        <p:cNvPr id="1" name=""/>
+        <p:cNvGrpSpPr/>
+        <p:nvPr/>
+      </p:nvGrpSpPr>
+      <p:grpSpPr>
+        <a:xfrm>
+          <a:off x="0" y="0"/>
+          <a:ext cx="0" cy="0"/>
+          <a:chOff x="0" y="0"/>
+          <a:chExt cx="0" cy="0"/>
+        </a:xfrm>
+      </p:grpSpPr>
+      <p:sp>
+        <p:nvSpPr>
+          <p:cNvPr id="2" name="Text 0"/>
+          <p:cNvSpPr txBox="1"/>
+          <p:nvPr/>
+        </p:nvSpPr>
+        <p:spPr>
+          <a:xfrm>
+            <a:off x="640080" y="457200"/>
+            <a:ext cx="10972800" cy="640080"/>
+          </a:xfrm>
+          <a:prstGeom prst="rect">
+            <a:avLst/>
+          </a:prstGeom>
+          <a:noFill/>
+          <a:ln/>
+        </p:spPr>
+        <p:txBody>
+          <a:bodyPr wrap="square" lIns="0" tIns="0" rIns="0" bIns="0" rtlCol="0" anchor="ctr"/>
+          <a:lstStyle/>
+          <a:p>
+            <a:pPr indent="0" marL="0">
+              <a:buNone/>
+            </a:pPr>
+            <a:r>
+              <a:rPr lang="en-US" sz="3200" b="1" dirty="0">
+                <a:solidFill>
+                  <a:srgbClr val="FFFFFF"/>
+                </a:solidFill>
+                <a:latin typeface="Cambria" pitchFamily="34" charset="0"/>
+                <a:ea typeface="Cambria" pitchFamily="34" charset="-122"/>
+                <a:cs typeface="Cambria" pitchFamily="34" charset="-120"/>
+              </a:rPr>
+              <a:t>What's built — the data pipeline</a:t>
+            </a:r>
+            <a:endParaRPr lang="en-US" sz="3200" dirty="0"/>
+          </a:p>
+        </p:txBody>
+      </p:sp>
+      <p:sp>
+        <p:nvSpPr>
+          <p:cNvPr id="3" name="Text 1"/>
+          <p:cNvSpPr txBox="1"/>
+          <p:nvPr/>
+        </p:nvSpPr>
+        <p:spPr>
+          <a:xfrm>
+            <a:off x="640080" y="1097280"/>
+            <a:ext cx="10972800" cy="365760"/>
+          </a:xfrm>
+          <a:prstGeom prst="rect">
+            <a:avLst/>
+          </a:prstGeom>
+          <a:noFill/>
+          <a:ln/>
+        </p:spPr>
+        <p:txBody>
+          <a:bodyPr wrap="square" lIns="0" tIns="0" rIns="0" bIns="0" rtlCol="0" anchor="ctr"/>
+          <a:lstStyle/>
+          <a:p>
+            <a:pPr indent="0" marL="0">
+              <a:buNone/>
+            </a:pPr>
+            <a:r>
+              <a:rPr lang="en-US" sz="1500" i="1" dirty="0">
+                <a:solidFill>
+                  <a:srgbClr val="9FB8B3"/>
+                </a:solidFill>
+                <a:latin typeface="Calibri" pitchFamily="34" charset="0"/>
+                <a:ea typeface="Calibri" pitchFamily="34" charset="-122"/>
+                <a:cs typeface="Calibri" pitchFamily="34" charset="-120"/>
+              </a:rPr>
+              <a:t>Reproducible, raw → clean → standardize → resolve → hybrid KB</a:t>
+            </a:r>
+            <a:endParaRPr lang="en-US" sz="1500" dirty="0"/>
+          </a:p>
+        </p:txBody>
+      </p:sp>
+      <p:sp>
+        <p:nvSpPr>
+          <p:cNvPr id="4" name="Shape 2"/>
+          <p:cNvSpPr/>
+          <p:nvPr/>
+        </p:nvSpPr>
+        <p:spPr>
+          <a:xfrm>
+            <a:off x="640080" y="1645920"/>
+            <a:ext cx="5349240" cy="1097280"/>
+          </a:xfrm>
+          <a:prstGeom prst="roundRect">
+            <a:avLst>
+              <a:gd name="adj" fmla="val 5833"/>
+            </a:avLst>
+          </a:prstGeom>
+          <a:solidFill>
+            <a:srgbClr val="12514A"/>
+          </a:solidFill>
+          <a:ln/>
+        </p:spPr>
+      </p:sp>
+      <p:sp>
+        <p:nvSpPr>
+          <p:cNvPr id="5" name="Shape 3"/>
+          <p:cNvSpPr/>
+          <p:nvPr/>
+        </p:nvSpPr>
+        <p:spPr>
+          <a:xfrm>
+            <a:off x="868680" y="1975104"/>
+            <a:ext cx="438912" cy="438912"/>
+          </a:xfrm>
+          <a:prstGeom prst="ellipse">
+            <a:avLst/>
+          </a:prstGeom>
+          <a:solidFill>
+            <a:srgbClr val="C9A227"/>
+          </a:solidFill>
+          <a:ln/>
+        </p:spPr>
+      </p:sp>
+      <p:sp>
+        <p:nvSpPr>
+          <p:cNvPr id="6" name="Text 4"/>
+          <p:cNvSpPr txBox="1"/>
+          <p:nvPr/>
+        </p:nvSpPr>
+        <p:spPr>
+          <a:xfrm>
+            <a:off x="868680" y="1975104"/>
+            <a:ext cx="438912" cy="438912"/>
+          </a:xfrm>
+          <a:prstGeom prst="rect">
+            <a:avLst/>
+          </a:prstGeom>
+          <a:noFill/>
+          <a:ln/>
+        </p:spPr>
+        <p:txBody>
+          <a:bodyPr wrap="square" lIns="0" tIns="0" rIns="0" bIns="0" rtlCol="0" anchor="ctr"/>
+          <a:lstStyle/>
+          <a:p>
+            <a:pPr algn="ctr" indent="0" marL="0">
+              <a:buNone/>
+            </a:pPr>
+            <a:r>
+              <a:rPr lang="en-US" sz="2000" b="1" dirty="0">
+                <a:solidFill>
+                  <a:srgbClr val="0B3B36"/>
+                </a:solidFill>
+                <a:latin typeface="Cambria" pitchFamily="34" charset="0"/>
+                <a:ea typeface="Cambria" pitchFamily="34" charset="-122"/>
+                <a:cs typeface="Cambria" pitchFamily="34" charset="-120"/>
+              </a:rPr>
+              <a:t>1</a:t>
+            </a:r>
+            <a:endParaRPr lang="en-US" sz="2000" dirty="0"/>
+          </a:p>
+        </p:txBody>
+      </p:sp>
+      <p:sp>
+        <p:nvSpPr>
+          <p:cNvPr id="7" name="Text 5"/>
+          <p:cNvSpPr txBox="1"/>
+          <p:nvPr/>
+        </p:nvSpPr>
+        <p:spPr>
+          <a:xfrm>
+            <a:off x="1463040" y="1828800"/>
+            <a:ext cx="4389120" cy="365760"/>
+          </a:xfrm>
+          <a:prstGeom prst="rect">
+            <a:avLst/>
+          </a:prstGeom>
+          <a:noFill/>
+          <a:ln/>
+        </p:spPr>
+        <p:txBody>
+          <a:bodyPr wrap="square" lIns="0" tIns="0" rIns="0" bIns="0" rtlCol="0" anchor="ctr"/>
+          <a:lstStyle/>
+          <a:p>
+            <a:pPr indent="0" marL="0">
+              <a:buNone/>
+            </a:pPr>
+            <a:r>
+              <a:rPr lang="en-US" sz="1600" b="1" dirty="0">
+                <a:solidFill>
+                  <a:srgbClr val="FFFFFF"/>
+                </a:solidFill>
+                <a:latin typeface="Cambria" pitchFamily="34" charset="0"/>
+                <a:ea typeface="Cambria" pitchFamily="34" charset="-122"/>
+                <a:cs typeface="Cambria" pitchFamily="34" charset="-120"/>
+              </a:rPr>
+              <a:t>Exploration &amp; Audit</a:t>
+            </a:r>
+            <a:endParaRPr lang="en-US" sz="1600" dirty="0"/>
+          </a:p>
+        </p:txBody>
+      </p:sp>
+      <p:sp>
+        <p:nvSpPr>
+          <p:cNvPr id="8" name="Text 6"/>
+          <p:cNvSpPr txBox="1"/>
+          <p:nvPr/>
+        </p:nvSpPr>
+        <p:spPr>
+          <a:xfrm>
+            <a:off x="1463040" y="2194560"/>
+            <a:ext cx="4389120" cy="457200"/>
+          </a:xfrm>
+          <a:prstGeom prst="rect">
+            <a:avLst/>
+          </a:prstGeom>
+          <a:noFill/>
+          <a:ln/>
+        </p:spPr>
+        <p:txBody>
+          <a:bodyPr wrap="square" lIns="0" tIns="0" rIns="0" bIns="0" rtlCol="0" anchor="ctr"/>
+          <a:lstStyle/>
+          <a:p>
+            <a:pPr indent="0" marL="0">
+              <a:lnSpc>
+                <a:spcPct val="100000"/>
+              </a:lnSpc>
+              <a:buNone/>
+            </a:pPr>
+            <a:r>
+              <a:rPr lang="en-US" sz="1250" dirty="0">
+                <a:solidFill>
+                  <a:srgbClr val="CFE3DF"/>
+                </a:solidFill>
+                <a:latin typeface="Calibri" pitchFamily="34" charset="0"/>
+                <a:ea typeface="Calibri" pitchFamily="34" charset="-122"/>
+                <a:cs typeface="Calibri" pitchFamily="34" charset="-120"/>
+              </a:rPr>
+              <a:t>Per-source notebooks + 11-point quality audit</a:t>
+            </a:r>
+            <a:endParaRPr lang="en-US" sz="1250" dirty="0"/>
+          </a:p>
+        </p:txBody>
+      </p:sp>
+      <p:sp>
+        <p:nvSpPr>
+          <p:cNvPr id="9" name="Shape 7"/>
+          <p:cNvSpPr/>
+          <p:nvPr/>
+        </p:nvSpPr>
+        <p:spPr>
+          <a:xfrm>
+            <a:off x="6217920" y="1645920"/>
+            <a:ext cx="5349240" cy="1097280"/>
+          </a:xfrm>
+          <a:prstGeom prst="roundRect">
+            <a:avLst>
+              <a:gd name="adj" fmla="val 5833"/>
+            </a:avLst>
+          </a:prstGeom>
+          <a:solidFill>
+            <a:srgbClr val="12514A"/>
+          </a:solidFill>
+          <a:ln/>
+        </p:spPr>
+      </p:sp>
+      <p:sp>
+        <p:nvSpPr>
+          <p:cNvPr id="10" name="Shape 8"/>
+          <p:cNvSpPr/>
+          <p:nvPr/>
+        </p:nvSpPr>
+        <p:spPr>
+          <a:xfrm>
+            <a:off x="6446520" y="1975104"/>
+            <a:ext cx="438912" cy="438912"/>
+          </a:xfrm>
+          <a:prstGeom prst="ellipse">
+            <a:avLst/>
+          </a:prstGeom>
+          <a:solidFill>
+            <a:srgbClr val="C9A227"/>
+          </a:solidFill>
+          <a:ln/>
+        </p:spPr>
+      </p:sp>
+      <p:sp>
+        <p:nvSpPr>
+          <p:cNvPr id="11" name="Text 9"/>
+          <p:cNvSpPr txBox="1"/>
+          <p:nvPr/>
+        </p:nvSpPr>
+        <p:spPr>
+          <a:xfrm>
+            <a:off x="6446520" y="1975104"/>
+            <a:ext cx="438912" cy="438912"/>
+          </a:xfrm>
+          <a:prstGeom prst="rect">
+            <a:avLst/>
+          </a:prstGeom>
+          <a:noFill/>
+          <a:ln/>
+        </p:spPr>
+        <p:txBody>
+          <a:bodyPr wrap="square" lIns="0" tIns="0" rIns="0" bIns="0" rtlCol="0" anchor="ctr"/>
+          <a:lstStyle/>
+          <a:p>
+            <a:pPr algn="ctr" indent="0" marL="0">
+              <a:buNone/>
+            </a:pPr>
+            <a:r>
+              <a:rPr lang="en-US" sz="2000" b="1" dirty="0">
+                <a:solidFill>
+                  <a:srgbClr val="0B3B36"/>
+                </a:solidFill>
+                <a:latin typeface="Cambria" pitchFamily="34" charset="0"/>
+                <a:ea typeface="Cambria" pitchFamily="34" charset="-122"/>
+                <a:cs typeface="Cambria" pitchFamily="34" charset="-120"/>
+              </a:rPr>
+              <a:t>2</a:t>
+            </a:r>
+            <a:endParaRPr lang="en-US" sz="2000" dirty="0"/>
+          </a:p>
+        </p:txBody>
+      </p:sp>
+      <p:sp>
+        <p:nvSpPr>
+          <p:cNvPr id="12" name="Text 10"/>
+          <p:cNvSpPr txBox="1"/>
+          <p:nvPr/>
+        </p:nvSpPr>
+        <p:spPr>
+          <a:xfrm>
+            <a:off x="7040880" y="1828800"/>
+            <a:ext cx="4389120" cy="365760"/>
+          </a:xfrm>
+          <a:prstGeom prst="rect">
+            <a:avLst/>
+          </a:prstGeom>
+          <a:noFill/>
+          <a:ln/>
+        </p:spPr>
+        <p:txBody>
+          <a:bodyPr wrap="square" lIns="0" tIns="0" rIns="0" bIns="0" rtlCol="0" anchor="ctr"/>
+          <a:lstStyle/>
+          <a:p>
+            <a:pPr indent="0" marL="0">
+              <a:buNone/>
+            </a:pPr>
+            <a:r>
+              <a:rPr lang="en-US" sz="1600" b="1" dirty="0">
+                <a:solidFill>
+                  <a:srgbClr val="FFFFFF"/>
+                </a:solidFill>
+                <a:latin typeface="Cambria" pitchFamily="34" charset="0"/>
+                <a:ea typeface="Cambria" pitchFamily="34" charset="-122"/>
+                <a:cs typeface="Cambria" pitchFamily="34" charset="-120"/>
+              </a:rPr>
+              <a:t>Data Contract</a:t>
+            </a:r>
+            <a:endParaRPr lang="en-US" sz="1600" dirty="0"/>
+          </a:p>
+        </p:txBody>
+      </p:sp>
+      <p:sp>
+        <p:nvSpPr>
+          <p:cNvPr id="13" name="Text 11"/>
+          <p:cNvSpPr txBox="1"/>
+          <p:nvPr/>
+        </p:nvSpPr>
+        <p:spPr>
+          <a:xfrm>
+            <a:off x="7040880" y="2194560"/>
+            <a:ext cx="4389120" cy="457200"/>
+          </a:xfrm>
+          <a:prstGeom prst="rect">
+            <a:avLst/>
+          </a:prstGeom>
+          <a:noFill/>
+          <a:ln/>
+        </p:spPr>
+        <p:txBody>
+          <a:bodyPr wrap="square" lIns="0" tIns="0" rIns="0" bIns="0" rtlCol="0" anchor="ctr"/>
+          <a:lstStyle/>
+          <a:p>
+            <a:pPr indent="0" marL="0">
+              <a:lnSpc>
+                <a:spcPct val="100000"/>
+              </a:lnSpc>
+              <a:buNone/>
+            </a:pPr>
+            <a:r>
+              <a:rPr lang="en-US" sz="1250" dirty="0">
+                <a:solidFill>
+                  <a:srgbClr val="CFE3DF"/>
+                </a:solidFill>
+                <a:latin typeface="Calibri" pitchFamily="34" charset="0"/>
+                <a:ea typeface="Calibri" pitchFamily="34" charset="-122"/>
+                <a:cs typeface="Calibri" pitchFamily="34" charset="-120"/>
+              </a:rPr>
+              <a:t>Target schema, units, provenance (data_dictionary.md)</a:t>
+            </a:r>
+            <a:endParaRPr lang="en-US" sz="1250" dirty="0"/>
+          </a:p>
+        </p:txBody>
+      </p:sp>
+      <p:sp>
+        <p:nvSpPr>
+          <p:cNvPr id="14" name="Shape 12"/>
+          <p:cNvSpPr/>
+          <p:nvPr/>
+        </p:nvSpPr>
+        <p:spPr>
+          <a:xfrm>
+            <a:off x="640080" y="2880360"/>
+            <a:ext cx="5349240" cy="1097280"/>
+          </a:xfrm>
+          <a:prstGeom prst="roundRect">
+            <a:avLst>
+              <a:gd name="adj" fmla="val 5833"/>
+            </a:avLst>
+          </a:prstGeom>
+          <a:solidFill>
+            <a:srgbClr val="12514A"/>
+          </a:solidFill>
+          <a:ln/>
+        </p:spPr>
+      </p:sp>
+      <p:sp>
+        <p:nvSpPr>
+          <p:cNvPr id="15" name="Shape 13"/>
+          <p:cNvSpPr/>
+          <p:nvPr/>
+        </p:nvSpPr>
+        <p:spPr>
+          <a:xfrm>
+            <a:off x="868680" y="3209544"/>
+            <a:ext cx="438912" cy="438912"/>
+          </a:xfrm>
+          <a:prstGeom prst="ellipse">
+            <a:avLst/>
+          </a:prstGeom>
+          <a:solidFill>
+            <a:srgbClr val="C9A227"/>
+          </a:solidFill>
+          <a:ln/>
+        </p:spPr>
+      </p:sp>
+      <p:sp>
+        <p:nvSpPr>
+          <p:cNvPr id="16" name="Text 14"/>
+          <p:cNvSpPr txBox="1"/>
+          <p:nvPr/>
+        </p:nvSpPr>
+        <p:spPr>
+          <a:xfrm>
+            <a:off x="868680" y="3209544"/>
+            <a:ext cx="438912" cy="438912"/>
+          </a:xfrm>
+          <a:prstGeom prst="rect">
+            <a:avLst/>
+          </a:prstGeom>
+          <a:noFill/>
+          <a:ln/>
+        </p:spPr>
+        <p:txBody>
+          <a:bodyPr wrap="square" lIns="0" tIns="0" rIns="0" bIns="0" rtlCol="0" anchor="ctr"/>
+          <a:lstStyle/>
+          <a:p>
+            <a:pPr algn="ctr" indent="0" marL="0">
+              <a:buNone/>
+            </a:pPr>
+            <a:r>
+              <a:rPr lang="en-US" sz="2000" b="1" dirty="0">
+                <a:solidFill>
+                  <a:srgbClr val="0B3B36"/>
+                </a:solidFill>
+                <a:latin typeface="Cambria" pitchFamily="34" charset="0"/>
+                <a:ea typeface="Cambria" pitchFamily="34" charset="-122"/>
+                <a:cs typeface="Cambria" pitchFamily="34" charset="-120"/>
+              </a:rPr>
+              <a:t>3</a:t>
+            </a:r>
+            <a:endParaRPr lang="en-US" sz="2000" dirty="0"/>
+          </a:p>
+        </p:txBody>
+      </p:sp>
+      <p:sp>
+        <p:nvSpPr>
+          <p:cNvPr id="17" name="Text 15"/>
+          <p:cNvSpPr txBox="1"/>
+          <p:nvPr/>
+        </p:nvSpPr>
+        <p:spPr>
+          <a:xfrm>
+            <a:off x="1463040" y="3063240"/>
+            <a:ext cx="4389120" cy="365760"/>
+          </a:xfrm>
+          <a:prstGeom prst="rect">
+            <a:avLst/>
+          </a:prstGeom>
+          <a:noFill/>
+          <a:ln/>
+        </p:spPr>
+        <p:txBody>
+          <a:bodyPr wrap="square" lIns="0" tIns="0" rIns="0" bIns="0" rtlCol="0" anchor="ctr"/>
+          <a:lstStyle/>
+          <a:p>
+            <a:pPr indent="0" marL="0">
+              <a:buNone/>
+            </a:pPr>
+            <a:r>
+              <a:rPr lang="en-US" sz="1600" b="1" dirty="0">
+                <a:solidFill>
+                  <a:srgbClr val="FFFFFF"/>
+                </a:solidFill>
+                <a:latin typeface="Cambria" pitchFamily="34" charset="0"/>
+                <a:ea typeface="Cambria" pitchFamily="34" charset="-122"/>
+                <a:cs typeface="Cambria" pitchFamily="34" charset="-120"/>
+              </a:rPr>
+              <a:t>Cleaning</a:t>
+            </a:r>
+            <a:endParaRPr lang="en-US" sz="1600" dirty="0"/>
+          </a:p>
+        </p:txBody>
+      </p:sp>
+      <p:sp>
+        <p:nvSpPr>
+          <p:cNvPr id="18" name="Text 16"/>
+          <p:cNvSpPr txBox="1"/>
+          <p:nvPr/>
+        </p:nvSpPr>
+        <p:spPr>
+          <a:xfrm>
+            <a:off x="1463040" y="3429000"/>
+            <a:ext cx="4389120" cy="457200"/>
+          </a:xfrm>
+          <a:prstGeom prst="rect">
+            <a:avLst/>
+          </a:prstGeom>
+          <a:noFill/>
+          <a:ln/>
+        </p:spPr>
+        <p:txBody>
+          <a:bodyPr wrap="square" lIns="0" tIns="0" rIns="0" bIns="0" rtlCol="0" anchor="ctr"/>
+          <a:lstStyle/>
+          <a:p>
+            <a:pPr indent="0" marL="0">
+              <a:lnSpc>
+                <a:spcPct val="100000"/>
+              </a:lnSpc>
+              <a:buNone/>
+            </a:pPr>
+            <a:r>
+              <a:rPr lang="en-US" sz="1250" dirty="0">
+                <a:solidFill>
+                  <a:srgbClr val="CFE3DF"/>
+                </a:solidFill>
+                <a:latin typeface="Calibri" pitchFamily="34" charset="0"/>
+                <a:ea typeface="Calibri" pitchFamily="34" charset="-122"/>
+                <a:cs typeface="Calibri" pitchFamily="34" charset="-120"/>
+              </a:rPr>
+              <a:t>raw→clean→validate; rating 0 = unrated, not 0/5</a:t>
+            </a:r>
+            <a:endParaRPr lang="en-US" sz="1250" dirty="0"/>
+          </a:p>
+        </p:txBody>
+      </p:sp>
+      <p:sp>
+        <p:nvSpPr>
+          <p:cNvPr id="19" name="Shape 17"/>
+          <p:cNvSpPr/>
+          <p:nvPr/>
+        </p:nvSpPr>
+        <p:spPr>
+          <a:xfrm>
+            <a:off x="6217920" y="2880360"/>
+            <a:ext cx="5349240" cy="1097280"/>
+          </a:xfrm>
+          <a:prstGeom prst="roundRect">
+            <a:avLst>
+              <a:gd name="adj" fmla="val 5833"/>
+            </a:avLst>
+          </a:prstGeom>
+          <a:solidFill>
+            <a:srgbClr val="12514A"/>
+          </a:solidFill>
+          <a:ln/>
+        </p:spPr>
+      </p:sp>
+      <p:sp>
+        <p:nvSpPr>
+          <p:cNvPr id="20" name="Shape 18"/>
+          <p:cNvSpPr/>
+          <p:nvPr/>
+        </p:nvSpPr>
+        <p:spPr>
+          <a:xfrm>
+            <a:off x="6446520" y="3209544"/>
+            <a:ext cx="438912" cy="438912"/>
+          </a:xfrm>
+          <a:prstGeom prst="ellipse">
+            <a:avLst/>
+          </a:prstGeom>
+          <a:solidFill>
+            <a:srgbClr val="C9A227"/>
+          </a:solidFill>
+          <a:ln/>
+        </p:spPr>
+      </p:sp>
+      <p:sp>
+        <p:nvSpPr>
+          <p:cNvPr id="21" name="Text 19"/>
+          <p:cNvSpPr txBox="1"/>
+          <p:nvPr/>
+        </p:nvSpPr>
+        <p:spPr>
+          <a:xfrm>
+            <a:off x="6446520" y="3209544"/>
+            <a:ext cx="438912" cy="438912"/>
+          </a:xfrm>
+          <a:prstGeom prst="rect">
+            <a:avLst/>
+          </a:prstGeom>
+          <a:noFill/>
+          <a:ln/>
+        </p:spPr>
+        <p:txBody>
+          <a:bodyPr wrap="square" lIns="0" tIns="0" rIns="0" bIns="0" rtlCol="0" anchor="ctr"/>
+          <a:lstStyle/>
+          <a:p>
+            <a:pPr algn="ctr" indent="0" marL="0">
+              <a:buNone/>
+            </a:pPr>
+            <a:r>
+              <a:rPr lang="en-US" sz="2000" b="1" dirty="0">
+                <a:solidFill>
+                  <a:srgbClr val="0B3B36"/>
+                </a:solidFill>
+                <a:latin typeface="Cambria" pitchFamily="34" charset="0"/>
+                <a:ea typeface="Cambria" pitchFamily="34" charset="-122"/>
+                <a:cs typeface="Cambria" pitchFamily="34" charset="-120"/>
+              </a:rPr>
+              <a:t>4</a:t>
+            </a:r>
+            <a:endParaRPr lang="en-US" sz="2000" dirty="0"/>
+          </a:p>
+        </p:txBody>
+      </p:sp>
+      <p:sp>
+        <p:nvSpPr>
+          <p:cNvPr id="22" name="Text 20"/>
+          <p:cNvSpPr txBox="1"/>
+          <p:nvPr/>
+        </p:nvSpPr>
+        <p:spPr>
+          <a:xfrm>
+            <a:off x="7040880" y="3063240"/>
+            <a:ext cx="4389120" cy="365760"/>
+          </a:xfrm>
+          <a:prstGeom prst="rect">
+            <a:avLst/>
+          </a:prstGeom>
+          <a:noFill/>
+          <a:ln/>
+        </p:spPr>
+        <p:txBody>
+          <a:bodyPr wrap="square" lIns="0" tIns="0" rIns="0" bIns="0" rtlCol="0" anchor="ctr"/>
+          <a:lstStyle/>
+          <a:p>
+            <a:pPr indent="0" marL="0">
+              <a:buNone/>
+            </a:pPr>
+            <a:r>
+              <a:rPr lang="en-US" sz="1600" b="1" dirty="0">
+                <a:solidFill>
+                  <a:srgbClr val="FFFFFF"/>
+                </a:solidFill>
+                <a:latin typeface="Cambria" pitchFamily="34" charset="0"/>
+                <a:ea typeface="Cambria" pitchFamily="34" charset="-122"/>
+                <a:cs typeface="Cambria" pitchFamily="34" charset="-120"/>
+              </a:rPr>
+              <a:t>Standardization</a:t>
+            </a:r>
+            <a:endParaRPr lang="en-US" sz="1600" dirty="0"/>
+          </a:p>
+        </p:txBody>
+      </p:sp>
+      <p:sp>
+        <p:nvSpPr>
+          <p:cNvPr id="23" name="Text 21"/>
+          <p:cNvSpPr txBox="1"/>
+          <p:nvPr/>
+        </p:nvSpPr>
+        <p:spPr>
+          <a:xfrm>
+            <a:off x="7040880" y="3429000"/>
+            <a:ext cx="4389120" cy="457200"/>
+          </a:xfrm>
+          <a:prstGeom prst="rect">
+            <a:avLst/>
+          </a:prstGeom>
+          <a:noFill/>
+          <a:ln/>
+        </p:spPr>
+        <p:txBody>
+          <a:bodyPr wrap="square" lIns="0" tIns="0" rIns="0" bIns="0" rtlCol="0" anchor="ctr"/>
+          <a:lstStyle/>
+          <a:p>
+            <a:pPr indent="0" marL="0">
+              <a:lnSpc>
+                <a:spcPct val="100000"/>
+              </a:lnSpc>
+              <a:buNone/>
+            </a:pPr>
+            <a:r>
+              <a:rPr lang="en-US" sz="1250" dirty="0">
+                <a:solidFill>
+                  <a:srgbClr val="CFE3DF"/>
+                </a:solidFill>
+                <a:latin typeface="Calibri" pitchFamily="34" charset="0"/>
+                <a:ea typeface="Calibri" pitchFamily="34" charset="-122"/>
+                <a:cs typeface="Calibri" pitchFamily="34" charset="-120"/>
+              </a:rPr>
+              <a:t>Shared schema, rating_norm, bilingual documents</a:t>
+            </a:r>
+            <a:endParaRPr lang="en-US" sz="1250" dirty="0"/>
+          </a:p>
+        </p:txBody>
+      </p:sp>
+      <p:sp>
+        <p:nvSpPr>
+          <p:cNvPr id="24" name="Shape 22"/>
+          <p:cNvSpPr/>
+          <p:nvPr/>
+        </p:nvSpPr>
+        <p:spPr>
+          <a:xfrm>
+            <a:off x="640080" y="4114800"/>
+            <a:ext cx="5349240" cy="1097280"/>
+          </a:xfrm>
+          <a:prstGeom prst="roundRect">
+            <a:avLst>
+              <a:gd name="adj" fmla="val 5833"/>
+            </a:avLst>
+          </a:prstGeom>
+          <a:solidFill>
+            <a:srgbClr val="12514A"/>
+          </a:solidFill>
+          <a:ln/>
+        </p:spPr>
+      </p:sp>
+      <p:sp>
+        <p:nvSpPr>
+          <p:cNvPr id="25" name="Shape 23"/>
+          <p:cNvSpPr/>
+          <p:nvPr/>
+        </p:nvSpPr>
+        <p:spPr>
+          <a:xfrm>
+            <a:off x="868680" y="4443984"/>
+            <a:ext cx="438912" cy="438912"/>
+          </a:xfrm>
+          <a:prstGeom prst="ellipse">
+            <a:avLst/>
+          </a:prstGeom>
+          <a:solidFill>
+            <a:srgbClr val="C9A227"/>
+          </a:solidFill>
+          <a:ln/>
+        </p:spPr>
+      </p:sp>
+      <p:sp>
+        <p:nvSpPr>
+          <p:cNvPr id="26" name="Text 24"/>
+          <p:cNvSpPr txBox="1"/>
+          <p:nvPr/>
+        </p:nvSpPr>
+        <p:spPr>
+          <a:xfrm>
+            <a:off x="868680" y="4443984"/>
+            <a:ext cx="438912" cy="438912"/>
+          </a:xfrm>
+          <a:prstGeom prst="rect">
+            <a:avLst/>
+          </a:prstGeom>
+          <a:noFill/>
+          <a:ln/>
+        </p:spPr>
+        <p:txBody>
+          <a:bodyPr wrap="square" lIns="0" tIns="0" rIns="0" bIns="0" rtlCol="0" anchor="ctr"/>
+          <a:lstStyle/>
+          <a:p>
+            <a:pPr algn="ctr" indent="0" marL="0">
+              <a:buNone/>
+            </a:pPr>
+            <a:r>
+              <a:rPr lang="en-US" sz="2000" b="1" dirty="0">
+                <a:solidFill>
+                  <a:srgbClr val="0B3B36"/>
+                </a:solidFill>
+                <a:latin typeface="Cambria" pitchFamily="34" charset="0"/>
+                <a:ea typeface="Cambria" pitchFamily="34" charset="-122"/>
+                <a:cs typeface="Cambria" pitchFamily="34" charset="-120"/>
+              </a:rPr>
+              <a:t>5</a:t>
+            </a:r>
+            <a:endParaRPr lang="en-US" sz="2000" dirty="0"/>
+          </a:p>
+        </p:txBody>
+      </p:sp>
+      <p:sp>
+        <p:nvSpPr>
+          <p:cNvPr id="27" name="Text 25"/>
+          <p:cNvSpPr txBox="1"/>
+          <p:nvPr/>
+        </p:nvSpPr>
+        <p:spPr>
+          <a:xfrm>
+            <a:off x="1463040" y="4297680"/>
+            <a:ext cx="4389120" cy="365760"/>
+          </a:xfrm>
+          <a:prstGeom prst="rect">
+            <a:avLst/>
+          </a:prstGeom>
+          <a:noFill/>
+          <a:ln/>
+        </p:spPr>
+        <p:txBody>
+          <a:bodyPr wrap="square" lIns="0" tIns="0" rIns="0" bIns="0" rtlCol="0" anchor="ctr"/>
+          <a:lstStyle/>
+          <a:p>
+            <a:pPr indent="0" marL="0">
+              <a:buNone/>
+            </a:pPr>
+            <a:r>
+              <a:rPr lang="en-US" sz="1600" b="1" dirty="0">
+                <a:solidFill>
+                  <a:srgbClr val="FFFFFF"/>
+                </a:solidFill>
+                <a:latin typeface="Cambria" pitchFamily="34" charset="0"/>
+                <a:ea typeface="Cambria" pitchFamily="34" charset="-122"/>
+                <a:cs typeface="Cambria" pitchFamily="34" charset="-120"/>
+              </a:rPr>
+              <a:t>Entity Resolution</a:t>
+            </a:r>
+            <a:endParaRPr lang="en-US" sz="1600" dirty="0"/>
+          </a:p>
+        </p:txBody>
+      </p:sp>
+      <p:sp>
+        <p:nvSpPr>
+          <p:cNvPr id="28" name="Text 26"/>
+          <p:cNvSpPr txBox="1"/>
+          <p:nvPr/>
+        </p:nvSpPr>
+        <p:spPr>
+          <a:xfrm>
+            <a:off x="1463040" y="4663440"/>
+            <a:ext cx="4389120" cy="457200"/>
+          </a:xfrm>
+          <a:prstGeom prst="rect">
+            <a:avLst/>
+          </a:prstGeom>
+          <a:noFill/>
+          <a:ln/>
+        </p:spPr>
+        <p:txBody>
+          <a:bodyPr wrap="square" lIns="0" tIns="0" rIns="0" bIns="0" rtlCol="0" anchor="ctr"/>
+          <a:lstStyle/>
+          <a:p>
+            <a:pPr indent="0" marL="0">
+              <a:lnSpc>
+                <a:spcPct val="100000"/>
+              </a:lnSpc>
+              <a:buNone/>
+            </a:pPr>
+            <a:r>
+              <a:rPr lang="en-US" sz="1250" dirty="0">
+                <a:solidFill>
+                  <a:srgbClr val="CFE3DF"/>
+                </a:solidFill>
+                <a:latin typeface="Calibri" pitchFamily="34" charset="0"/>
+                <a:ea typeface="Calibri" pitchFamily="34" charset="-122"/>
+                <a:cs typeface="Calibri" pitchFamily="34" charset="-120"/>
+              </a:rPr>
+              <a:t>Canonical IDs (RYD_000123) via name+city+coords</a:t>
+            </a:r>
+            <a:endParaRPr lang="en-US" sz="1250" dirty="0"/>
+          </a:p>
+        </p:txBody>
+      </p:sp>
+      <p:sp>
+        <p:nvSpPr>
+          <p:cNvPr id="29" name="Shape 27"/>
+          <p:cNvSpPr/>
+          <p:nvPr/>
+        </p:nvSpPr>
+        <p:spPr>
+          <a:xfrm>
+            <a:off x="6217920" y="4114800"/>
+            <a:ext cx="5349240" cy="1097280"/>
+          </a:xfrm>
+          <a:prstGeom prst="roundRect">
+            <a:avLst>
+              <a:gd name="adj" fmla="val 5833"/>
+            </a:avLst>
+          </a:prstGeom>
+          <a:solidFill>
+            <a:srgbClr val="12514A"/>
+          </a:solidFill>
+          <a:ln/>
+        </p:spPr>
+      </p:sp>
+      <p:sp>
+        <p:nvSpPr>
+          <p:cNvPr id="30" name="Shape 28"/>
+          <p:cNvSpPr/>
+          <p:nvPr/>
+        </p:nvSpPr>
+        <p:spPr>
+          <a:xfrm>
+            <a:off x="6446520" y="4443984"/>
+            <a:ext cx="438912" cy="438912"/>
+          </a:xfrm>
+          <a:prstGeom prst="ellipse">
+            <a:avLst/>
+          </a:prstGeom>
+          <a:solidFill>
+            <a:srgbClr val="C9A227"/>
+          </a:solidFill>
+          <a:ln/>
+        </p:spPr>
+      </p:sp>
+      <p:sp>
+        <p:nvSpPr>
+          <p:cNvPr id="31" name="Text 29"/>
+          <p:cNvSpPr txBox="1"/>
+          <p:nvPr/>
+        </p:nvSpPr>
+        <p:spPr>
+          <a:xfrm>
+            <a:off x="6446520" y="4443984"/>
+            <a:ext cx="438912" cy="438912"/>
+          </a:xfrm>
+          <a:prstGeom prst="rect">
+            <a:avLst/>
+          </a:prstGeom>
+          <a:noFill/>
+          <a:ln/>
+        </p:spPr>
+        <p:txBody>
+          <a:bodyPr wrap="square" lIns="0" tIns="0" rIns="0" bIns="0" rtlCol="0" anchor="ctr"/>
+          <a:lstStyle/>
+          <a:p>
+            <a:pPr algn="ctr" indent="0" marL="0">
+              <a:buNone/>
+            </a:pPr>
+            <a:r>
+              <a:rPr lang="en-US" sz="2000" b="1" dirty="0">
+                <a:solidFill>
+                  <a:srgbClr val="0B3B36"/>
+                </a:solidFill>
+                <a:latin typeface="Cambria" pitchFamily="34" charset="0"/>
+                <a:ea typeface="Cambria" pitchFamily="34" charset="-122"/>
+                <a:cs typeface="Cambria" pitchFamily="34" charset="-120"/>
+              </a:rPr>
+              <a:t>6</a:t>
+            </a:r>
+            <a:endParaRPr lang="en-US" sz="2000" dirty="0"/>
+          </a:p>
+        </p:txBody>
+      </p:sp>
+      <p:sp>
+        <p:nvSpPr>
+          <p:cNvPr id="32" name="Text 30"/>
+          <p:cNvSpPr txBox="1"/>
+          <p:nvPr/>
+        </p:nvSpPr>
+        <p:spPr>
+          <a:xfrm>
+            <a:off x="7040880" y="4297680"/>
+            <a:ext cx="4389120" cy="365760"/>
+          </a:xfrm>
+          <a:prstGeom prst="rect">
+            <a:avLst/>
+          </a:prstGeom>
+          <a:noFill/>
+          <a:ln/>
+        </p:spPr>
+        <p:txBody>
+          <a:bodyPr wrap="square" lIns="0" tIns="0" rIns="0" bIns="0" rtlCol="0" anchor="ctr"/>
+          <a:lstStyle/>
+          <a:p>
+            <a:pPr indent="0" marL="0">
+              <a:buNone/>
+            </a:pPr>
+            <a:r>
+              <a:rPr lang="en-US" sz="1600" b="1" dirty="0">
+                <a:solidFill>
+                  <a:srgbClr val="FFFFFF"/>
+                </a:solidFill>
+                <a:latin typeface="Cambria" pitchFamily="34" charset="0"/>
+                <a:ea typeface="Cambria" pitchFamily="34" charset="-122"/>
+                <a:cs typeface="Cambria" pitchFamily="34" charset="-120"/>
+              </a:rPr>
+              <a:t>Hybrid KB</a:t>
+            </a:r>
+            <a:endParaRPr lang="en-US" sz="1600" dirty="0"/>
+          </a:p>
+        </p:txBody>
+      </p:sp>
+      <p:sp>
+        <p:nvSpPr>
+          <p:cNvPr id="33" name="Text 31"/>
+          <p:cNvSpPr txBox="1"/>
+          <p:nvPr/>
+        </p:nvSpPr>
+        <p:spPr>
+          <a:xfrm>
+            <a:off x="7040880" y="4663440"/>
+            <a:ext cx="4389120" cy="457200"/>
+          </a:xfrm>
+          <a:prstGeom prst="rect">
+            <a:avLst/>
+          </a:prstGeom>
+          <a:noFill/>
+          <a:ln/>
+        </p:spPr>
+        <p:txBody>
+          <a:bodyPr wrap="square" lIns="0" tIns="0" rIns="0" bIns="0" rtlCol="0" anchor="ctr"/>
+          <a:lstStyle/>
+          <a:p>
+            <a:pPr indent="0" marL="0">
+              <a:lnSpc>
+                <a:spcPct val="100000"/>
+              </a:lnSpc>
+              <a:buNone/>
+            </a:pPr>
+            <a:r>
+              <a:rPr lang="en-US" sz="1250" dirty="0">
+                <a:solidFill>
+                  <a:srgbClr val="CFE3DF"/>
+                </a:solidFill>
+                <a:latin typeface="Calibri" pitchFamily="34" charset="0"/>
+                <a:ea typeface="Calibri" pitchFamily="34" charset="-122"/>
+                <a:cs typeface="Calibri" pitchFamily="34" charset="-120"/>
+              </a:rPr>
+              <a:t>SQLite exact filters + multilingual vector store</a:t>
+            </a:r>
+            <a:endParaRPr lang="en-US" sz="1250" dirty="0"/>
+          </a:p>
+        </p:txBody>
+      </p:sp>
+      <p:sp>
+        <p:nvSpPr>
+          <p:cNvPr id="34" name="Text 32"/>
+          <p:cNvSpPr txBox="1"/>
+          <p:nvPr/>
+        </p:nvSpPr>
+        <p:spPr>
+          <a:xfrm>
+            <a:off x="640080" y="5806440"/>
+            <a:ext cx="3520440" cy="548640"/>
+          </a:xfrm>
+          <a:prstGeom prst="rect">
+            <a:avLst/>
+          </a:prstGeom>
+          <a:noFill/>
+          <a:ln/>
+        </p:spPr>
+        <p:txBody>
+          <a:bodyPr wrap="square" lIns="0" tIns="0" rIns="0" bIns="0" rtlCol="0" anchor="ctr"/>
+          <a:lstStyle/>
+          <a:p>
+            <a:pPr indent="0" marL="0">
+              <a:buNone/>
+            </a:pPr>
+            <a:r>
+              <a:rPr lang="en-US" sz="3000" b="1" dirty="0">
+                <a:solidFill>
+                  <a:srgbClr val="C9A227"/>
+                </a:solidFill>
+                <a:latin typeface="Cambria" pitchFamily="34" charset="0"/>
+                <a:ea typeface="Cambria" pitchFamily="34" charset="-122"/>
+                <a:cs typeface="Cambria" pitchFamily="34" charset="-120"/>
+              </a:rPr>
+              <a:t>21,782</a:t>
+            </a:r>
+            <a:endParaRPr lang="en-US" sz="3000" dirty="0"/>
+          </a:p>
+        </p:txBody>
+      </p:sp>
+      <p:sp>
+        <p:nvSpPr>
+          <p:cNvPr id="35" name="Text 33"/>
+          <p:cNvSpPr txBox="1"/>
+          <p:nvPr/>
+        </p:nvSpPr>
+        <p:spPr>
+          <a:xfrm>
+            <a:off x="640080" y="6355080"/>
+            <a:ext cx="3520440" cy="320040"/>
+          </a:xfrm>
+          <a:prstGeom prst="rect">
+            <a:avLst/>
+          </a:prstGeom>
+          <a:noFill/>
+          <a:ln/>
+        </p:spPr>
+        <p:txBody>
+          <a:bodyPr wrap="square" lIns="0" tIns="0" rIns="0" bIns="0" rtlCol="0" anchor="ctr"/>
+          <a:lstStyle/>
+          <a:p>
+            <a:pPr indent="0" marL="0">
+              <a:buNone/>
+            </a:pPr>
+            <a:r>
+              <a:rPr lang="en-US" sz="1200" dirty="0">
+                <a:solidFill>
+                  <a:srgbClr val="9FB8B3"/>
+                </a:solidFill>
+                <a:latin typeface="Calibri" pitchFamily="34" charset="0"/>
+                <a:ea typeface="Calibri" pitchFamily="34" charset="-122"/>
+                <a:cs typeface="Calibri" pitchFamily="34" charset="-120"/>
+              </a:rPr>
+              <a:t>clean entity records</a:t>
+            </a:r>
+            <a:endParaRPr lang="en-US" sz="1200" dirty="0"/>
+          </a:p>
+        </p:txBody>
+      </p:sp>
+      <p:sp>
+        <p:nvSpPr>
+          <p:cNvPr id="36" name="Text 34"/>
+          <p:cNvSpPr txBox="1"/>
+          <p:nvPr/>
+        </p:nvSpPr>
+        <p:spPr>
+          <a:xfrm>
+            <a:off x="4343400" y="5806440"/>
+            <a:ext cx="3520440" cy="548640"/>
+          </a:xfrm>
+          <a:prstGeom prst="rect">
+            <a:avLst/>
+          </a:prstGeom>
+          <a:noFill/>
+          <a:ln/>
+        </p:spPr>
+        <p:txBody>
+          <a:bodyPr wrap="square" lIns="0" tIns="0" rIns="0" bIns="0" rtlCol="0" anchor="ctr"/>
+          <a:lstStyle/>
+          <a:p>
+            <a:pPr indent="0" marL="0">
+              <a:buNone/>
+            </a:pPr>
+            <a:r>
+              <a:rPr lang="en-US" sz="3000" b="1" dirty="0">
+                <a:solidFill>
+                  <a:srgbClr val="C9A227"/>
+                </a:solidFill>
+                <a:latin typeface="Cambria" pitchFamily="34" charset="0"/>
+                <a:ea typeface="Cambria" pitchFamily="34" charset="-122"/>
+                <a:cs typeface="Cambria" pitchFamily="34" charset="-120"/>
+              </a:rPr>
+              <a:t>10,027</a:t>
+            </a:r>
+            <a:endParaRPr lang="en-US" sz="3000" dirty="0"/>
+          </a:p>
+        </p:txBody>
+      </p:sp>
+      <p:sp>
+        <p:nvSpPr>
+          <p:cNvPr id="37" name="Text 35"/>
+          <p:cNvSpPr txBox="1"/>
+          <p:nvPr/>
+        </p:nvSpPr>
+        <p:spPr>
+          <a:xfrm>
+            <a:off x="4343400" y="6355080"/>
+            <a:ext cx="3520440" cy="320040"/>
+          </a:xfrm>
+          <a:prstGeom prst="rect">
+            <a:avLst/>
+          </a:prstGeom>
+          <a:noFill/>
+          <a:ln/>
+        </p:spPr>
+        <p:txBody>
+          <a:bodyPr wrap="square" lIns="0" tIns="0" rIns="0" bIns="0" rtlCol="0" anchor="ctr"/>
+          <a:lstStyle/>
+          <a:p>
+            <a:pPr indent="0" marL="0">
+              <a:buNone/>
+            </a:pPr>
+            <a:r>
+              <a:rPr lang="en-US" sz="1200" dirty="0">
+                <a:solidFill>
+                  <a:srgbClr val="9FB8B3"/>
+                </a:solidFill>
+                <a:latin typeface="Calibri" pitchFamily="34" charset="0"/>
+                <a:ea typeface="Calibri" pitchFamily="34" charset="-122"/>
+                <a:cs typeface="Calibri" pitchFamily="34" charset="-120"/>
+              </a:rPr>
+              <a:t>canonical entities</a:t>
+            </a:r>
+            <a:endParaRPr lang="en-US" sz="1200" dirty="0"/>
+          </a:p>
+        </p:txBody>
+      </p:sp>
+      <p:sp>
+        <p:nvSpPr>
+          <p:cNvPr id="38" name="Text 36"/>
+          <p:cNvSpPr txBox="1"/>
+          <p:nvPr/>
+        </p:nvSpPr>
+        <p:spPr>
+          <a:xfrm>
+            <a:off x="8046720" y="5806440"/>
+            <a:ext cx="3520440" cy="548640"/>
+          </a:xfrm>
+          <a:prstGeom prst="rect">
+            <a:avLst/>
+          </a:prstGeom>
+          <a:noFill/>
+          <a:ln/>
+        </p:spPr>
+        <p:txBody>
+          <a:bodyPr wrap="square" lIns="0" tIns="0" rIns="0" bIns="0" rtlCol="0" anchor="ctr"/>
+          <a:lstStyle/>
+          <a:p>
+            <a:pPr indent="0" marL="0">
+              <a:buNone/>
+            </a:pPr>
+            <a:r>
+              <a:rPr lang="en-US" sz="3000" b="1" dirty="0">
+                <a:solidFill>
+                  <a:srgbClr val="C9A227"/>
+                </a:solidFill>
+                <a:latin typeface="Cambria" pitchFamily="34" charset="0"/>
+                <a:ea typeface="Cambria" pitchFamily="34" charset="-122"/>
+                <a:cs typeface="Cambria" pitchFamily="34" charset="-120"/>
+              </a:rPr>
+              <a:t>34</a:t>
+            </a:r>
+            <a:endParaRPr lang="en-US" sz="3000" dirty="0"/>
+          </a:p>
+        </p:txBody>
+      </p:sp>
+      <p:sp>
+        <p:nvSpPr>
+          <p:cNvPr id="39" name="Text 37"/>
+          <p:cNvSpPr txBox="1"/>
+          <p:nvPr/>
+        </p:nvSpPr>
+        <p:spPr>
+          <a:xfrm>
+            <a:off x="8046720" y="6355080"/>
+            <a:ext cx="3520440" cy="320040"/>
+          </a:xfrm>
+          <a:prstGeom prst="rect">
+            <a:avLst/>
+          </a:prstGeom>
+          <a:noFill/>
+          <a:ln/>
+        </p:spPr>
+        <p:txBody>
+          <a:bodyPr wrap="square" lIns="0" tIns="0" rIns="0" bIns="0" rtlCol="0" anchor="ctr"/>
+          <a:lstStyle/>
+          <a:p>
+            <a:pPr indent="0" marL="0">
+              <a:buNone/>
+            </a:pPr>
+            <a:r>
+              <a:rPr lang="en-US" sz="1200" dirty="0">
+                <a:solidFill>
+                  <a:srgbClr val="9FB8B3"/>
+                </a:solidFill>
+                <a:latin typeface="Calibri" pitchFamily="34" charset="0"/>
+                <a:ea typeface="Calibri" pitchFamily="34" charset="-122"/>
+                <a:cs typeface="Calibri" pitchFamily="34" charset="-120"/>
+              </a:rPr>
+              <a:t>hotels match a sample query</a:t>
+            </a:r>
+            <a:endParaRPr lang="en-US" sz="1200" dirty="0"/>
+          </a:p>
+        </p:txBody>
+      </p:sp>
+    </p:spTree>
+  </p:cSld>
+  <p:clrMapOvr>
+    <a:masterClrMapping/>
+  </p:clrMapOvr>
+</p:sld>
+</file>
+
+<file path=ppt/slides/slide11.xml><?xml version="1.0" encoding="utf-8"?>
+<p:sld xmlns:a="http://schemas.openxmlformats.org/drawingml/2006/main" xmlns:r="http://schemas.openxmlformats.org/officeDocument/2006/relationships" xmlns:p="http://schemas.openxmlformats.org/presentationml/2006/main">
+  <p:cSld name="Slide 11">
+    <p:bg>
+      <p:bgPr>
+        <a:solidFill>
           <a:srgbClr val="FFFFFF"/>
         </a:solidFill>
       </p:bgPr>
@@ -15140,7 +16545,7 @@
     <p:bg>
       <p:bgPr>
         <a:solidFill>
-          <a:srgbClr val="0B3B36"/>
+          <a:srgbClr val="FFFFFF"/>
         </a:solidFill>
       </p:bgPr>
     </p:bg>
@@ -15166,8 +16571,8 @@
         </p:nvSpPr>
         <p:spPr>
           <a:xfrm>
-            <a:off x="640080" y="457200"/>
-            <a:ext cx="10972800" cy="640080"/>
+            <a:off x="640080" y="411480"/>
+            <a:ext cx="10972800" cy="548640"/>
           </a:xfrm>
           <a:prstGeom prst="rect">
             <a:avLst/>
@@ -15183,17 +16588,17 @@
               <a:buNone/>
             </a:pPr>
             <a:r>
-              <a:rPr lang="en-US" sz="3200" b="1" dirty="0">
-                <a:solidFill>
-                  <a:srgbClr val="FFFFFF"/>
+              <a:rPr lang="en-US" sz="3000" b="1" dirty="0">
+                <a:solidFill>
+                  <a:srgbClr val="1F2A28"/>
                 </a:solidFill>
                 <a:latin typeface="Cambria" pitchFamily="34" charset="0"/>
                 <a:ea typeface="Cambria" pitchFamily="34" charset="-122"/>
                 <a:cs typeface="Cambria" pitchFamily="34" charset="-120"/>
               </a:rPr>
-              <a:t>What's built — the data pipeline</a:t>
-            </a:r>
-            <a:endParaRPr lang="en-US" sz="3200" dirty="0"/>
+              <a:t>The file trail — one café through the pipeline</a:t>
+            </a:r>
+            <a:endParaRPr lang="en-US" sz="3000" dirty="0"/>
           </a:p>
         </p:txBody>
       </p:sp>
@@ -15205,8 +16610,8 @@
         </p:nvSpPr>
         <p:spPr>
           <a:xfrm>
-            <a:off x="640080" y="1097280"/>
-            <a:ext cx="10972800" cy="365760"/>
+            <a:off x="640080" y="987552"/>
+            <a:ext cx="10972800" cy="320040"/>
           </a:xfrm>
           <a:prstGeom prst="rect">
             <a:avLst/>
@@ -15222,17 +16627,17 @@
               <a:buNone/>
             </a:pPr>
             <a:r>
-              <a:rPr lang="en-US" sz="1500" i="1" dirty="0">
-                <a:solidFill>
-                  <a:srgbClr val="9FB8B3"/>
+              <a:rPr lang="en-US" sz="1400" i="1" dirty="0">
+                <a:solidFill>
+                  <a:srgbClr val="6B7B77"/>
                 </a:solidFill>
                 <a:latin typeface="Calibri" pitchFamily="34" charset="0"/>
                 <a:ea typeface="Calibri" pitchFamily="34" charset="-122"/>
                 <a:cs typeface="Calibri" pitchFamily="34" charset="-120"/>
               </a:rPr>
-              <a:t>Reproducible, raw → clean → standardize → resolve → hybrid KB</a:t>
-            </a:r>
-            <a:endParaRPr lang="en-US" sz="1500" dirty="0"/>
+              <a:t>Each stage writes its own file; standardization splits into two shapes — one per half of the hybrid KB.</a:t>
+            </a:r>
+            <a:endParaRPr lang="en-US" sz="1400" dirty="0"/>
           </a:p>
         </p:txBody>
       </p:sp>
@@ -15244,50 +16649,30 @@
         </p:nvSpPr>
         <p:spPr>
           <a:xfrm>
-            <a:off x="640080" y="1645920"/>
-            <a:ext cx="5349240" cy="1097280"/>
+            <a:off x="2743200" y="1417320"/>
+            <a:ext cx="3566160" cy="749808"/>
           </a:xfrm>
           <a:prstGeom prst="roundRect">
             <a:avLst>
-              <a:gd name="adj" fmla="val 5833"/>
+              <a:gd name="adj" fmla="val 7317"/>
             </a:avLst>
           </a:prstGeom>
           <a:solidFill>
-            <a:srgbClr val="12514A"/>
+            <a:srgbClr val="F3EEE4"/>
           </a:solidFill>
           <a:ln/>
         </p:spPr>
       </p:sp>
       <p:sp>
         <p:nvSpPr>
-          <p:cNvPr id="5" name="Shape 3"/>
-          <p:cNvSpPr/>
-          <p:nvPr/>
-        </p:nvSpPr>
-        <p:spPr>
-          <a:xfrm>
-            <a:off x="868680" y="1975104"/>
-            <a:ext cx="438912" cy="438912"/>
-          </a:xfrm>
-          <a:prstGeom prst="ellipse">
-            <a:avLst/>
-          </a:prstGeom>
-          <a:solidFill>
-            <a:srgbClr val="C9A227"/>
-          </a:solidFill>
-          <a:ln/>
-        </p:spPr>
-      </p:sp>
-      <p:sp>
-        <p:nvSpPr>
-          <p:cNvPr id="6" name="Text 4"/>
+          <p:cNvPr id="5" name="Text 3"/>
           <p:cNvSpPr txBox="1"/>
           <p:nvPr/>
         </p:nvSpPr>
         <p:spPr>
           <a:xfrm>
-            <a:off x="868680" y="1975104"/>
-            <a:ext cx="438912" cy="438912"/>
+            <a:off x="2907792" y="1527048"/>
+            <a:ext cx="3273552" cy="274320"/>
           </a:xfrm>
           <a:prstGeom prst="rect">
             <a:avLst/>
@@ -15299,19 +16684,139 @@
           <a:bodyPr wrap="square" lIns="0" tIns="0" rIns="0" bIns="0" rtlCol="0" anchor="ctr"/>
           <a:lstStyle/>
           <a:p>
+            <a:pPr indent="0" marL="0">
+              <a:buNone/>
+            </a:pPr>
+            <a:r>
+              <a:rPr lang="en-US" sz="1150" b="1" dirty="0">
+                <a:solidFill>
+                  <a:srgbClr val="1F2A28"/>
+                </a:solidFill>
+                <a:latin typeface="Consolas" pitchFamily="34" charset="0"/>
+                <a:ea typeface="Consolas" pitchFamily="34" charset="-122"/>
+                <a:cs typeface="Consolas" pitchFamily="34" charset="-120"/>
+              </a:rPr>
+              <a:t>raw/places.csv</a:t>
+            </a:r>
+            <a:endParaRPr lang="en-US" sz="1150" dirty="0"/>
+          </a:p>
+        </p:txBody>
+      </p:sp>
+      <p:sp>
+        <p:nvSpPr>
+          <p:cNvPr id="6" name="Text 4"/>
+          <p:cNvSpPr txBox="1"/>
+          <p:nvPr/>
+        </p:nvSpPr>
+        <p:spPr>
+          <a:xfrm>
+            <a:off x="2907792" y="1819656"/>
+            <a:ext cx="3273552" cy="292608"/>
+          </a:xfrm>
+          <a:prstGeom prst="rect">
+            <a:avLst/>
+          </a:prstGeom>
+          <a:noFill/>
+          <a:ln/>
+        </p:spPr>
+        <p:txBody>
+          <a:bodyPr wrap="square" lIns="0" tIns="0" rIns="0" bIns="0" rtlCol="0" anchor="ctr"/>
+          <a:lstStyle/>
+          <a:p>
+            <a:pPr indent="0" marL="0">
+              <a:lnSpc>
+                <a:spcPct val="95000"/>
+              </a:lnSpc>
+              <a:buNone/>
+            </a:pPr>
+            <a:r>
+              <a:rPr lang="en-US" sz="1000" dirty="0">
+                <a:solidFill>
+                  <a:srgbClr val="6B7B77"/>
+                </a:solidFill>
+                <a:latin typeface="Calibri" pitchFamily="34" charset="0"/>
+                <a:ea typeface="Calibri" pitchFamily="34" charset="-122"/>
+                <a:cs typeface="Calibri" pitchFamily="34" charset="-120"/>
+              </a:rPr>
+              <a:t>2 messy rows · rating=0 · "Riyadh, Saudi Arabia"</a:t>
+            </a:r>
+            <a:endParaRPr lang="en-US" sz="1000" dirty="0"/>
+          </a:p>
+        </p:txBody>
+      </p:sp>
+      <p:sp>
+        <p:nvSpPr>
+          <p:cNvPr id="7" name="Text 5"/>
+          <p:cNvSpPr txBox="1"/>
+          <p:nvPr/>
+        </p:nvSpPr>
+        <p:spPr>
+          <a:xfrm>
+            <a:off x="6446520" y="1554480"/>
+            <a:ext cx="1463040" cy="274320"/>
+          </a:xfrm>
+          <a:prstGeom prst="rect">
+            <a:avLst/>
+          </a:prstGeom>
+          <a:noFill/>
+          <a:ln/>
+        </p:spPr>
+        <p:txBody>
+          <a:bodyPr wrap="square" lIns="0" tIns="0" rIns="0" bIns="0" rtlCol="0" anchor="ctr"/>
+          <a:lstStyle/>
+          <a:p>
+            <a:pPr indent="0" marL="0">
+              <a:buNone/>
+            </a:pPr>
+            <a:r>
+              <a:rPr lang="en-US" sz="1000" i="1" dirty="0">
+                <a:solidFill>
+                  <a:srgbClr val="6B7B77"/>
+                </a:solidFill>
+                <a:latin typeface="Calibri" pitchFamily="34" charset="0"/>
+                <a:ea typeface="Calibri" pitchFamily="34" charset="-122"/>
+                <a:cs typeface="Calibri" pitchFamily="34" charset="-120"/>
+              </a:rPr>
+              <a:t>collect</a:t>
+            </a:r>
+            <a:endParaRPr lang="en-US" sz="1000" dirty="0"/>
+          </a:p>
+        </p:txBody>
+      </p:sp>
+      <p:sp>
+        <p:nvSpPr>
+          <p:cNvPr id="8" name="Text 6"/>
+          <p:cNvSpPr txBox="1"/>
+          <p:nvPr/>
+        </p:nvSpPr>
+        <p:spPr>
+          <a:xfrm>
+            <a:off x="4251960" y="2194560"/>
+            <a:ext cx="548640" cy="320040"/>
+          </a:xfrm>
+          <a:prstGeom prst="rect">
+            <a:avLst/>
+          </a:prstGeom>
+          <a:noFill/>
+          <a:ln/>
+        </p:spPr>
+        <p:txBody>
+          <a:bodyPr wrap="square" lIns="0" tIns="0" rIns="0" bIns="0" rtlCol="0" anchor="ctr"/>
+          <a:lstStyle/>
+          <a:p>
             <a:pPr algn="ctr" indent="0" marL="0">
               <a:buNone/>
             </a:pPr>
             <a:r>
               <a:rPr lang="en-US" sz="2000" b="1" dirty="0">
                 <a:solidFill>
-                  <a:srgbClr val="0B3B36"/>
+                  <a:srgbClr val="C9A227"/>
                 </a:solidFill>
                 <a:latin typeface="Cambria" pitchFamily="34" charset="0"/>
                 <a:ea typeface="Cambria" pitchFamily="34" charset="-122"/>
                 <a:cs typeface="Cambria" pitchFamily="34" charset="-120"/>
               </a:rPr>
-              <a:t>1</a:t>
+              <a:t>↓</a:t>
             </a:r>
             <a:endParaRPr lang="en-US" sz="2000" dirty="0"/>
           </a:p>
@@ -15319,14 +16824,36 @@
       </p:sp>
       <p:sp>
         <p:nvSpPr>
-          <p:cNvPr id="7" name="Text 5"/>
+          <p:cNvPr id="9" name="Shape 7"/>
+          <p:cNvSpPr/>
+          <p:nvPr/>
+        </p:nvSpPr>
+        <p:spPr>
+          <a:xfrm>
+            <a:off x="2743200" y="2487168"/>
+            <a:ext cx="3566160" cy="749808"/>
+          </a:xfrm>
+          <a:prstGeom prst="roundRect">
+            <a:avLst>
+              <a:gd name="adj" fmla="val 7317"/>
+            </a:avLst>
+          </a:prstGeom>
+          <a:solidFill>
+            <a:srgbClr val="F3EEE4"/>
+          </a:solidFill>
+          <a:ln/>
+        </p:spPr>
+      </p:sp>
+      <p:sp>
+        <p:nvSpPr>
+          <p:cNvPr id="10" name="Text 8"/>
           <p:cNvSpPr txBox="1"/>
           <p:nvPr/>
         </p:nvSpPr>
         <p:spPr>
           <a:xfrm>
-            <a:off x="1463040" y="1828800"/>
-            <a:ext cx="4389120" cy="365760"/>
+            <a:off x="2907792" y="2596896"/>
+            <a:ext cx="3273552" cy="274320"/>
           </a:xfrm>
           <a:prstGeom prst="rect">
             <a:avLst/>
@@ -15342,30 +16869,150 @@
               <a:buNone/>
             </a:pPr>
             <a:r>
-              <a:rPr lang="en-US" sz="1600" b="1" dirty="0">
-                <a:solidFill>
-                  <a:srgbClr val="FFFFFF"/>
+              <a:rPr lang="en-US" sz="1150" b="1" dirty="0">
+                <a:solidFill>
+                  <a:srgbClr val="1F2A28"/>
+                </a:solidFill>
+                <a:latin typeface="Consolas" pitchFamily="34" charset="0"/>
+                <a:ea typeface="Consolas" pitchFamily="34" charset="-122"/>
+                <a:cs typeface="Consolas" pitchFamily="34" charset="-120"/>
+              </a:rPr>
+              <a:t>processed/places_clean.csv</a:t>
+            </a:r>
+            <a:endParaRPr lang="en-US" sz="1150" dirty="0"/>
+          </a:p>
+        </p:txBody>
+      </p:sp>
+      <p:sp>
+        <p:nvSpPr>
+          <p:cNvPr id="11" name="Text 9"/>
+          <p:cNvSpPr txBox="1"/>
+          <p:nvPr/>
+        </p:nvSpPr>
+        <p:spPr>
+          <a:xfrm>
+            <a:off x="2907792" y="2889504"/>
+            <a:ext cx="3273552" cy="292608"/>
+          </a:xfrm>
+          <a:prstGeom prst="rect">
+            <a:avLst/>
+          </a:prstGeom>
+          <a:noFill/>
+          <a:ln/>
+        </p:spPr>
+        <p:txBody>
+          <a:bodyPr wrap="square" lIns="0" tIns="0" rIns="0" bIns="0" rtlCol="0" anchor="ctr"/>
+          <a:lstStyle/>
+          <a:p>
+            <a:pPr indent="0" marL="0">
+              <a:lnSpc>
+                <a:spcPct val="95000"/>
+              </a:lnSpc>
+              <a:buNone/>
+            </a:pPr>
+            <a:r>
+              <a:rPr lang="en-US" sz="1000" dirty="0">
+                <a:solidFill>
+                  <a:srgbClr val="6B7B77"/>
+                </a:solidFill>
+                <a:latin typeface="Calibri" pitchFamily="34" charset="0"/>
+                <a:ea typeface="Calibri" pitchFamily="34" charset="-122"/>
+                <a:cs typeface="Calibri" pitchFamily="34" charset="-120"/>
+              </a:rPr>
+              <a:t>rating 0→null · city→Riyadh/Riyadh</a:t>
+            </a:r>
+            <a:endParaRPr lang="en-US" sz="1000" dirty="0"/>
+          </a:p>
+        </p:txBody>
+      </p:sp>
+      <p:sp>
+        <p:nvSpPr>
+          <p:cNvPr id="12" name="Text 10"/>
+          <p:cNvSpPr txBox="1"/>
+          <p:nvPr/>
+        </p:nvSpPr>
+        <p:spPr>
+          <a:xfrm>
+            <a:off x="6446520" y="2624328"/>
+            <a:ext cx="1463040" cy="274320"/>
+          </a:xfrm>
+          <a:prstGeom prst="rect">
+            <a:avLst/>
+          </a:prstGeom>
+          <a:noFill/>
+          <a:ln/>
+        </p:spPr>
+        <p:txBody>
+          <a:bodyPr wrap="square" lIns="0" tIns="0" rIns="0" bIns="0" rtlCol="0" anchor="ctr"/>
+          <a:lstStyle/>
+          <a:p>
+            <a:pPr indent="0" marL="0">
+              <a:buNone/>
+            </a:pPr>
+            <a:r>
+              <a:rPr lang="en-US" sz="1000" i="1" dirty="0">
+                <a:solidFill>
+                  <a:srgbClr val="6B7B77"/>
+                </a:solidFill>
+                <a:latin typeface="Calibri" pitchFamily="34" charset="0"/>
+                <a:ea typeface="Calibri" pitchFamily="34" charset="-122"/>
+                <a:cs typeface="Calibri" pitchFamily="34" charset="-120"/>
+              </a:rPr>
+              <a:t>clean</a:t>
+            </a:r>
+            <a:endParaRPr lang="en-US" sz="1000" dirty="0"/>
+          </a:p>
+        </p:txBody>
+      </p:sp>
+      <p:sp>
+        <p:nvSpPr>
+          <p:cNvPr id="13" name="Text 11"/>
+          <p:cNvSpPr txBox="1"/>
+          <p:nvPr/>
+        </p:nvSpPr>
+        <p:spPr>
+          <a:xfrm>
+            <a:off x="4251960" y="3264408"/>
+            <a:ext cx="548640" cy="320040"/>
+          </a:xfrm>
+          <a:prstGeom prst="rect">
+            <a:avLst/>
+          </a:prstGeom>
+          <a:noFill/>
+          <a:ln/>
+        </p:spPr>
+        <p:txBody>
+          <a:bodyPr wrap="square" lIns="0" tIns="0" rIns="0" bIns="0" rtlCol="0" anchor="ctr"/>
+          <a:lstStyle/>
+          <a:p>
+            <a:pPr algn="ctr" indent="0" marL="0">
+              <a:buNone/>
+            </a:pPr>
+            <a:r>
+              <a:rPr lang="en-US" sz="2000" b="1" dirty="0">
+                <a:solidFill>
+                  <a:srgbClr val="C9A227"/>
                 </a:solidFill>
                 <a:latin typeface="Cambria" pitchFamily="34" charset="0"/>
                 <a:ea typeface="Cambria" pitchFamily="34" charset="-122"/>
                 <a:cs typeface="Cambria" pitchFamily="34" charset="-120"/>
               </a:rPr>
-              <a:t>Exploration &amp; Audit</a:t>
-            </a:r>
-            <a:endParaRPr lang="en-US" sz="1600" dirty="0"/>
+              <a:t>↓</a:t>
+            </a:r>
+            <a:endParaRPr lang="en-US" sz="2000" dirty="0"/>
           </a:p>
         </p:txBody>
       </p:sp>
       <p:sp>
         <p:nvSpPr>
-          <p:cNvPr id="8" name="Text 6"/>
+          <p:cNvPr id="14" name="Text 12"/>
           <p:cNvSpPr txBox="1"/>
           <p:nvPr/>
         </p:nvSpPr>
         <p:spPr>
           <a:xfrm>
-            <a:off x="1463040" y="2194560"/>
-            <a:ext cx="4389120" cy="457200"/>
+            <a:off x="1463040" y="3566160"/>
+            <a:ext cx="6126480" cy="274320"/>
           </a:xfrm>
           <a:prstGeom prst="rect">
             <a:avLst/>
@@ -15377,79 +17024,159 @@
           <a:bodyPr wrap="square" lIns="0" tIns="0" rIns="0" bIns="0" rtlCol="0" anchor="ctr"/>
           <a:lstStyle/>
           <a:p>
+            <a:pPr algn="ctr" indent="0" marL="0">
+              <a:buNone/>
+            </a:pPr>
+            <a:r>
+              <a:rPr lang="en-US" sz="1200" b="1" dirty="0">
+                <a:solidFill>
+                  <a:srgbClr val="0E6E63"/>
+                </a:solidFill>
+                <a:latin typeface="Cambria" pitchFamily="34" charset="0"/>
+                <a:ea typeface="Cambria" pitchFamily="34" charset="-122"/>
+                <a:cs typeface="Cambria" pitchFamily="34" charset="-120"/>
+              </a:rPr>
+              <a:t>standardize → splits into two shapes</a:t>
+            </a:r>
+            <a:endParaRPr lang="en-US" sz="1200" dirty="0"/>
+          </a:p>
+        </p:txBody>
+      </p:sp>
+      <p:sp>
+        <p:nvSpPr>
+          <p:cNvPr id="15" name="Shape 13"/>
+          <p:cNvSpPr/>
+          <p:nvPr/>
+        </p:nvSpPr>
+        <p:spPr>
+          <a:xfrm>
+            <a:off x="640080" y="3913632"/>
+            <a:ext cx="3703320" cy="749808"/>
+          </a:xfrm>
+          <a:prstGeom prst="roundRect">
+            <a:avLst>
+              <a:gd name="adj" fmla="val 7317"/>
+            </a:avLst>
+          </a:prstGeom>
+          <a:solidFill>
+            <a:srgbClr val="E9F2F0"/>
+          </a:solidFill>
+          <a:ln/>
+        </p:spPr>
+      </p:sp>
+      <p:sp>
+        <p:nvSpPr>
+          <p:cNvPr id="16" name="Text 14"/>
+          <p:cNvSpPr txBox="1"/>
+          <p:nvPr/>
+        </p:nvSpPr>
+        <p:spPr>
+          <a:xfrm>
+            <a:off x="804672" y="4023360"/>
+            <a:ext cx="3410712" cy="274320"/>
+          </a:xfrm>
+          <a:prstGeom prst="rect">
+            <a:avLst/>
+          </a:prstGeom>
+          <a:noFill/>
+          <a:ln/>
+        </p:spPr>
+        <p:txBody>
+          <a:bodyPr wrap="square" lIns="0" tIns="0" rIns="0" bIns="0" rtlCol="0" anchor="ctr"/>
+          <a:lstStyle/>
+          <a:p>
+            <a:pPr indent="0" marL="0">
+              <a:buNone/>
+            </a:pPr>
+            <a:r>
+              <a:rPr lang="en-US" sz="1150" b="1" dirty="0">
+                <a:solidFill>
+                  <a:srgbClr val="1F2A28"/>
+                </a:solidFill>
+                <a:latin typeface="Consolas" pitchFamily="34" charset="0"/>
+                <a:ea typeface="Consolas" pitchFamily="34" charset="-122"/>
+                <a:cs typeface="Consolas" pitchFamily="34" charset="-120"/>
+              </a:rPr>
+              <a:t>entities_core.csv</a:t>
+            </a:r>
+            <a:endParaRPr lang="en-US" sz="1150" dirty="0"/>
+          </a:p>
+        </p:txBody>
+      </p:sp>
+      <p:sp>
+        <p:nvSpPr>
+          <p:cNvPr id="17" name="Text 15"/>
+          <p:cNvSpPr txBox="1"/>
+          <p:nvPr/>
+        </p:nvSpPr>
+        <p:spPr>
+          <a:xfrm>
+            <a:off x="804672" y="4315968"/>
+            <a:ext cx="3410712" cy="292608"/>
+          </a:xfrm>
+          <a:prstGeom prst="rect">
+            <a:avLst/>
+          </a:prstGeom>
+          <a:noFill/>
+          <a:ln/>
+        </p:spPr>
+        <p:txBody>
+          <a:bodyPr wrap="square" lIns="0" tIns="0" rIns="0" bIns="0" rtlCol="0" anchor="ctr"/>
+          <a:lstStyle/>
+          <a:p>
             <a:pPr indent="0" marL="0">
               <a:lnSpc>
-                <a:spcPct val="100000"/>
+                <a:spcPct val="95000"/>
               </a:lnSpc>
               <a:buNone/>
             </a:pPr>
             <a:r>
-              <a:rPr lang="en-US" sz="1250" dirty="0">
-                <a:solidFill>
-                  <a:srgbClr val="CFE3DF"/>
+              <a:rPr lang="en-US" sz="1000" dirty="0">
+                <a:solidFill>
+                  <a:srgbClr val="6B7B77"/>
                 </a:solidFill>
                 <a:latin typeface="Calibri" pitchFamily="34" charset="0"/>
                 <a:ea typeface="Calibri" pitchFamily="34" charset="-122"/>
                 <a:cs typeface="Calibri" pitchFamily="34" charset="-120"/>
               </a:rPr>
-              <a:t>Per-source notebooks + 11-point quality audit</a:t>
-            </a:r>
-            <a:endParaRPr lang="en-US" sz="1250" dirty="0"/>
+              <a:t>facts to FILTER · rating_norm 0.8 · city · price</a:t>
+            </a:r>
+            <a:endParaRPr lang="en-US" sz="1000" dirty="0"/>
           </a:p>
         </p:txBody>
       </p:sp>
       <p:sp>
         <p:nvSpPr>
-          <p:cNvPr id="9" name="Shape 7"/>
+          <p:cNvPr id="18" name="Shape 16"/>
           <p:cNvSpPr/>
           <p:nvPr/>
         </p:nvSpPr>
         <p:spPr>
           <a:xfrm>
-            <a:off x="6217920" y="1645920"/>
-            <a:ext cx="5349240" cy="1097280"/>
+            <a:off x="4617720" y="3913632"/>
+            <a:ext cx="3703320" cy="749808"/>
           </a:xfrm>
           <a:prstGeom prst="roundRect">
             <a:avLst>
-              <a:gd name="adj" fmla="val 5833"/>
+              <a:gd name="adj" fmla="val 7317"/>
             </a:avLst>
           </a:prstGeom>
           <a:solidFill>
-            <a:srgbClr val="12514A"/>
+            <a:srgbClr val="FBF4DD"/>
           </a:solidFill>
           <a:ln/>
         </p:spPr>
       </p:sp>
       <p:sp>
         <p:nvSpPr>
-          <p:cNvPr id="10" name="Shape 8"/>
-          <p:cNvSpPr/>
-          <p:nvPr/>
-        </p:nvSpPr>
-        <p:spPr>
-          <a:xfrm>
-            <a:off x="6446520" y="1975104"/>
-            <a:ext cx="438912" cy="438912"/>
-          </a:xfrm>
-          <a:prstGeom prst="ellipse">
-            <a:avLst/>
-          </a:prstGeom>
-          <a:solidFill>
-            <a:srgbClr val="C9A227"/>
-          </a:solidFill>
-          <a:ln/>
-        </p:spPr>
-      </p:sp>
-      <p:sp>
-        <p:nvSpPr>
-          <p:cNvPr id="11" name="Text 9"/>
+          <p:cNvPr id="19" name="Text 17"/>
           <p:cNvSpPr txBox="1"/>
           <p:nvPr/>
         </p:nvSpPr>
         <p:spPr>
           <a:xfrm>
-            <a:off x="6446520" y="1975104"/>
-            <a:ext cx="438912" cy="438912"/>
+            <a:off x="4782312" y="4023360"/>
+            <a:ext cx="3410712" cy="274320"/>
           </a:xfrm>
           <a:prstGeom prst="rect">
             <a:avLst/>
@@ -15461,34 +17188,137 @@
           <a:bodyPr wrap="square" lIns="0" tIns="0" rIns="0" bIns="0" rtlCol="0" anchor="ctr"/>
           <a:lstStyle/>
           <a:p>
-            <a:pPr algn="ctr" indent="0" marL="0">
+            <a:pPr indent="0" marL="0">
               <a:buNone/>
             </a:pPr>
             <a:r>
-              <a:rPr lang="en-US" sz="2000" b="1" dirty="0">
-                <a:solidFill>
-                  <a:srgbClr val="0B3B36"/>
+              <a:rPr lang="en-US" sz="1150" b="1" dirty="0">
+                <a:solidFill>
+                  <a:srgbClr val="1F2A28"/>
+                </a:solidFill>
+                <a:latin typeface="Consolas" pitchFamily="34" charset="0"/>
+                <a:ea typeface="Consolas" pitchFamily="34" charset="-122"/>
+                <a:cs typeface="Consolas" pitchFamily="34" charset="-120"/>
+              </a:rPr>
+              <a:t>kb_documents.csv</a:t>
+            </a:r>
+            <a:endParaRPr lang="en-US" sz="1150" dirty="0"/>
+          </a:p>
+        </p:txBody>
+      </p:sp>
+      <p:sp>
+        <p:nvSpPr>
+          <p:cNvPr id="20" name="Text 18"/>
+          <p:cNvSpPr txBox="1"/>
+          <p:nvPr/>
+        </p:nvSpPr>
+        <p:spPr>
+          <a:xfrm>
+            <a:off x="4782312" y="4315968"/>
+            <a:ext cx="3410712" cy="292608"/>
+          </a:xfrm>
+          <a:prstGeom prst="rect">
+            <a:avLst/>
+          </a:prstGeom>
+          <a:noFill/>
+          <a:ln/>
+        </p:spPr>
+        <p:txBody>
+          <a:bodyPr wrap="square" lIns="0" tIns="0" rIns="0" bIns="0" rtlCol="0" anchor="ctr"/>
+          <a:lstStyle/>
+          <a:p>
+            <a:pPr indent="0" marL="0">
+              <a:lnSpc>
+                <a:spcPct val="95000"/>
+              </a:lnSpc>
+              <a:buNone/>
+            </a:pPr>
+            <a:r>
+              <a:rPr lang="en-US" sz="1000" dirty="0">
+                <a:solidFill>
+                  <a:srgbClr val="6B7B77"/>
+                </a:solidFill>
+                <a:latin typeface="Calibri" pitchFamily="34" charset="0"/>
+                <a:ea typeface="Calibri" pitchFamily="34" charset="-122"/>
+                <a:cs typeface="Calibri" pitchFamily="34" charset="-120"/>
+              </a:rPr>
+              <a:t>TEXT to embed + embed flag · language</a:t>
+            </a:r>
+            <a:endParaRPr lang="en-US" sz="1000" dirty="0"/>
+          </a:p>
+        </p:txBody>
+      </p:sp>
+      <p:sp>
+        <p:nvSpPr>
+          <p:cNvPr id="21" name="Shape 19"/>
+          <p:cNvSpPr/>
+          <p:nvPr/>
+        </p:nvSpPr>
+        <p:spPr>
+          <a:xfrm>
+            <a:off x="8732520" y="1417320"/>
+            <a:ext cx="2880360" cy="2148840"/>
+          </a:xfrm>
+          <a:prstGeom prst="roundRect">
+            <a:avLst>
+              <a:gd name="adj" fmla="val 3404"/>
+            </a:avLst>
+          </a:prstGeom>
+          <a:solidFill>
+            <a:srgbClr val="0B3B36"/>
+          </a:solidFill>
+          <a:ln/>
+        </p:spPr>
+      </p:sp>
+      <p:sp>
+        <p:nvSpPr>
+          <p:cNvPr id="22" name="Text 20"/>
+          <p:cNvSpPr txBox="1"/>
+          <p:nvPr/>
+        </p:nvSpPr>
+        <p:spPr>
+          <a:xfrm>
+            <a:off x="8961120" y="1572768"/>
+            <a:ext cx="2468880" cy="274320"/>
+          </a:xfrm>
+          <a:prstGeom prst="rect">
+            <a:avLst/>
+          </a:prstGeom>
+          <a:noFill/>
+          <a:ln/>
+        </p:spPr>
+        <p:txBody>
+          <a:bodyPr wrap="square" lIns="0" tIns="0" rIns="0" bIns="0" rtlCol="0" anchor="ctr"/>
+          <a:lstStyle/>
+          <a:p>
+            <a:pPr indent="0" marL="0">
+              <a:buNone/>
+            </a:pPr>
+            <a:r>
+              <a:rPr lang="en-US" sz="1300" b="1" dirty="0">
+                <a:solidFill>
+                  <a:srgbClr val="C9A227"/>
                 </a:solidFill>
                 <a:latin typeface="Cambria" pitchFamily="34" charset="0"/>
                 <a:ea typeface="Cambria" pitchFamily="34" charset="-122"/>
                 <a:cs typeface="Cambria" pitchFamily="34" charset="-120"/>
               </a:rPr>
-              <a:t>2</a:t>
-            </a:r>
-            <a:endParaRPr lang="en-US" sz="2000" dirty="0"/>
+              <a:t>Structured layer</a:t>
+            </a:r>
+            <a:endParaRPr lang="en-US" sz="1300" dirty="0"/>
           </a:p>
         </p:txBody>
       </p:sp>
       <p:sp>
         <p:nvSpPr>
-          <p:cNvPr id="12" name="Text 10"/>
+          <p:cNvPr id="23" name="Text 21"/>
           <p:cNvSpPr txBox="1"/>
           <p:nvPr/>
         </p:nvSpPr>
         <p:spPr>
           <a:xfrm>
-            <a:off x="7040880" y="1828800"/>
-            <a:ext cx="4389120" cy="365760"/>
+            <a:off x="8961120" y="1883664"/>
+            <a:ext cx="2468880" cy="274320"/>
           </a:xfrm>
           <a:prstGeom prst="rect">
             <a:avLst/>
@@ -15504,30 +17334,153 @@
               <a:buNone/>
             </a:pPr>
             <a:r>
-              <a:rPr lang="en-US" sz="1600" b="1" dirty="0">
+              <a:rPr lang="en-US" sz="1050" dirty="0">
                 <a:solidFill>
                   <a:srgbClr val="FFFFFF"/>
+                </a:solidFill>
+                <a:latin typeface="Consolas" pitchFamily="34" charset="0"/>
+                <a:ea typeface="Consolas" pitchFamily="34" charset="-122"/>
+                <a:cs typeface="Consolas" pitchFamily="34" charset="-120"/>
+              </a:rPr>
+              <a:t>knowledge_base.sqlite</a:t>
+            </a:r>
+            <a:endParaRPr lang="en-US" sz="1050" dirty="0"/>
+          </a:p>
+        </p:txBody>
+      </p:sp>
+      <p:sp>
+        <p:nvSpPr>
+          <p:cNvPr id="24" name="Text 22"/>
+          <p:cNvSpPr txBox="1"/>
+          <p:nvPr/>
+        </p:nvSpPr>
+        <p:spPr>
+          <a:xfrm>
+            <a:off x="8961120" y="2212848"/>
+            <a:ext cx="2468880" cy="1188720"/>
+          </a:xfrm>
+          <a:prstGeom prst="rect">
+            <a:avLst/>
+          </a:prstGeom>
+          <a:noFill/>
+          <a:ln/>
+        </p:spPr>
+        <p:txBody>
+          <a:bodyPr wrap="square" lIns="0" tIns="0" rIns="0" bIns="0" rtlCol="0" anchor="ctr"/>
+          <a:lstStyle/>
+          <a:p>
+            <a:pPr indent="0" marL="0">
+              <a:lnSpc>
+                <a:spcPct val="105000"/>
+              </a:lnSpc>
+              <a:buNone/>
+            </a:pPr>
+            <a:r>
+              <a:rPr lang="en-US" sz="1050" b="1" dirty="0">
+                <a:solidFill>
+                  <a:srgbClr val="E8F3F0"/>
+                </a:solidFill>
+                <a:latin typeface="Calibri" pitchFamily="34" charset="0"/>
+                <a:ea typeface="Calibri" pitchFamily="34" charset="-122"/>
+                <a:cs typeface="Calibri" pitchFamily="34" charset="-120"/>
+              </a:rPr>
+              <a:t>exact filters</a:t>
+            </a:r>
+            <a:endParaRPr lang="en-US" sz="1050" dirty="0"/>
+          </a:p>
+          <a:p>
+            <a:pPr indent="0" marL="0">
+              <a:lnSpc>
+                <a:spcPct val="105000"/>
+              </a:lnSpc>
+              <a:buNone/>
+            </a:pPr>
+            <a:r>
+              <a:rPr lang="en-US" sz="1050" dirty="0">
+                <a:solidFill>
+                  <a:srgbClr val="BFE0DA"/>
+                </a:solidFill>
+                <a:latin typeface="Calibri" pitchFamily="34" charset="0"/>
+                <a:ea typeface="Calibri" pitchFamily="34" charset="-122"/>
+                <a:cs typeface="Calibri" pitchFamily="34" charset="-120"/>
+              </a:rPr>
+              <a:t>city = Riyadh AND rating_norm ≥ 0.8 AND price ≤ 50</a:t>
+            </a:r>
+            <a:endParaRPr lang="en-US" sz="1050" dirty="0"/>
+          </a:p>
+        </p:txBody>
+      </p:sp>
+      <p:sp>
+        <p:nvSpPr>
+          <p:cNvPr id="25" name="Shape 23"/>
+          <p:cNvSpPr/>
+          <p:nvPr/>
+        </p:nvSpPr>
+        <p:spPr>
+          <a:xfrm>
+            <a:off x="8732520" y="3703320"/>
+            <a:ext cx="2880360" cy="2560320"/>
+          </a:xfrm>
+          <a:prstGeom prst="roundRect">
+            <a:avLst>
+              <a:gd name="adj" fmla="val 2857"/>
+            </a:avLst>
+          </a:prstGeom>
+          <a:solidFill>
+            <a:srgbClr val="0E6E63"/>
+          </a:solidFill>
+          <a:ln/>
+        </p:spPr>
+      </p:sp>
+      <p:sp>
+        <p:nvSpPr>
+          <p:cNvPr id="26" name="Text 24"/>
+          <p:cNvSpPr txBox="1"/>
+          <p:nvPr/>
+        </p:nvSpPr>
+        <p:spPr>
+          <a:xfrm>
+            <a:off x="8961120" y="3858768"/>
+            <a:ext cx="2468880" cy="274320"/>
+          </a:xfrm>
+          <a:prstGeom prst="rect">
+            <a:avLst/>
+          </a:prstGeom>
+          <a:noFill/>
+          <a:ln/>
+        </p:spPr>
+        <p:txBody>
+          <a:bodyPr wrap="square" lIns="0" tIns="0" rIns="0" bIns="0" rtlCol="0" anchor="ctr"/>
+          <a:lstStyle/>
+          <a:p>
+            <a:pPr indent="0" marL="0">
+              <a:buNone/>
+            </a:pPr>
+            <a:r>
+              <a:rPr lang="en-US" sz="1300" b="1" dirty="0">
+                <a:solidFill>
+                  <a:srgbClr val="FFF3CC"/>
                 </a:solidFill>
                 <a:latin typeface="Cambria" pitchFamily="34" charset="0"/>
                 <a:ea typeface="Cambria" pitchFamily="34" charset="-122"/>
                 <a:cs typeface="Cambria" pitchFamily="34" charset="-120"/>
               </a:rPr>
-              <a:t>Data Contract</a:t>
-            </a:r>
-            <a:endParaRPr lang="en-US" sz="1600" dirty="0"/>
+              <a:t>Semantic layer</a:t>
+            </a:r>
+            <a:endParaRPr lang="en-US" sz="1300" dirty="0"/>
           </a:p>
         </p:txBody>
       </p:sp>
       <p:sp>
         <p:nvSpPr>
-          <p:cNvPr id="13" name="Text 11"/>
+          <p:cNvPr id="27" name="Text 25"/>
           <p:cNvSpPr txBox="1"/>
           <p:nvPr/>
         </p:nvSpPr>
         <p:spPr>
           <a:xfrm>
-            <a:off x="7040880" y="2194560"/>
-            <a:ext cx="4389120" cy="457200"/>
+            <a:off x="8961120" y="4169664"/>
+            <a:ext cx="2468880" cy="274320"/>
           </a:xfrm>
           <a:prstGeom prst="rect">
             <a:avLst/>
@@ -15540,78 +17493,95 @@
           <a:lstStyle/>
           <a:p>
             <a:pPr indent="0" marL="0">
+              <a:buNone/>
+            </a:pPr>
+            <a:r>
+              <a:rPr lang="en-US" sz="1000" dirty="0">
+                <a:solidFill>
+                  <a:srgbClr val="FFFFFF"/>
+                </a:solidFill>
+                <a:latin typeface="Consolas" pitchFamily="34" charset="0"/>
+                <a:ea typeface="Consolas" pitchFamily="34" charset="-122"/>
+                <a:cs typeface="Consolas" pitchFamily="34" charset="-120"/>
+              </a:rPr>
+              <a:t>vector_store/  (.npy + meta)</a:t>
+            </a:r>
+            <a:endParaRPr lang="en-US" sz="1000" dirty="0"/>
+          </a:p>
+        </p:txBody>
+      </p:sp>
+      <p:sp>
+        <p:nvSpPr>
+          <p:cNvPr id="28" name="Text 26"/>
+          <p:cNvSpPr txBox="1"/>
+          <p:nvPr/>
+        </p:nvSpPr>
+        <p:spPr>
+          <a:xfrm>
+            <a:off x="8961120" y="4498848"/>
+            <a:ext cx="2468880" cy="1188720"/>
+          </a:xfrm>
+          <a:prstGeom prst="rect">
+            <a:avLst/>
+          </a:prstGeom>
+          <a:noFill/>
+          <a:ln/>
+        </p:spPr>
+        <p:txBody>
+          <a:bodyPr wrap="square" lIns="0" tIns="0" rIns="0" bIns="0" rtlCol="0" anchor="ctr"/>
+          <a:lstStyle/>
+          <a:p>
+            <a:pPr indent="0" marL="0">
               <a:lnSpc>
-                <a:spcPct val="100000"/>
+                <a:spcPct val="105000"/>
               </a:lnSpc>
               <a:buNone/>
             </a:pPr>
             <a:r>
-              <a:rPr lang="en-US" sz="1250" dirty="0">
-                <a:solidFill>
-                  <a:srgbClr val="CFE3DF"/>
+              <a:rPr lang="en-US" sz="1050" b="1" dirty="0">
+                <a:solidFill>
+                  <a:srgbClr val="FFFFFF"/>
                 </a:solidFill>
                 <a:latin typeface="Calibri" pitchFamily="34" charset="0"/>
                 <a:ea typeface="Calibri" pitchFamily="34" charset="-122"/>
                 <a:cs typeface="Calibri" pitchFamily="34" charset="-120"/>
               </a:rPr>
-              <a:t>Target schema, units, provenance (data_dictionary.md)</a:t>
-            </a:r>
-            <a:endParaRPr lang="en-US" sz="1250" dirty="0"/>
+              <a:t>meaning search</a:t>
+            </a:r>
+            <a:endParaRPr lang="en-US" sz="1050" dirty="0"/>
+          </a:p>
+          <a:p>
+            <a:pPr indent="0" marL="0">
+              <a:lnSpc>
+                <a:spcPct val="105000"/>
+              </a:lnSpc>
+              <a:buNone/>
+            </a:pPr>
+            <a:r>
+              <a:rPr lang="en-US" sz="1050" dirty="0">
+                <a:solidFill>
+                  <a:srgbClr val="E8F3F0"/>
+                </a:solidFill>
+                <a:latin typeface="Calibri" pitchFamily="34" charset="0"/>
+                <a:ea typeface="Calibri" pitchFamily="34" charset="-122"/>
+                <a:cs typeface="Calibri" pitchFamily="34" charset="-120"/>
+              </a:rPr>
+              <a:t>“cozy, family-friendly vibe” → 768-dim vector</a:t>
+            </a:r>
+            <a:endParaRPr lang="en-US" sz="1050" dirty="0"/>
           </a:p>
         </p:txBody>
       </p:sp>
       <p:sp>
         <p:nvSpPr>
-          <p:cNvPr id="14" name="Shape 12"/>
-          <p:cNvSpPr/>
-          <p:nvPr/>
-        </p:nvSpPr>
-        <p:spPr>
-          <a:xfrm>
-            <a:off x="640080" y="2880360"/>
-            <a:ext cx="5349240" cy="1097280"/>
-          </a:xfrm>
-          <a:prstGeom prst="roundRect">
-            <a:avLst>
-              <a:gd name="adj" fmla="val 5833"/>
-            </a:avLst>
-          </a:prstGeom>
-          <a:solidFill>
-            <a:srgbClr val="12514A"/>
-          </a:solidFill>
-          <a:ln/>
-        </p:spPr>
-      </p:sp>
-      <p:sp>
-        <p:nvSpPr>
-          <p:cNvPr id="15" name="Shape 13"/>
-          <p:cNvSpPr/>
-          <p:nvPr/>
-        </p:nvSpPr>
-        <p:spPr>
-          <a:xfrm>
-            <a:off x="868680" y="3209544"/>
-            <a:ext cx="438912" cy="438912"/>
-          </a:xfrm>
-          <a:prstGeom prst="ellipse">
-            <a:avLst/>
-          </a:prstGeom>
-          <a:solidFill>
-            <a:srgbClr val="C9A227"/>
-          </a:solidFill>
-          <a:ln/>
-        </p:spPr>
-      </p:sp>
-      <p:sp>
-        <p:nvSpPr>
-          <p:cNvPr id="16" name="Text 14"/>
+          <p:cNvPr id="29" name="Text 27"/>
           <p:cNvSpPr txBox="1"/>
           <p:nvPr/>
         </p:nvSpPr>
         <p:spPr>
           <a:xfrm>
-            <a:off x="868680" y="3209544"/>
-            <a:ext cx="438912" cy="438912"/>
+            <a:off x="8229600" y="2194560"/>
+            <a:ext cx="548640" cy="457200"/>
           </a:xfrm>
           <a:prstGeom prst="rect">
             <a:avLst/>
@@ -15627,30 +17597,30 @@
               <a:buNone/>
             </a:pPr>
             <a:r>
-              <a:rPr lang="en-US" sz="2000" b="1" dirty="0">
-                <a:solidFill>
-                  <a:srgbClr val="0B3B36"/>
+              <a:rPr lang="en-US" sz="2600" b="1" dirty="0">
+                <a:solidFill>
+                  <a:srgbClr val="C9A227"/>
                 </a:solidFill>
                 <a:latin typeface="Cambria" pitchFamily="34" charset="0"/>
                 <a:ea typeface="Cambria" pitchFamily="34" charset="-122"/>
                 <a:cs typeface="Cambria" pitchFamily="34" charset="-120"/>
               </a:rPr>
-              <a:t>3</a:t>
-            </a:r>
-            <a:endParaRPr lang="en-US" sz="2000" dirty="0"/>
+              <a:t>→</a:t>
+            </a:r>
+            <a:endParaRPr lang="en-US" sz="2600" dirty="0"/>
           </a:p>
         </p:txBody>
       </p:sp>
       <p:sp>
         <p:nvSpPr>
-          <p:cNvPr id="17" name="Text 15"/>
+          <p:cNvPr id="30" name="Text 28"/>
           <p:cNvSpPr txBox="1"/>
           <p:nvPr/>
         </p:nvSpPr>
         <p:spPr>
           <a:xfrm>
-            <a:off x="1463040" y="3063240"/>
-            <a:ext cx="4389120" cy="365760"/>
+            <a:off x="8229600" y="4480560"/>
+            <a:ext cx="548640" cy="457200"/>
           </a:xfrm>
           <a:prstGeom prst="rect">
             <a:avLst/>
@@ -15662,34 +17632,34 @@
           <a:bodyPr wrap="square" lIns="0" tIns="0" rIns="0" bIns="0" rtlCol="0" anchor="ctr"/>
           <a:lstStyle/>
           <a:p>
-            <a:pPr indent="0" marL="0">
+            <a:pPr algn="ctr" indent="0" marL="0">
               <a:buNone/>
             </a:pPr>
             <a:r>
-              <a:rPr lang="en-US" sz="1600" b="1" dirty="0">
-                <a:solidFill>
-                  <a:srgbClr val="FFFFFF"/>
+              <a:rPr lang="en-US" sz="2600" b="1" dirty="0">
+                <a:solidFill>
+                  <a:srgbClr val="C9A227"/>
                 </a:solidFill>
                 <a:latin typeface="Cambria" pitchFamily="34" charset="0"/>
                 <a:ea typeface="Cambria" pitchFamily="34" charset="-122"/>
                 <a:cs typeface="Cambria" pitchFamily="34" charset="-120"/>
               </a:rPr>
-              <a:t>Cleaning</a:t>
-            </a:r>
-            <a:endParaRPr lang="en-US" sz="1600" dirty="0"/>
+              <a:t>→</a:t>
+            </a:r>
+            <a:endParaRPr lang="en-US" sz="2600" dirty="0"/>
           </a:p>
         </p:txBody>
       </p:sp>
       <p:sp>
         <p:nvSpPr>
-          <p:cNvPr id="18" name="Text 16"/>
+          <p:cNvPr id="31" name="Text 29"/>
           <p:cNvSpPr txBox="1"/>
           <p:nvPr/>
         </p:nvSpPr>
         <p:spPr>
           <a:xfrm>
-            <a:off x="1463040" y="3429000"/>
-            <a:ext cx="4389120" cy="457200"/>
+            <a:off x="8732520" y="5989320"/>
+            <a:ext cx="2926080" cy="274320"/>
           </a:xfrm>
           <a:prstGeom prst="rect">
             <a:avLst/>
@@ -15701,79 +17671,56 @@
           <a:bodyPr wrap="square" lIns="0" tIns="0" rIns="0" bIns="0" rtlCol="0" anchor="ctr"/>
           <a:lstStyle/>
           <a:p>
-            <a:pPr indent="0" marL="0">
-              <a:lnSpc>
-                <a:spcPct val="100000"/>
-              </a:lnSpc>
+            <a:pPr algn="ctr" indent="0" marL="0">
               <a:buNone/>
             </a:pPr>
             <a:r>
-              <a:rPr lang="en-US" sz="1250" dirty="0">
-                <a:solidFill>
-                  <a:srgbClr val="CFE3DF"/>
+              <a:rPr lang="en-US" sz="950" i="1" dirty="0">
+                <a:solidFill>
+                  <a:srgbClr val="6B7B77"/>
                 </a:solidFill>
                 <a:latin typeface="Calibri" pitchFamily="34" charset="0"/>
                 <a:ea typeface="Calibri" pitchFamily="34" charset="-122"/>
                 <a:cs typeface="Calibri" pitchFamily="34" charset="-120"/>
               </a:rPr>
-              <a:t>raw→clean→validate; rating 0 = unrated, not 0/5</a:t>
-            </a:r>
-            <a:endParaRPr lang="en-US" sz="1250" dirty="0"/>
+              <a:t>build KB (regenerable, git-ignored)</a:t>
+            </a:r>
+            <a:endParaRPr lang="en-US" sz="950" dirty="0"/>
           </a:p>
         </p:txBody>
       </p:sp>
       <p:sp>
         <p:nvSpPr>
-          <p:cNvPr id="19" name="Shape 17"/>
+          <p:cNvPr id="32" name="Shape 30"/>
           <p:cNvSpPr/>
           <p:nvPr/>
         </p:nvSpPr>
         <p:spPr>
           <a:xfrm>
-            <a:off x="6217920" y="2880360"/>
-            <a:ext cx="5349240" cy="1097280"/>
+            <a:off x="640080" y="5029200"/>
+            <a:ext cx="7680960" cy="1234440"/>
           </a:xfrm>
           <a:prstGeom prst="roundRect">
             <a:avLst>
-              <a:gd name="adj" fmla="val 5833"/>
+              <a:gd name="adj" fmla="val 5185"/>
             </a:avLst>
           </a:prstGeom>
           <a:solidFill>
-            <a:srgbClr val="12514A"/>
+            <a:srgbClr val="F3EEE4"/>
           </a:solidFill>
           <a:ln/>
         </p:spPr>
       </p:sp>
       <p:sp>
         <p:nvSpPr>
-          <p:cNvPr id="20" name="Shape 18"/>
-          <p:cNvSpPr/>
-          <p:nvPr/>
-        </p:nvSpPr>
-        <p:spPr>
-          <a:xfrm>
-            <a:off x="6446520" y="3209544"/>
-            <a:ext cx="438912" cy="438912"/>
-          </a:xfrm>
-          <a:prstGeom prst="ellipse">
-            <a:avLst/>
-          </a:prstGeom>
-          <a:solidFill>
-            <a:srgbClr val="C9A227"/>
-          </a:solidFill>
-          <a:ln/>
-        </p:spPr>
-      </p:sp>
-      <p:sp>
-        <p:nvSpPr>
-          <p:cNvPr id="21" name="Text 19"/>
+          <p:cNvPr id="33" name="Text 31"/>
           <p:cNvSpPr txBox="1"/>
           <p:nvPr/>
         </p:nvSpPr>
         <p:spPr>
           <a:xfrm>
-            <a:off x="6446520" y="3209544"/>
-            <a:ext cx="438912" cy="438912"/>
+            <a:off x="868680" y="5138928"/>
+            <a:ext cx="7315200" cy="274320"/>
           </a:xfrm>
           <a:prstGeom prst="rect">
             <a:avLst/>
@@ -15785,34 +17732,34 @@
           <a:bodyPr wrap="square" lIns="0" tIns="0" rIns="0" bIns="0" rtlCol="0" anchor="ctr"/>
           <a:lstStyle/>
           <a:p>
-            <a:pPr algn="ctr" indent="0" marL="0">
+            <a:pPr indent="0" marL="0">
               <a:buNone/>
             </a:pPr>
             <a:r>
-              <a:rPr lang="en-US" sz="2000" b="1" dirty="0">
-                <a:solidFill>
-                  <a:srgbClr val="0B3B36"/>
+              <a:rPr lang="en-US" sz="1200" b="1" dirty="0">
+                <a:solidFill>
+                  <a:srgbClr val="0E6E63"/>
                 </a:solidFill>
                 <a:latin typeface="Cambria" pitchFamily="34" charset="0"/>
                 <a:ea typeface="Cambria" pitchFamily="34" charset="-122"/>
                 <a:cs typeface="Cambria" pitchFamily="34" charset="-120"/>
               </a:rPr>
-              <a:t>4</a:t>
-            </a:r>
-            <a:endParaRPr lang="en-US" sz="2000" dirty="0"/>
+              <a:t>Entity resolution (between the split and the KB) writes 4 relationship files:</a:t>
+            </a:r>
+            <a:endParaRPr lang="en-US" sz="1200" dirty="0"/>
           </a:p>
         </p:txBody>
       </p:sp>
       <p:sp>
         <p:nvSpPr>
-          <p:cNvPr id="22" name="Text 20"/>
+          <p:cNvPr id="34" name="Text 32"/>
           <p:cNvSpPr txBox="1"/>
           <p:nvPr/>
         </p:nvSpPr>
         <p:spPr>
           <a:xfrm>
-            <a:off x="7040880" y="3063240"/>
-            <a:ext cx="4389120" cy="365760"/>
+            <a:off x="868680" y="5440680"/>
+            <a:ext cx="7315200" cy="731520"/>
           </a:xfrm>
           <a:prstGeom prst="rect">
             <a:avLst/>
@@ -15825,620 +17772,145 @@
           <a:lstStyle/>
           <a:p>
             <a:pPr indent="0" marL="0">
-              <a:buNone/>
-            </a:pPr>
-            <a:r>
-              <a:rPr lang="en-US" sz="1600" b="1" dirty="0">
-                <a:solidFill>
-                  <a:srgbClr val="FFFFFF"/>
-                </a:solidFill>
-                <a:latin typeface="Cambria" pitchFamily="34" charset="0"/>
-                <a:ea typeface="Cambria" pitchFamily="34" charset="-122"/>
-                <a:cs typeface="Cambria" pitchFamily="34" charset="-120"/>
-              </a:rPr>
-              <a:t>Standardization</a:t>
-            </a:r>
-            <a:endParaRPr lang="en-US" sz="1600" dirty="0"/>
-          </a:p>
-        </p:txBody>
-      </p:sp>
-      <p:sp>
-        <p:nvSpPr>
-          <p:cNvPr id="23" name="Text 21"/>
-          <p:cNvSpPr txBox="1"/>
-          <p:nvPr/>
-        </p:nvSpPr>
-        <p:spPr>
-          <a:xfrm>
-            <a:off x="7040880" y="3429000"/>
-            <a:ext cx="4389120" cy="457200"/>
-          </a:xfrm>
-          <a:prstGeom prst="rect">
-            <a:avLst/>
-          </a:prstGeom>
-          <a:noFill/>
-          <a:ln/>
-        </p:spPr>
-        <p:txBody>
-          <a:bodyPr wrap="square" lIns="0" tIns="0" rIns="0" bIns="0" rtlCol="0" anchor="ctr"/>
-          <a:lstStyle/>
-          <a:p>
-            <a:pPr indent="0" marL="0">
               <a:lnSpc>
-                <a:spcPct val="100000"/>
+                <a:spcPct val="115000"/>
               </a:lnSpc>
               <a:buNone/>
             </a:pPr>
             <a:r>
-              <a:rPr lang="en-US" sz="1250" dirty="0">
-                <a:solidFill>
-                  <a:srgbClr val="CFE3DF"/>
+              <a:rPr lang="en-US" sz="1100" b="1" dirty="0">
+                <a:solidFill>
+                  <a:srgbClr val="1F2A28"/>
                 </a:solidFill>
                 <a:latin typeface="Calibri" pitchFamily="34" charset="0"/>
                 <a:ea typeface="Calibri" pitchFamily="34" charset="-122"/>
                 <a:cs typeface="Calibri" pitchFamily="34" charset="-120"/>
               </a:rPr>
-              <a:t>Shared schema, rating_norm, bilingual documents</a:t>
-            </a:r>
-            <a:endParaRPr lang="en-US" sz="1250" dirty="0"/>
-          </a:p>
-        </p:txBody>
-      </p:sp>
-      <p:sp>
-        <p:nvSpPr>
-          <p:cNvPr id="24" name="Shape 22"/>
-          <p:cNvSpPr/>
-          <p:nvPr/>
-        </p:nvSpPr>
-        <p:spPr>
-          <a:xfrm>
-            <a:off x="640080" y="4114800"/>
-            <a:ext cx="5349240" cy="1097280"/>
-          </a:xfrm>
-          <a:prstGeom prst="roundRect">
-            <a:avLst>
-              <a:gd name="adj" fmla="val 5833"/>
-            </a:avLst>
-          </a:prstGeom>
-          <a:solidFill>
-            <a:srgbClr val="12514A"/>
-          </a:solidFill>
-          <a:ln/>
-        </p:spPr>
-      </p:sp>
-      <p:sp>
-        <p:nvSpPr>
-          <p:cNvPr id="25" name="Shape 23"/>
-          <p:cNvSpPr/>
-          <p:nvPr/>
-        </p:nvSpPr>
-        <p:spPr>
-          <a:xfrm>
-            <a:off x="868680" y="4443984"/>
-            <a:ext cx="438912" cy="438912"/>
-          </a:xfrm>
-          <a:prstGeom prst="ellipse">
-            <a:avLst/>
-          </a:prstGeom>
-          <a:solidFill>
-            <a:srgbClr val="C9A227"/>
-          </a:solidFill>
-          <a:ln/>
-        </p:spPr>
-      </p:sp>
-      <p:sp>
-        <p:nvSpPr>
-          <p:cNvPr id="26" name="Text 24"/>
-          <p:cNvSpPr txBox="1"/>
-          <p:nvPr/>
-        </p:nvSpPr>
-        <p:spPr>
-          <a:xfrm>
-            <a:off x="868680" y="4443984"/>
-            <a:ext cx="438912" cy="438912"/>
-          </a:xfrm>
-          <a:prstGeom prst="rect">
-            <a:avLst/>
-          </a:prstGeom>
-          <a:noFill/>
-          <a:ln/>
-        </p:spPr>
-        <p:txBody>
-          <a:bodyPr wrap="square" lIns="0" tIns="0" rIns="0" bIns="0" rtlCol="0" anchor="ctr"/>
-          <a:lstStyle/>
-          <a:p>
-            <a:pPr algn="ctr" indent="0" marL="0">
-              <a:buNone/>
-            </a:pPr>
-            <a:r>
-              <a:rPr lang="en-US" sz="2000" b="1" dirty="0">
-                <a:solidFill>
-                  <a:srgbClr val="0B3B36"/>
-                </a:solidFill>
-                <a:latin typeface="Cambria" pitchFamily="34" charset="0"/>
-                <a:ea typeface="Cambria" pitchFamily="34" charset="-122"/>
-                <a:cs typeface="Cambria" pitchFamily="34" charset="-120"/>
-              </a:rPr>
-              <a:t>5</a:t>
-            </a:r>
-            <a:endParaRPr lang="en-US" sz="2000" dirty="0"/>
-          </a:p>
-        </p:txBody>
-      </p:sp>
-      <p:sp>
-        <p:nvSpPr>
-          <p:cNvPr id="27" name="Text 25"/>
-          <p:cNvSpPr txBox="1"/>
-          <p:nvPr/>
-        </p:nvSpPr>
-        <p:spPr>
-          <a:xfrm>
-            <a:off x="1463040" y="4297680"/>
-            <a:ext cx="4389120" cy="365760"/>
-          </a:xfrm>
-          <a:prstGeom prst="rect">
-            <a:avLst/>
-          </a:prstGeom>
-          <a:noFill/>
-          <a:ln/>
-        </p:spPr>
-        <p:txBody>
-          <a:bodyPr wrap="square" lIns="0" tIns="0" rIns="0" bIns="0" rtlCol="0" anchor="ctr"/>
-          <a:lstStyle/>
-          <a:p>
-            <a:pPr indent="0" marL="0">
-              <a:buNone/>
-            </a:pPr>
-            <a:r>
-              <a:rPr lang="en-US" sz="1600" b="1" dirty="0">
-                <a:solidFill>
-                  <a:srgbClr val="FFFFFF"/>
-                </a:solidFill>
-                <a:latin typeface="Cambria" pitchFamily="34" charset="0"/>
-                <a:ea typeface="Cambria" pitchFamily="34" charset="-122"/>
-                <a:cs typeface="Cambria" pitchFamily="34" charset="-120"/>
-              </a:rPr>
-              <a:t>Entity Resolution</a:t>
-            </a:r>
-            <a:endParaRPr lang="en-US" sz="1600" dirty="0"/>
-          </a:p>
-        </p:txBody>
-      </p:sp>
-      <p:sp>
-        <p:nvSpPr>
-          <p:cNvPr id="28" name="Text 26"/>
-          <p:cNvSpPr txBox="1"/>
-          <p:nvPr/>
-        </p:nvSpPr>
-        <p:spPr>
-          <a:xfrm>
-            <a:off x="1463040" y="4663440"/>
-            <a:ext cx="4389120" cy="457200"/>
-          </a:xfrm>
-          <a:prstGeom prst="rect">
-            <a:avLst/>
-          </a:prstGeom>
-          <a:noFill/>
-          <a:ln/>
-        </p:spPr>
-        <p:txBody>
-          <a:bodyPr wrap="square" lIns="0" tIns="0" rIns="0" bIns="0" rtlCol="0" anchor="ctr"/>
-          <a:lstStyle/>
-          <a:p>
+              <a:t>canonical_entities</a:t>
+            </a:r>
             <a:pPr indent="0" marL="0">
               <a:lnSpc>
-                <a:spcPct val="100000"/>
+                <a:spcPct val="115000"/>
               </a:lnSpc>
               <a:buNone/>
             </a:pPr>
             <a:r>
-              <a:rPr lang="en-US" sz="1250" dirty="0">
-                <a:solidFill>
-                  <a:srgbClr val="CFE3DF"/>
+              <a:rPr lang="en-US" sz="1100" dirty="0">
+                <a:solidFill>
+                  <a:srgbClr val="6B7B77"/>
                 </a:solidFill>
                 <a:latin typeface="Calibri" pitchFamily="34" charset="0"/>
                 <a:ea typeface="Calibri" pitchFamily="34" charset="-122"/>
                 <a:cs typeface="Calibri" pitchFamily="34" charset="-120"/>
               </a:rPr>
-              <a:t>Canonical IDs (RYD_000123) via name+city+coords</a:t>
-            </a:r>
-            <a:endParaRPr lang="en-US" sz="1250" dirty="0"/>
-          </a:p>
-        </p:txBody>
-      </p:sp>
-      <p:sp>
-        <p:nvSpPr>
-          <p:cNvPr id="29" name="Shape 27"/>
-          <p:cNvSpPr/>
-          <p:nvPr/>
-        </p:nvSpPr>
-        <p:spPr>
-          <a:xfrm>
-            <a:off x="6217920" y="4114800"/>
-            <a:ext cx="5349240" cy="1097280"/>
-          </a:xfrm>
-          <a:prstGeom prst="roundRect">
-            <a:avLst>
-              <a:gd name="adj" fmla="val 5833"/>
-            </a:avLst>
-          </a:prstGeom>
-          <a:solidFill>
-            <a:srgbClr val="12514A"/>
-          </a:solidFill>
-          <a:ln/>
-        </p:spPr>
-      </p:sp>
-      <p:sp>
-        <p:nvSpPr>
-          <p:cNvPr id="30" name="Shape 28"/>
-          <p:cNvSpPr/>
-          <p:nvPr/>
-        </p:nvSpPr>
-        <p:spPr>
-          <a:xfrm>
-            <a:off x="6446520" y="4443984"/>
-            <a:ext cx="438912" cy="438912"/>
-          </a:xfrm>
-          <a:prstGeom prst="ellipse">
-            <a:avLst/>
-          </a:prstGeom>
-          <a:solidFill>
-            <a:srgbClr val="C9A227"/>
-          </a:solidFill>
-          <a:ln/>
-        </p:spPr>
-      </p:sp>
-      <p:sp>
-        <p:nvSpPr>
-          <p:cNvPr id="31" name="Text 29"/>
-          <p:cNvSpPr txBox="1"/>
-          <p:nvPr/>
-        </p:nvSpPr>
-        <p:spPr>
-          <a:xfrm>
-            <a:off x="6446520" y="4443984"/>
-            <a:ext cx="438912" cy="438912"/>
-          </a:xfrm>
-          <a:prstGeom prst="rect">
-            <a:avLst/>
-          </a:prstGeom>
-          <a:noFill/>
-          <a:ln/>
-        </p:spPr>
-        <p:txBody>
-          <a:bodyPr wrap="square" lIns="0" tIns="0" rIns="0" bIns="0" rtlCol="0" anchor="ctr"/>
-          <a:lstStyle/>
-          <a:p>
-            <a:pPr algn="ctr" indent="0" marL="0">
-              <a:buNone/>
-            </a:pPr>
-            <a:r>
-              <a:rPr lang="en-US" sz="2000" b="1" dirty="0">
-                <a:solidFill>
-                  <a:srgbClr val="0B3B36"/>
-                </a:solidFill>
-                <a:latin typeface="Cambria" pitchFamily="34" charset="0"/>
-                <a:ea typeface="Cambria" pitchFamily="34" charset="-122"/>
-                <a:cs typeface="Cambria" pitchFamily="34" charset="-120"/>
-              </a:rPr>
-              <a:t>6</a:t>
-            </a:r>
-            <a:endParaRPr lang="en-US" sz="2000" dirty="0"/>
-          </a:p>
-        </p:txBody>
-      </p:sp>
-      <p:sp>
-        <p:nvSpPr>
-          <p:cNvPr id="32" name="Text 30"/>
-          <p:cNvSpPr txBox="1"/>
-          <p:nvPr/>
-        </p:nvSpPr>
-        <p:spPr>
-          <a:xfrm>
-            <a:off x="7040880" y="4297680"/>
-            <a:ext cx="4389120" cy="365760"/>
-          </a:xfrm>
-          <a:prstGeom prst="rect">
-            <a:avLst/>
-          </a:prstGeom>
-          <a:noFill/>
-          <a:ln/>
-        </p:spPr>
-        <p:txBody>
-          <a:bodyPr wrap="square" lIns="0" tIns="0" rIns="0" bIns="0" rtlCol="0" anchor="ctr"/>
-          <a:lstStyle/>
-          <a:p>
-            <a:pPr indent="0" marL="0">
-              <a:buNone/>
-            </a:pPr>
-            <a:r>
-              <a:rPr lang="en-US" sz="1600" b="1" dirty="0">
-                <a:solidFill>
-                  <a:srgbClr val="FFFFFF"/>
-                </a:solidFill>
-                <a:latin typeface="Cambria" pitchFamily="34" charset="0"/>
-                <a:ea typeface="Cambria" pitchFamily="34" charset="-122"/>
-                <a:cs typeface="Cambria" pitchFamily="34" charset="-120"/>
-              </a:rPr>
-              <a:t>Hybrid KB</a:t>
-            </a:r>
-            <a:endParaRPr lang="en-US" sz="1600" dirty="0"/>
-          </a:p>
-        </p:txBody>
-      </p:sp>
-      <p:sp>
-        <p:nvSpPr>
-          <p:cNvPr id="33" name="Text 31"/>
-          <p:cNvSpPr txBox="1"/>
-          <p:nvPr/>
-        </p:nvSpPr>
-        <p:spPr>
-          <a:xfrm>
-            <a:off x="7040880" y="4663440"/>
-            <a:ext cx="4389120" cy="457200"/>
-          </a:xfrm>
-          <a:prstGeom prst="rect">
-            <a:avLst/>
-          </a:prstGeom>
-          <a:noFill/>
-          <a:ln/>
-        </p:spPr>
-        <p:txBody>
-          <a:bodyPr wrap="square" lIns="0" tIns="0" rIns="0" bIns="0" rtlCol="0" anchor="ctr"/>
-          <a:lstStyle/>
-          <a:p>
+              <a:t> (master list)   </a:t>
+            </a:r>
             <a:pPr indent="0" marL="0">
               <a:lnSpc>
-                <a:spcPct val="100000"/>
+                <a:spcPct val="115000"/>
               </a:lnSpc>
               <a:buNone/>
             </a:pPr>
             <a:r>
-              <a:rPr lang="en-US" sz="1250" dirty="0">
-                <a:solidFill>
-                  <a:srgbClr val="CFE3DF"/>
+              <a:rPr lang="en-US" sz="1100" b="1" dirty="0">
+                <a:solidFill>
+                  <a:srgbClr val="1F2A28"/>
                 </a:solidFill>
                 <a:latin typeface="Calibri" pitchFamily="34" charset="0"/>
                 <a:ea typeface="Calibri" pitchFamily="34" charset="-122"/>
                 <a:cs typeface="Calibri" pitchFamily="34" charset="-120"/>
               </a:rPr>
-              <a:t>SQLite exact filters + multilingual vector store</a:t>
-            </a:r>
-            <a:endParaRPr lang="en-US" sz="1250" dirty="0"/>
-          </a:p>
-        </p:txBody>
-      </p:sp>
-      <p:sp>
-        <p:nvSpPr>
-          <p:cNvPr id="34" name="Text 32"/>
-          <p:cNvSpPr txBox="1"/>
-          <p:nvPr/>
-        </p:nvSpPr>
-        <p:spPr>
-          <a:xfrm>
-            <a:off x="640080" y="5806440"/>
-            <a:ext cx="3520440" cy="548640"/>
-          </a:xfrm>
-          <a:prstGeom prst="rect">
-            <a:avLst/>
-          </a:prstGeom>
-          <a:noFill/>
-          <a:ln/>
-        </p:spPr>
-        <p:txBody>
-          <a:bodyPr wrap="square" lIns="0" tIns="0" rIns="0" bIns="0" rtlCol="0" anchor="ctr"/>
-          <a:lstStyle/>
-          <a:p>
+              <a:t>entity_crosswalk</a:t>
+            </a:r>
             <a:pPr indent="0" marL="0">
+              <a:lnSpc>
+                <a:spcPct val="115000"/>
+              </a:lnSpc>
               <a:buNone/>
             </a:pPr>
             <a:r>
-              <a:rPr lang="en-US" sz="3000" b="1" dirty="0">
-                <a:solidFill>
-                  <a:srgbClr val="C9A227"/>
-                </a:solidFill>
-                <a:latin typeface="Cambria" pitchFamily="34" charset="0"/>
-                <a:ea typeface="Cambria" pitchFamily="34" charset="-122"/>
-                <a:cs typeface="Cambria" pitchFamily="34" charset="-120"/>
-              </a:rPr>
-              <a:t>21,782</a:t>
-            </a:r>
-            <a:endParaRPr lang="en-US" sz="3000" dirty="0"/>
-          </a:p>
-        </p:txBody>
-      </p:sp>
-      <p:sp>
-        <p:nvSpPr>
-          <p:cNvPr id="35" name="Text 33"/>
-          <p:cNvSpPr txBox="1"/>
-          <p:nvPr/>
-        </p:nvSpPr>
-        <p:spPr>
-          <a:xfrm>
-            <a:off x="640080" y="6355080"/>
-            <a:ext cx="3520440" cy="320040"/>
-          </a:xfrm>
-          <a:prstGeom prst="rect">
-            <a:avLst/>
-          </a:prstGeom>
-          <a:noFill/>
-          <a:ln/>
-        </p:spPr>
-        <p:txBody>
-          <a:bodyPr wrap="square" lIns="0" tIns="0" rIns="0" bIns="0" rtlCol="0" anchor="ctr"/>
-          <a:lstStyle/>
-          <a:p>
-            <a:pPr indent="0" marL="0">
-              <a:buNone/>
-            </a:pPr>
-            <a:r>
-              <a:rPr lang="en-US" sz="1200" dirty="0">
-                <a:solidFill>
-                  <a:srgbClr val="9FB8B3"/>
+              <a:rPr lang="en-US" sz="1100" dirty="0">
+                <a:solidFill>
+                  <a:srgbClr val="6B7B77"/>
                 </a:solidFill>
                 <a:latin typeface="Calibri" pitchFamily="34" charset="0"/>
                 <a:ea typeface="Calibri" pitchFamily="34" charset="-122"/>
                 <a:cs typeface="Calibri" pitchFamily="34" charset="-120"/>
               </a:rPr>
-              <a:t>clean entity records</a:t>
-            </a:r>
-            <a:endParaRPr lang="en-US" sz="1200" dirty="0"/>
-          </a:p>
-        </p:txBody>
-      </p:sp>
-      <p:sp>
-        <p:nvSpPr>
-          <p:cNvPr id="36" name="Text 34"/>
-          <p:cNvSpPr txBox="1"/>
-          <p:nvPr/>
-        </p:nvSpPr>
-        <p:spPr>
-          <a:xfrm>
-            <a:off x="4343400" y="5806440"/>
-            <a:ext cx="3520440" cy="548640"/>
-          </a:xfrm>
-          <a:prstGeom prst="rect">
-            <a:avLst/>
-          </a:prstGeom>
-          <a:noFill/>
-          <a:ln/>
-        </p:spPr>
-        <p:txBody>
-          <a:bodyPr wrap="square" lIns="0" tIns="0" rIns="0" bIns="0" rtlCol="0" anchor="ctr"/>
-          <a:lstStyle/>
+              <a:t> (source→canonical join hub)</a:t>
+            </a:r>
+            <a:endParaRPr lang="en-US" sz="1100" dirty="0"/>
+          </a:p>
           <a:p>
             <a:pPr indent="0" marL="0">
+              <a:lnSpc>
+                <a:spcPct val="115000"/>
+              </a:lnSpc>
               <a:buNone/>
             </a:pPr>
             <a:r>
-              <a:rPr lang="en-US" sz="3000" b="1" dirty="0">
-                <a:solidFill>
-                  <a:srgbClr val="C9A227"/>
-                </a:solidFill>
-                <a:latin typeface="Cambria" pitchFamily="34" charset="0"/>
-                <a:ea typeface="Cambria" pitchFamily="34" charset="-122"/>
-                <a:cs typeface="Cambria" pitchFamily="34" charset="-120"/>
-              </a:rPr>
-              <a:t>10,027</a:t>
-            </a:r>
-            <a:endParaRPr lang="en-US" sz="3000" dirty="0"/>
-          </a:p>
-        </p:txBody>
-      </p:sp>
-      <p:sp>
-        <p:nvSpPr>
-          <p:cNvPr id="37" name="Text 35"/>
-          <p:cNvSpPr txBox="1"/>
-          <p:nvPr/>
-        </p:nvSpPr>
-        <p:spPr>
-          <a:xfrm>
-            <a:off x="4343400" y="6355080"/>
-            <a:ext cx="3520440" cy="320040"/>
-          </a:xfrm>
-          <a:prstGeom prst="rect">
-            <a:avLst/>
-          </a:prstGeom>
-          <a:noFill/>
-          <a:ln/>
-        </p:spPr>
-        <p:txBody>
-          <a:bodyPr wrap="square" lIns="0" tIns="0" rIns="0" bIns="0" rtlCol="0" anchor="ctr"/>
-          <a:lstStyle/>
-          <a:p>
-            <a:pPr indent="0" marL="0">
-              <a:buNone/>
-            </a:pPr>
-            <a:r>
-              <a:rPr lang="en-US" sz="1200" dirty="0">
-                <a:solidFill>
-                  <a:srgbClr val="9FB8B3"/>
+              <a:rPr lang="en-US" sz="1100" b="1" dirty="0">
+                <a:solidFill>
+                  <a:srgbClr val="1F2A28"/>
                 </a:solidFill>
                 <a:latin typeface="Calibri" pitchFamily="34" charset="0"/>
                 <a:ea typeface="Calibri" pitchFamily="34" charset="-122"/>
                 <a:cs typeface="Calibri" pitchFamily="34" charset="-120"/>
               </a:rPr>
-              <a:t>canonical entities</a:t>
-            </a:r>
-            <a:endParaRPr lang="en-US" sz="1200" dirty="0"/>
-          </a:p>
-        </p:txBody>
-      </p:sp>
-      <p:sp>
-        <p:nvSpPr>
-          <p:cNvPr id="38" name="Text 36"/>
-          <p:cNvSpPr txBox="1"/>
-          <p:nvPr/>
-        </p:nvSpPr>
-        <p:spPr>
-          <a:xfrm>
-            <a:off x="8046720" y="5806440"/>
-            <a:ext cx="3520440" cy="548640"/>
-          </a:xfrm>
-          <a:prstGeom prst="rect">
-            <a:avLst/>
-          </a:prstGeom>
-          <a:noFill/>
-          <a:ln/>
-        </p:spPr>
-        <p:txBody>
-          <a:bodyPr wrap="square" lIns="0" tIns="0" rIns="0" bIns="0" rtlCol="0" anchor="ctr"/>
-          <a:lstStyle/>
-          <a:p>
+              <a:t>candidate_links</a:t>
+            </a:r>
             <a:pPr indent="0" marL="0">
+              <a:lnSpc>
+                <a:spcPct val="115000"/>
+              </a:lnSpc>
               <a:buNone/>
             </a:pPr>
             <a:r>
-              <a:rPr lang="en-US" sz="3000" b="1" dirty="0">
-                <a:solidFill>
-                  <a:srgbClr val="C9A227"/>
-                </a:solidFill>
-                <a:latin typeface="Cambria" pitchFamily="34" charset="0"/>
-                <a:ea typeface="Cambria" pitchFamily="34" charset="-122"/>
-                <a:cs typeface="Cambria" pitchFamily="34" charset="-120"/>
-              </a:rPr>
-              <a:t>34</a:t>
-            </a:r>
-            <a:endParaRPr lang="en-US" sz="3000" dirty="0"/>
-          </a:p>
-        </p:txBody>
-      </p:sp>
-      <p:sp>
-        <p:nvSpPr>
-          <p:cNvPr id="39" name="Text 37"/>
-          <p:cNvSpPr txBox="1"/>
-          <p:nvPr/>
-        </p:nvSpPr>
-        <p:spPr>
-          <a:xfrm>
-            <a:off x="8046720" y="6355080"/>
-            <a:ext cx="3520440" cy="320040"/>
-          </a:xfrm>
-          <a:prstGeom prst="rect">
-            <a:avLst/>
-          </a:prstGeom>
-          <a:noFill/>
-          <a:ln/>
-        </p:spPr>
-        <p:txBody>
-          <a:bodyPr wrap="square" lIns="0" tIns="0" rIns="0" bIns="0" rtlCol="0" anchor="ctr"/>
-          <a:lstStyle/>
-          <a:p>
-            <a:pPr indent="0" marL="0">
-              <a:buNone/>
-            </a:pPr>
-            <a:r>
-              <a:rPr lang="en-US" sz="1200" dirty="0">
-                <a:solidFill>
-                  <a:srgbClr val="9FB8B3"/>
+              <a:rPr lang="en-US" sz="1100" dirty="0">
+                <a:solidFill>
+                  <a:srgbClr val="6B7B77"/>
                 </a:solidFill>
                 <a:latin typeface="Calibri" pitchFamily="34" charset="0"/>
                 <a:ea typeface="Calibri" pitchFamily="34" charset="-122"/>
                 <a:cs typeface="Calibri" pitchFamily="34" charset="-120"/>
               </a:rPr>
-              <a:t>hotels match a sample query</a:t>
-            </a:r>
-            <a:endParaRPr lang="en-US" sz="1200" dirty="0"/>
+              <a:t> (near-matches, not merged)   </a:t>
+            </a:r>
+            <a:pPr indent="0" marL="0">
+              <a:lnSpc>
+                <a:spcPct val="115000"/>
+              </a:lnSpc>
+              <a:buNone/>
+            </a:pPr>
+            <a:r>
+              <a:rPr lang="en-US" sz="1100" b="1" dirty="0">
+                <a:solidFill>
+                  <a:srgbClr val="1F2A28"/>
+                </a:solidFill>
+                <a:latin typeface="Calibri" pitchFamily="34" charset="0"/>
+                <a:ea typeface="Calibri" pitchFamily="34" charset="-122"/>
+                <a:cs typeface="Calibri" pitchFamily="34" charset="-120"/>
+              </a:rPr>
+              <a:t>review_place_links</a:t>
+            </a:r>
+            <a:pPr indent="0" marL="0">
+              <a:lnSpc>
+                <a:spcPct val="115000"/>
+              </a:lnSpc>
+              <a:buNone/>
+            </a:pPr>
+            <a:r>
+              <a:rPr lang="en-US" sz="1100" dirty="0">
+                <a:solidFill>
+                  <a:srgbClr val="6B7B77"/>
+                </a:solidFill>
+                <a:latin typeface="Calibri" pitchFamily="34" charset="0"/>
+                <a:ea typeface="Calibri" pitchFamily="34" charset="-122"/>
+                <a:cs typeface="Calibri" pitchFamily="34" charset="-120"/>
+              </a:rPr>
+              <a:t> (review→place)</a:t>
+            </a:r>
+            <a:endParaRPr lang="en-US" sz="1100" dirty="0"/>
           </a:p>
         </p:txBody>
       </p:sp>

</xml_diff>

<commit_message>
Add conceptual pipeline-flow slide (RAW -> KB fork)
Vertical flow with a guiding question under each stage (Quality
Assessment / Cleaning / Standardization / Entity Resolution / Knowledge
Base), forking into the two KB layers: Structured (SQLite - exact facts:
dates, prices, ratings, coordinates) and Semantic (Vector Store -
meaning/evidence: reviews, descriptions, preferences, contextual text).
Deck now 12 slides; schema validation passes.

Co-Authored-By: Claude Opus 4.8 <noreply@anthropic.com>
Claude-Session: https://claude.ai/code/session_01NGG3PfYdyeFGmt8xWkYAuk
</commit_message>
<xml_diff>
--- a/docs/Saudi_Digital_Concierge_Proposal.pptx
+++ b/docs/Saudi_Digital_Concierge_Proposal.pptx
@@ -16,9 +16,10 @@
     <p:sldId id="264" r:id="rId10"/>
     <p:sldId id="265" r:id="rId11"/>
     <p:sldId id="266" r:id="rId12"/>
+    <p:sldId id="267" r:id="rId13"/>
   </p:sldIdLst>
   <p:notesMasterIdLst>
-    <p:notesMasterId r:id="rId13"/>
+    <p:notesMasterId r:id="rId14"/>
   </p:notesMasterIdLst>
   <p:sldSz cx="12192000" cy="6858000"/>
   <p:notesSz cx="6858000" cy="12192000"/>
@@ -712,6 +713,94 @@
             <a:fld id="{F7021451-1387-4CA6-816F-3879F97B5CBC}" type="slidenum">
               <a:rPr lang="en-US"/>
               <a:t>11</a:t>
+            </a:fld>
+            <a:endParaRPr lang="en-US"/>
+          </a:p>
+        </p:txBody>
+      </p:sp>
+    </p:spTree>
+    <p:extLst>
+      <p:ext uri="{BB962C8B-B14F-4D97-AF65-F5344CB8AC3E}">
+        <p14:creationId xmlns:p14="http://schemas.microsoft.com/office/powerpoint/2010/main" val="1024086991"/>
+      </p:ext>
+    </p:extLst>
+  </p:cSld>
+  <p:clrMapOvr>
+    <a:masterClrMapping/>
+  </p:clrMapOvr>
+</p:notes>
+</file>
+
+<file path=ppt/notesSlides/notesSlide12.xml><?xml version="1.0" encoding="utf-8"?>
+<p:notes xmlns:a="http://schemas.openxmlformats.org/drawingml/2006/main" xmlns:r="http://schemas.openxmlformats.org/officeDocument/2006/relationships" xmlns:p="http://schemas.openxmlformats.org/presentationml/2006/main">
+  <p:cSld>
+    <p:spTree>
+      <p:nvGrpSpPr>
+        <p:cNvPr id="1" name=""/>
+        <p:cNvGrpSpPr/>
+        <p:nvPr/>
+      </p:nvGrpSpPr>
+      <p:grpSpPr>
+        <a:xfrm>
+          <a:off x="0" y="0"/>
+          <a:ext cx="0" cy="0"/>
+          <a:chOff x="0" y="0"/>
+          <a:chExt cx="0" cy="0"/>
+        </a:xfrm>
+      </p:grpSpPr>
+      <p:sp>
+        <p:nvSpPr>
+          <p:cNvPr id="2" name="Slide Image Placeholder 1"/>
+          <p:cNvSpPr>
+            <a:spLocks noGrp="1" noRot="1" noChangeAspect="1"/>
+          </p:cNvSpPr>
+          <p:nvPr>
+            <p:ph type="sldImg"/>
+          </p:nvPr>
+        </p:nvSpPr>
+        <p:spPr/>
+      </p:sp>
+      <p:sp>
+        <p:nvSpPr>
+          <p:cNvPr id="3" name="Notes Placeholder 2"/>
+          <p:cNvSpPr>
+            <a:spLocks noGrp="1"/>
+          </p:cNvSpPr>
+          <p:nvPr>
+            <p:ph type="body" idx="1"/>
+          </p:nvPr>
+        </p:nvSpPr>
+        <p:spPr/>
+        <p:txBody>
+          <a:bodyPr/>
+          <a:lstStyle/>
+          <a:p>
+            <a:r>
+              <a:rPr lang="en-US" dirty="0"/>
+              <a:t/>
+            </a:r>
+            <a:endParaRPr lang="en-US" dirty="0"/>
+          </a:p>
+        </p:txBody>
+      </p:sp>
+      <p:sp>
+        <p:nvSpPr>
+          <p:cNvPr id="4" name="Slide Number Placeholder 3"/>
+          <p:cNvSpPr>
+            <a:spLocks noGrp="1"/>
+          </p:cNvSpPr>
+          <p:nvPr>
+            <p:ph type="sldNum" sz="quarter" idx="10"/>
+          </p:nvPr>
+        </p:nvSpPr>
+        <p:spPr/>
+        <p:txBody>
+          <a:bodyPr/>
+          <a:lstStyle/>
+          <a:p>
+            <a:fld id="{F7021451-1387-4CA6-816F-3879F97B5CBC}" type="slidenum">
+              <a:rPr lang="en-US"/>
+              <a:t>12</a:t>
             </a:fld>
             <a:endParaRPr lang="en-US"/>
           </a:p>
@@ -1998,6 +2087,1389 @@
     <p:bg>
       <p:bgPr>
         <a:solidFill>
+          <a:srgbClr val="FFFFFF"/>
+        </a:solidFill>
+      </p:bgPr>
+    </p:bg>
+    <p:spTree>
+      <p:nvGrpSpPr>
+        <p:cNvPr id="1" name=""/>
+        <p:cNvGrpSpPr/>
+        <p:nvPr/>
+      </p:nvGrpSpPr>
+      <p:grpSpPr>
+        <a:xfrm>
+          <a:off x="0" y="0"/>
+          <a:ext cx="0" cy="0"/>
+          <a:chOff x="0" y="0"/>
+          <a:chExt cx="0" cy="0"/>
+        </a:xfrm>
+      </p:grpSpPr>
+      <p:sp>
+        <p:nvSpPr>
+          <p:cNvPr id="2" name="Text 0"/>
+          <p:cNvSpPr txBox="1"/>
+          <p:nvPr/>
+        </p:nvSpPr>
+        <p:spPr>
+          <a:xfrm>
+            <a:off x="640080" y="411480"/>
+            <a:ext cx="10972800" cy="548640"/>
+          </a:xfrm>
+          <a:prstGeom prst="rect">
+            <a:avLst/>
+          </a:prstGeom>
+          <a:noFill/>
+          <a:ln/>
+        </p:spPr>
+        <p:txBody>
+          <a:bodyPr wrap="square" lIns="0" tIns="0" rIns="0" bIns="0" rtlCol="0" anchor="ctr"/>
+          <a:lstStyle/>
+          <a:p>
+            <a:pPr indent="0" marL="0">
+              <a:buNone/>
+            </a:pPr>
+            <a:r>
+              <a:rPr lang="en-US" sz="3000" b="1" dirty="0">
+                <a:solidFill>
+                  <a:srgbClr val="1F2A28"/>
+                </a:solidFill>
+                <a:latin typeface="Cambria" pitchFamily="34" charset="0"/>
+                <a:ea typeface="Cambria" pitchFamily="34" charset="-122"/>
+                <a:cs typeface="Cambria" pitchFamily="34" charset="-120"/>
+              </a:rPr>
+              <a:t>The file trail — one café through the pipeline</a:t>
+            </a:r>
+            <a:endParaRPr lang="en-US" sz="3000" dirty="0"/>
+          </a:p>
+        </p:txBody>
+      </p:sp>
+      <p:sp>
+        <p:nvSpPr>
+          <p:cNvPr id="3" name="Text 1"/>
+          <p:cNvSpPr txBox="1"/>
+          <p:nvPr/>
+        </p:nvSpPr>
+        <p:spPr>
+          <a:xfrm>
+            <a:off x="640080" y="987552"/>
+            <a:ext cx="10972800" cy="320040"/>
+          </a:xfrm>
+          <a:prstGeom prst="rect">
+            <a:avLst/>
+          </a:prstGeom>
+          <a:noFill/>
+          <a:ln/>
+        </p:spPr>
+        <p:txBody>
+          <a:bodyPr wrap="square" lIns="0" tIns="0" rIns="0" bIns="0" rtlCol="0" anchor="ctr"/>
+          <a:lstStyle/>
+          <a:p>
+            <a:pPr indent="0" marL="0">
+              <a:buNone/>
+            </a:pPr>
+            <a:r>
+              <a:rPr lang="en-US" sz="1400" i="1" dirty="0">
+                <a:solidFill>
+                  <a:srgbClr val="6B7B77"/>
+                </a:solidFill>
+                <a:latin typeface="Calibri" pitchFamily="34" charset="0"/>
+                <a:ea typeface="Calibri" pitchFamily="34" charset="-122"/>
+                <a:cs typeface="Calibri" pitchFamily="34" charset="-120"/>
+              </a:rPr>
+              <a:t>Each stage writes its own file; standardization splits into two shapes — one per half of the hybrid KB.</a:t>
+            </a:r>
+            <a:endParaRPr lang="en-US" sz="1400" dirty="0"/>
+          </a:p>
+        </p:txBody>
+      </p:sp>
+      <p:sp>
+        <p:nvSpPr>
+          <p:cNvPr id="4" name="Shape 2"/>
+          <p:cNvSpPr/>
+          <p:nvPr/>
+        </p:nvSpPr>
+        <p:spPr>
+          <a:xfrm>
+            <a:off x="2743200" y="1417320"/>
+            <a:ext cx="3566160" cy="749808"/>
+          </a:xfrm>
+          <a:prstGeom prst="roundRect">
+            <a:avLst>
+              <a:gd name="adj" fmla="val 7317"/>
+            </a:avLst>
+          </a:prstGeom>
+          <a:solidFill>
+            <a:srgbClr val="F3EEE4"/>
+          </a:solidFill>
+          <a:ln/>
+        </p:spPr>
+      </p:sp>
+      <p:sp>
+        <p:nvSpPr>
+          <p:cNvPr id="5" name="Text 3"/>
+          <p:cNvSpPr txBox="1"/>
+          <p:nvPr/>
+        </p:nvSpPr>
+        <p:spPr>
+          <a:xfrm>
+            <a:off x="2907792" y="1527048"/>
+            <a:ext cx="3273552" cy="274320"/>
+          </a:xfrm>
+          <a:prstGeom prst="rect">
+            <a:avLst/>
+          </a:prstGeom>
+          <a:noFill/>
+          <a:ln/>
+        </p:spPr>
+        <p:txBody>
+          <a:bodyPr wrap="square" lIns="0" tIns="0" rIns="0" bIns="0" rtlCol="0" anchor="ctr"/>
+          <a:lstStyle/>
+          <a:p>
+            <a:pPr indent="0" marL="0">
+              <a:buNone/>
+            </a:pPr>
+            <a:r>
+              <a:rPr lang="en-US" sz="1150" b="1" dirty="0">
+                <a:solidFill>
+                  <a:srgbClr val="1F2A28"/>
+                </a:solidFill>
+                <a:latin typeface="Consolas" pitchFamily="34" charset="0"/>
+                <a:ea typeface="Consolas" pitchFamily="34" charset="-122"/>
+                <a:cs typeface="Consolas" pitchFamily="34" charset="-120"/>
+              </a:rPr>
+              <a:t>raw/places.csv</a:t>
+            </a:r>
+            <a:endParaRPr lang="en-US" sz="1150" dirty="0"/>
+          </a:p>
+        </p:txBody>
+      </p:sp>
+      <p:sp>
+        <p:nvSpPr>
+          <p:cNvPr id="6" name="Text 4"/>
+          <p:cNvSpPr txBox="1"/>
+          <p:nvPr/>
+        </p:nvSpPr>
+        <p:spPr>
+          <a:xfrm>
+            <a:off x="2907792" y="1819656"/>
+            <a:ext cx="3273552" cy="292608"/>
+          </a:xfrm>
+          <a:prstGeom prst="rect">
+            <a:avLst/>
+          </a:prstGeom>
+          <a:noFill/>
+          <a:ln/>
+        </p:spPr>
+        <p:txBody>
+          <a:bodyPr wrap="square" lIns="0" tIns="0" rIns="0" bIns="0" rtlCol="0" anchor="ctr"/>
+          <a:lstStyle/>
+          <a:p>
+            <a:pPr indent="0" marL="0">
+              <a:lnSpc>
+                <a:spcPct val="95000"/>
+              </a:lnSpc>
+              <a:buNone/>
+            </a:pPr>
+            <a:r>
+              <a:rPr lang="en-US" sz="1000" dirty="0">
+                <a:solidFill>
+                  <a:srgbClr val="6B7B77"/>
+                </a:solidFill>
+                <a:latin typeface="Calibri" pitchFamily="34" charset="0"/>
+                <a:ea typeface="Calibri" pitchFamily="34" charset="-122"/>
+                <a:cs typeface="Calibri" pitchFamily="34" charset="-120"/>
+              </a:rPr>
+              <a:t>2 messy rows · rating=0 · "Riyadh, Saudi Arabia"</a:t>
+            </a:r>
+            <a:endParaRPr lang="en-US" sz="1000" dirty="0"/>
+          </a:p>
+        </p:txBody>
+      </p:sp>
+      <p:sp>
+        <p:nvSpPr>
+          <p:cNvPr id="7" name="Text 5"/>
+          <p:cNvSpPr txBox="1"/>
+          <p:nvPr/>
+        </p:nvSpPr>
+        <p:spPr>
+          <a:xfrm>
+            <a:off x="6446520" y="1554480"/>
+            <a:ext cx="1463040" cy="274320"/>
+          </a:xfrm>
+          <a:prstGeom prst="rect">
+            <a:avLst/>
+          </a:prstGeom>
+          <a:noFill/>
+          <a:ln/>
+        </p:spPr>
+        <p:txBody>
+          <a:bodyPr wrap="square" lIns="0" tIns="0" rIns="0" bIns="0" rtlCol="0" anchor="ctr"/>
+          <a:lstStyle/>
+          <a:p>
+            <a:pPr indent="0" marL="0">
+              <a:buNone/>
+            </a:pPr>
+            <a:r>
+              <a:rPr lang="en-US" sz="1000" i="1" dirty="0">
+                <a:solidFill>
+                  <a:srgbClr val="6B7B77"/>
+                </a:solidFill>
+                <a:latin typeface="Calibri" pitchFamily="34" charset="0"/>
+                <a:ea typeface="Calibri" pitchFamily="34" charset="-122"/>
+                <a:cs typeface="Calibri" pitchFamily="34" charset="-120"/>
+              </a:rPr>
+              <a:t>collect</a:t>
+            </a:r>
+            <a:endParaRPr lang="en-US" sz="1000" dirty="0"/>
+          </a:p>
+        </p:txBody>
+      </p:sp>
+      <p:sp>
+        <p:nvSpPr>
+          <p:cNvPr id="8" name="Text 6"/>
+          <p:cNvSpPr txBox="1"/>
+          <p:nvPr/>
+        </p:nvSpPr>
+        <p:spPr>
+          <a:xfrm>
+            <a:off x="4251960" y="2194560"/>
+            <a:ext cx="548640" cy="320040"/>
+          </a:xfrm>
+          <a:prstGeom prst="rect">
+            <a:avLst/>
+          </a:prstGeom>
+          <a:noFill/>
+          <a:ln/>
+        </p:spPr>
+        <p:txBody>
+          <a:bodyPr wrap="square" lIns="0" tIns="0" rIns="0" bIns="0" rtlCol="0" anchor="ctr"/>
+          <a:lstStyle/>
+          <a:p>
+            <a:pPr algn="ctr" indent="0" marL="0">
+              <a:buNone/>
+            </a:pPr>
+            <a:r>
+              <a:rPr lang="en-US" sz="2000" b="1" dirty="0">
+                <a:solidFill>
+                  <a:srgbClr val="C9A227"/>
+                </a:solidFill>
+                <a:latin typeface="Cambria" pitchFamily="34" charset="0"/>
+                <a:ea typeface="Cambria" pitchFamily="34" charset="-122"/>
+                <a:cs typeface="Cambria" pitchFamily="34" charset="-120"/>
+              </a:rPr>
+              <a:t>↓</a:t>
+            </a:r>
+            <a:endParaRPr lang="en-US" sz="2000" dirty="0"/>
+          </a:p>
+        </p:txBody>
+      </p:sp>
+      <p:sp>
+        <p:nvSpPr>
+          <p:cNvPr id="9" name="Shape 7"/>
+          <p:cNvSpPr/>
+          <p:nvPr/>
+        </p:nvSpPr>
+        <p:spPr>
+          <a:xfrm>
+            <a:off x="2743200" y="2487168"/>
+            <a:ext cx="3566160" cy="749808"/>
+          </a:xfrm>
+          <a:prstGeom prst="roundRect">
+            <a:avLst>
+              <a:gd name="adj" fmla="val 7317"/>
+            </a:avLst>
+          </a:prstGeom>
+          <a:solidFill>
+            <a:srgbClr val="F3EEE4"/>
+          </a:solidFill>
+          <a:ln/>
+        </p:spPr>
+      </p:sp>
+      <p:sp>
+        <p:nvSpPr>
+          <p:cNvPr id="10" name="Text 8"/>
+          <p:cNvSpPr txBox="1"/>
+          <p:nvPr/>
+        </p:nvSpPr>
+        <p:spPr>
+          <a:xfrm>
+            <a:off x="2907792" y="2596896"/>
+            <a:ext cx="3273552" cy="274320"/>
+          </a:xfrm>
+          <a:prstGeom prst="rect">
+            <a:avLst/>
+          </a:prstGeom>
+          <a:noFill/>
+          <a:ln/>
+        </p:spPr>
+        <p:txBody>
+          <a:bodyPr wrap="square" lIns="0" tIns="0" rIns="0" bIns="0" rtlCol="0" anchor="ctr"/>
+          <a:lstStyle/>
+          <a:p>
+            <a:pPr indent="0" marL="0">
+              <a:buNone/>
+            </a:pPr>
+            <a:r>
+              <a:rPr lang="en-US" sz="1150" b="1" dirty="0">
+                <a:solidFill>
+                  <a:srgbClr val="1F2A28"/>
+                </a:solidFill>
+                <a:latin typeface="Consolas" pitchFamily="34" charset="0"/>
+                <a:ea typeface="Consolas" pitchFamily="34" charset="-122"/>
+                <a:cs typeface="Consolas" pitchFamily="34" charset="-120"/>
+              </a:rPr>
+              <a:t>processed/places_clean.csv</a:t>
+            </a:r>
+            <a:endParaRPr lang="en-US" sz="1150" dirty="0"/>
+          </a:p>
+        </p:txBody>
+      </p:sp>
+      <p:sp>
+        <p:nvSpPr>
+          <p:cNvPr id="11" name="Text 9"/>
+          <p:cNvSpPr txBox="1"/>
+          <p:nvPr/>
+        </p:nvSpPr>
+        <p:spPr>
+          <a:xfrm>
+            <a:off x="2907792" y="2889504"/>
+            <a:ext cx="3273552" cy="292608"/>
+          </a:xfrm>
+          <a:prstGeom prst="rect">
+            <a:avLst/>
+          </a:prstGeom>
+          <a:noFill/>
+          <a:ln/>
+        </p:spPr>
+        <p:txBody>
+          <a:bodyPr wrap="square" lIns="0" tIns="0" rIns="0" bIns="0" rtlCol="0" anchor="ctr"/>
+          <a:lstStyle/>
+          <a:p>
+            <a:pPr indent="0" marL="0">
+              <a:lnSpc>
+                <a:spcPct val="95000"/>
+              </a:lnSpc>
+              <a:buNone/>
+            </a:pPr>
+            <a:r>
+              <a:rPr lang="en-US" sz="1000" dirty="0">
+                <a:solidFill>
+                  <a:srgbClr val="6B7B77"/>
+                </a:solidFill>
+                <a:latin typeface="Calibri" pitchFamily="34" charset="0"/>
+                <a:ea typeface="Calibri" pitchFamily="34" charset="-122"/>
+                <a:cs typeface="Calibri" pitchFamily="34" charset="-120"/>
+              </a:rPr>
+              <a:t>rating 0→null · city→Riyadh/Riyadh</a:t>
+            </a:r>
+            <a:endParaRPr lang="en-US" sz="1000" dirty="0"/>
+          </a:p>
+        </p:txBody>
+      </p:sp>
+      <p:sp>
+        <p:nvSpPr>
+          <p:cNvPr id="12" name="Text 10"/>
+          <p:cNvSpPr txBox="1"/>
+          <p:nvPr/>
+        </p:nvSpPr>
+        <p:spPr>
+          <a:xfrm>
+            <a:off x="6446520" y="2624328"/>
+            <a:ext cx="1463040" cy="274320"/>
+          </a:xfrm>
+          <a:prstGeom prst="rect">
+            <a:avLst/>
+          </a:prstGeom>
+          <a:noFill/>
+          <a:ln/>
+        </p:spPr>
+        <p:txBody>
+          <a:bodyPr wrap="square" lIns="0" tIns="0" rIns="0" bIns="0" rtlCol="0" anchor="ctr"/>
+          <a:lstStyle/>
+          <a:p>
+            <a:pPr indent="0" marL="0">
+              <a:buNone/>
+            </a:pPr>
+            <a:r>
+              <a:rPr lang="en-US" sz="1000" i="1" dirty="0">
+                <a:solidFill>
+                  <a:srgbClr val="6B7B77"/>
+                </a:solidFill>
+                <a:latin typeface="Calibri" pitchFamily="34" charset="0"/>
+                <a:ea typeface="Calibri" pitchFamily="34" charset="-122"/>
+                <a:cs typeface="Calibri" pitchFamily="34" charset="-120"/>
+              </a:rPr>
+              <a:t>clean</a:t>
+            </a:r>
+            <a:endParaRPr lang="en-US" sz="1000" dirty="0"/>
+          </a:p>
+        </p:txBody>
+      </p:sp>
+      <p:sp>
+        <p:nvSpPr>
+          <p:cNvPr id="13" name="Text 11"/>
+          <p:cNvSpPr txBox="1"/>
+          <p:nvPr/>
+        </p:nvSpPr>
+        <p:spPr>
+          <a:xfrm>
+            <a:off x="4251960" y="3264408"/>
+            <a:ext cx="548640" cy="320040"/>
+          </a:xfrm>
+          <a:prstGeom prst="rect">
+            <a:avLst/>
+          </a:prstGeom>
+          <a:noFill/>
+          <a:ln/>
+        </p:spPr>
+        <p:txBody>
+          <a:bodyPr wrap="square" lIns="0" tIns="0" rIns="0" bIns="0" rtlCol="0" anchor="ctr"/>
+          <a:lstStyle/>
+          <a:p>
+            <a:pPr algn="ctr" indent="0" marL="0">
+              <a:buNone/>
+            </a:pPr>
+            <a:r>
+              <a:rPr lang="en-US" sz="2000" b="1" dirty="0">
+                <a:solidFill>
+                  <a:srgbClr val="C9A227"/>
+                </a:solidFill>
+                <a:latin typeface="Cambria" pitchFamily="34" charset="0"/>
+                <a:ea typeface="Cambria" pitchFamily="34" charset="-122"/>
+                <a:cs typeface="Cambria" pitchFamily="34" charset="-120"/>
+              </a:rPr>
+              <a:t>↓</a:t>
+            </a:r>
+            <a:endParaRPr lang="en-US" sz="2000" dirty="0"/>
+          </a:p>
+        </p:txBody>
+      </p:sp>
+      <p:sp>
+        <p:nvSpPr>
+          <p:cNvPr id="14" name="Text 12"/>
+          <p:cNvSpPr txBox="1"/>
+          <p:nvPr/>
+        </p:nvSpPr>
+        <p:spPr>
+          <a:xfrm>
+            <a:off x="1463040" y="3566160"/>
+            <a:ext cx="6126480" cy="274320"/>
+          </a:xfrm>
+          <a:prstGeom prst="rect">
+            <a:avLst/>
+          </a:prstGeom>
+          <a:noFill/>
+          <a:ln/>
+        </p:spPr>
+        <p:txBody>
+          <a:bodyPr wrap="square" lIns="0" tIns="0" rIns="0" bIns="0" rtlCol="0" anchor="ctr"/>
+          <a:lstStyle/>
+          <a:p>
+            <a:pPr algn="ctr" indent="0" marL="0">
+              <a:buNone/>
+            </a:pPr>
+            <a:r>
+              <a:rPr lang="en-US" sz="1200" b="1" dirty="0">
+                <a:solidFill>
+                  <a:srgbClr val="0E6E63"/>
+                </a:solidFill>
+                <a:latin typeface="Cambria" pitchFamily="34" charset="0"/>
+                <a:ea typeface="Cambria" pitchFamily="34" charset="-122"/>
+                <a:cs typeface="Cambria" pitchFamily="34" charset="-120"/>
+              </a:rPr>
+              <a:t>standardize → splits into two shapes</a:t>
+            </a:r>
+            <a:endParaRPr lang="en-US" sz="1200" dirty="0"/>
+          </a:p>
+        </p:txBody>
+      </p:sp>
+      <p:sp>
+        <p:nvSpPr>
+          <p:cNvPr id="15" name="Shape 13"/>
+          <p:cNvSpPr/>
+          <p:nvPr/>
+        </p:nvSpPr>
+        <p:spPr>
+          <a:xfrm>
+            <a:off x="640080" y="3913632"/>
+            <a:ext cx="3703320" cy="749808"/>
+          </a:xfrm>
+          <a:prstGeom prst="roundRect">
+            <a:avLst>
+              <a:gd name="adj" fmla="val 7317"/>
+            </a:avLst>
+          </a:prstGeom>
+          <a:solidFill>
+            <a:srgbClr val="E9F2F0"/>
+          </a:solidFill>
+          <a:ln/>
+        </p:spPr>
+      </p:sp>
+      <p:sp>
+        <p:nvSpPr>
+          <p:cNvPr id="16" name="Text 14"/>
+          <p:cNvSpPr txBox="1"/>
+          <p:nvPr/>
+        </p:nvSpPr>
+        <p:spPr>
+          <a:xfrm>
+            <a:off x="804672" y="4023360"/>
+            <a:ext cx="3410712" cy="274320"/>
+          </a:xfrm>
+          <a:prstGeom prst="rect">
+            <a:avLst/>
+          </a:prstGeom>
+          <a:noFill/>
+          <a:ln/>
+        </p:spPr>
+        <p:txBody>
+          <a:bodyPr wrap="square" lIns="0" tIns="0" rIns="0" bIns="0" rtlCol="0" anchor="ctr"/>
+          <a:lstStyle/>
+          <a:p>
+            <a:pPr indent="0" marL="0">
+              <a:buNone/>
+            </a:pPr>
+            <a:r>
+              <a:rPr lang="en-US" sz="1150" b="1" dirty="0">
+                <a:solidFill>
+                  <a:srgbClr val="1F2A28"/>
+                </a:solidFill>
+                <a:latin typeface="Consolas" pitchFamily="34" charset="0"/>
+                <a:ea typeface="Consolas" pitchFamily="34" charset="-122"/>
+                <a:cs typeface="Consolas" pitchFamily="34" charset="-120"/>
+              </a:rPr>
+              <a:t>entities_core.csv</a:t>
+            </a:r>
+            <a:endParaRPr lang="en-US" sz="1150" dirty="0"/>
+          </a:p>
+        </p:txBody>
+      </p:sp>
+      <p:sp>
+        <p:nvSpPr>
+          <p:cNvPr id="17" name="Text 15"/>
+          <p:cNvSpPr txBox="1"/>
+          <p:nvPr/>
+        </p:nvSpPr>
+        <p:spPr>
+          <a:xfrm>
+            <a:off x="804672" y="4315968"/>
+            <a:ext cx="3410712" cy="292608"/>
+          </a:xfrm>
+          <a:prstGeom prst="rect">
+            <a:avLst/>
+          </a:prstGeom>
+          <a:noFill/>
+          <a:ln/>
+        </p:spPr>
+        <p:txBody>
+          <a:bodyPr wrap="square" lIns="0" tIns="0" rIns="0" bIns="0" rtlCol="0" anchor="ctr"/>
+          <a:lstStyle/>
+          <a:p>
+            <a:pPr indent="0" marL="0">
+              <a:lnSpc>
+                <a:spcPct val="95000"/>
+              </a:lnSpc>
+              <a:buNone/>
+            </a:pPr>
+            <a:r>
+              <a:rPr lang="en-US" sz="1000" dirty="0">
+                <a:solidFill>
+                  <a:srgbClr val="6B7B77"/>
+                </a:solidFill>
+                <a:latin typeface="Calibri" pitchFamily="34" charset="0"/>
+                <a:ea typeface="Calibri" pitchFamily="34" charset="-122"/>
+                <a:cs typeface="Calibri" pitchFamily="34" charset="-120"/>
+              </a:rPr>
+              <a:t>facts to FILTER · rating_norm 0.8 · city · price</a:t>
+            </a:r>
+            <a:endParaRPr lang="en-US" sz="1000" dirty="0"/>
+          </a:p>
+        </p:txBody>
+      </p:sp>
+      <p:sp>
+        <p:nvSpPr>
+          <p:cNvPr id="18" name="Shape 16"/>
+          <p:cNvSpPr/>
+          <p:nvPr/>
+        </p:nvSpPr>
+        <p:spPr>
+          <a:xfrm>
+            <a:off x="4617720" y="3913632"/>
+            <a:ext cx="3703320" cy="749808"/>
+          </a:xfrm>
+          <a:prstGeom prst="roundRect">
+            <a:avLst>
+              <a:gd name="adj" fmla="val 7317"/>
+            </a:avLst>
+          </a:prstGeom>
+          <a:solidFill>
+            <a:srgbClr val="FBF4DD"/>
+          </a:solidFill>
+          <a:ln/>
+        </p:spPr>
+      </p:sp>
+      <p:sp>
+        <p:nvSpPr>
+          <p:cNvPr id="19" name="Text 17"/>
+          <p:cNvSpPr txBox="1"/>
+          <p:nvPr/>
+        </p:nvSpPr>
+        <p:spPr>
+          <a:xfrm>
+            <a:off x="4782312" y="4023360"/>
+            <a:ext cx="3410712" cy="274320"/>
+          </a:xfrm>
+          <a:prstGeom prst="rect">
+            <a:avLst/>
+          </a:prstGeom>
+          <a:noFill/>
+          <a:ln/>
+        </p:spPr>
+        <p:txBody>
+          <a:bodyPr wrap="square" lIns="0" tIns="0" rIns="0" bIns="0" rtlCol="0" anchor="ctr"/>
+          <a:lstStyle/>
+          <a:p>
+            <a:pPr indent="0" marL="0">
+              <a:buNone/>
+            </a:pPr>
+            <a:r>
+              <a:rPr lang="en-US" sz="1150" b="1" dirty="0">
+                <a:solidFill>
+                  <a:srgbClr val="1F2A28"/>
+                </a:solidFill>
+                <a:latin typeface="Consolas" pitchFamily="34" charset="0"/>
+                <a:ea typeface="Consolas" pitchFamily="34" charset="-122"/>
+                <a:cs typeface="Consolas" pitchFamily="34" charset="-120"/>
+              </a:rPr>
+              <a:t>kb_documents.csv</a:t>
+            </a:r>
+            <a:endParaRPr lang="en-US" sz="1150" dirty="0"/>
+          </a:p>
+        </p:txBody>
+      </p:sp>
+      <p:sp>
+        <p:nvSpPr>
+          <p:cNvPr id="20" name="Text 18"/>
+          <p:cNvSpPr txBox="1"/>
+          <p:nvPr/>
+        </p:nvSpPr>
+        <p:spPr>
+          <a:xfrm>
+            <a:off x="4782312" y="4315968"/>
+            <a:ext cx="3410712" cy="292608"/>
+          </a:xfrm>
+          <a:prstGeom prst="rect">
+            <a:avLst/>
+          </a:prstGeom>
+          <a:noFill/>
+          <a:ln/>
+        </p:spPr>
+        <p:txBody>
+          <a:bodyPr wrap="square" lIns="0" tIns="0" rIns="0" bIns="0" rtlCol="0" anchor="ctr"/>
+          <a:lstStyle/>
+          <a:p>
+            <a:pPr indent="0" marL="0">
+              <a:lnSpc>
+                <a:spcPct val="95000"/>
+              </a:lnSpc>
+              <a:buNone/>
+            </a:pPr>
+            <a:r>
+              <a:rPr lang="en-US" sz="1000" dirty="0">
+                <a:solidFill>
+                  <a:srgbClr val="6B7B77"/>
+                </a:solidFill>
+                <a:latin typeface="Calibri" pitchFamily="34" charset="0"/>
+                <a:ea typeface="Calibri" pitchFamily="34" charset="-122"/>
+                <a:cs typeface="Calibri" pitchFamily="34" charset="-120"/>
+              </a:rPr>
+              <a:t>TEXT to embed + embed flag · language</a:t>
+            </a:r>
+            <a:endParaRPr lang="en-US" sz="1000" dirty="0"/>
+          </a:p>
+        </p:txBody>
+      </p:sp>
+      <p:sp>
+        <p:nvSpPr>
+          <p:cNvPr id="21" name="Shape 19"/>
+          <p:cNvSpPr/>
+          <p:nvPr/>
+        </p:nvSpPr>
+        <p:spPr>
+          <a:xfrm>
+            <a:off x="8732520" y="1417320"/>
+            <a:ext cx="2880360" cy="2148840"/>
+          </a:xfrm>
+          <a:prstGeom prst="roundRect">
+            <a:avLst>
+              <a:gd name="adj" fmla="val 3404"/>
+            </a:avLst>
+          </a:prstGeom>
+          <a:solidFill>
+            <a:srgbClr val="0B3B36"/>
+          </a:solidFill>
+          <a:ln/>
+        </p:spPr>
+      </p:sp>
+      <p:sp>
+        <p:nvSpPr>
+          <p:cNvPr id="22" name="Text 20"/>
+          <p:cNvSpPr txBox="1"/>
+          <p:nvPr/>
+        </p:nvSpPr>
+        <p:spPr>
+          <a:xfrm>
+            <a:off x="8961120" y="1572768"/>
+            <a:ext cx="2468880" cy="274320"/>
+          </a:xfrm>
+          <a:prstGeom prst="rect">
+            <a:avLst/>
+          </a:prstGeom>
+          <a:noFill/>
+          <a:ln/>
+        </p:spPr>
+        <p:txBody>
+          <a:bodyPr wrap="square" lIns="0" tIns="0" rIns="0" bIns="0" rtlCol="0" anchor="ctr"/>
+          <a:lstStyle/>
+          <a:p>
+            <a:pPr indent="0" marL="0">
+              <a:buNone/>
+            </a:pPr>
+            <a:r>
+              <a:rPr lang="en-US" sz="1300" b="1" dirty="0">
+                <a:solidFill>
+                  <a:srgbClr val="C9A227"/>
+                </a:solidFill>
+                <a:latin typeface="Cambria" pitchFamily="34" charset="0"/>
+                <a:ea typeface="Cambria" pitchFamily="34" charset="-122"/>
+                <a:cs typeface="Cambria" pitchFamily="34" charset="-120"/>
+              </a:rPr>
+              <a:t>Structured layer</a:t>
+            </a:r>
+            <a:endParaRPr lang="en-US" sz="1300" dirty="0"/>
+          </a:p>
+        </p:txBody>
+      </p:sp>
+      <p:sp>
+        <p:nvSpPr>
+          <p:cNvPr id="23" name="Text 21"/>
+          <p:cNvSpPr txBox="1"/>
+          <p:nvPr/>
+        </p:nvSpPr>
+        <p:spPr>
+          <a:xfrm>
+            <a:off x="8961120" y="1883664"/>
+            <a:ext cx="2468880" cy="274320"/>
+          </a:xfrm>
+          <a:prstGeom prst="rect">
+            <a:avLst/>
+          </a:prstGeom>
+          <a:noFill/>
+          <a:ln/>
+        </p:spPr>
+        <p:txBody>
+          <a:bodyPr wrap="square" lIns="0" tIns="0" rIns="0" bIns="0" rtlCol="0" anchor="ctr"/>
+          <a:lstStyle/>
+          <a:p>
+            <a:pPr indent="0" marL="0">
+              <a:buNone/>
+            </a:pPr>
+            <a:r>
+              <a:rPr lang="en-US" sz="1050" dirty="0">
+                <a:solidFill>
+                  <a:srgbClr val="FFFFFF"/>
+                </a:solidFill>
+                <a:latin typeface="Consolas" pitchFamily="34" charset="0"/>
+                <a:ea typeface="Consolas" pitchFamily="34" charset="-122"/>
+                <a:cs typeface="Consolas" pitchFamily="34" charset="-120"/>
+              </a:rPr>
+              <a:t>knowledge_base.sqlite</a:t>
+            </a:r>
+            <a:endParaRPr lang="en-US" sz="1050" dirty="0"/>
+          </a:p>
+        </p:txBody>
+      </p:sp>
+      <p:sp>
+        <p:nvSpPr>
+          <p:cNvPr id="24" name="Text 22"/>
+          <p:cNvSpPr txBox="1"/>
+          <p:nvPr/>
+        </p:nvSpPr>
+        <p:spPr>
+          <a:xfrm>
+            <a:off x="8961120" y="2212848"/>
+            <a:ext cx="2468880" cy="1188720"/>
+          </a:xfrm>
+          <a:prstGeom prst="rect">
+            <a:avLst/>
+          </a:prstGeom>
+          <a:noFill/>
+          <a:ln/>
+        </p:spPr>
+        <p:txBody>
+          <a:bodyPr wrap="square" lIns="0" tIns="0" rIns="0" bIns="0" rtlCol="0" anchor="ctr"/>
+          <a:lstStyle/>
+          <a:p>
+            <a:pPr indent="0" marL="0">
+              <a:lnSpc>
+                <a:spcPct val="105000"/>
+              </a:lnSpc>
+              <a:buNone/>
+            </a:pPr>
+            <a:r>
+              <a:rPr lang="en-US" sz="1050" b="1" dirty="0">
+                <a:solidFill>
+                  <a:srgbClr val="E8F3F0"/>
+                </a:solidFill>
+                <a:latin typeface="Calibri" pitchFamily="34" charset="0"/>
+                <a:ea typeface="Calibri" pitchFamily="34" charset="-122"/>
+                <a:cs typeface="Calibri" pitchFamily="34" charset="-120"/>
+              </a:rPr>
+              <a:t>exact filters</a:t>
+            </a:r>
+            <a:endParaRPr lang="en-US" sz="1050" dirty="0"/>
+          </a:p>
+          <a:p>
+            <a:pPr indent="0" marL="0">
+              <a:lnSpc>
+                <a:spcPct val="105000"/>
+              </a:lnSpc>
+              <a:buNone/>
+            </a:pPr>
+            <a:r>
+              <a:rPr lang="en-US" sz="1050" dirty="0">
+                <a:solidFill>
+                  <a:srgbClr val="BFE0DA"/>
+                </a:solidFill>
+                <a:latin typeface="Calibri" pitchFamily="34" charset="0"/>
+                <a:ea typeface="Calibri" pitchFamily="34" charset="-122"/>
+                <a:cs typeface="Calibri" pitchFamily="34" charset="-120"/>
+              </a:rPr>
+              <a:t>city = Riyadh AND rating_norm ≥ 0.8 AND price ≤ 50</a:t>
+            </a:r>
+            <a:endParaRPr lang="en-US" sz="1050" dirty="0"/>
+          </a:p>
+        </p:txBody>
+      </p:sp>
+      <p:sp>
+        <p:nvSpPr>
+          <p:cNvPr id="25" name="Shape 23"/>
+          <p:cNvSpPr/>
+          <p:nvPr/>
+        </p:nvSpPr>
+        <p:spPr>
+          <a:xfrm>
+            <a:off x="8732520" y="3703320"/>
+            <a:ext cx="2880360" cy="2560320"/>
+          </a:xfrm>
+          <a:prstGeom prst="roundRect">
+            <a:avLst>
+              <a:gd name="adj" fmla="val 2857"/>
+            </a:avLst>
+          </a:prstGeom>
+          <a:solidFill>
+            <a:srgbClr val="0E6E63"/>
+          </a:solidFill>
+          <a:ln/>
+        </p:spPr>
+      </p:sp>
+      <p:sp>
+        <p:nvSpPr>
+          <p:cNvPr id="26" name="Text 24"/>
+          <p:cNvSpPr txBox="1"/>
+          <p:nvPr/>
+        </p:nvSpPr>
+        <p:spPr>
+          <a:xfrm>
+            <a:off x="8961120" y="3858768"/>
+            <a:ext cx="2468880" cy="274320"/>
+          </a:xfrm>
+          <a:prstGeom prst="rect">
+            <a:avLst/>
+          </a:prstGeom>
+          <a:noFill/>
+          <a:ln/>
+        </p:spPr>
+        <p:txBody>
+          <a:bodyPr wrap="square" lIns="0" tIns="0" rIns="0" bIns="0" rtlCol="0" anchor="ctr"/>
+          <a:lstStyle/>
+          <a:p>
+            <a:pPr indent="0" marL="0">
+              <a:buNone/>
+            </a:pPr>
+            <a:r>
+              <a:rPr lang="en-US" sz="1300" b="1" dirty="0">
+                <a:solidFill>
+                  <a:srgbClr val="FFF3CC"/>
+                </a:solidFill>
+                <a:latin typeface="Cambria" pitchFamily="34" charset="0"/>
+                <a:ea typeface="Cambria" pitchFamily="34" charset="-122"/>
+                <a:cs typeface="Cambria" pitchFamily="34" charset="-120"/>
+              </a:rPr>
+              <a:t>Semantic layer</a:t>
+            </a:r>
+            <a:endParaRPr lang="en-US" sz="1300" dirty="0"/>
+          </a:p>
+        </p:txBody>
+      </p:sp>
+      <p:sp>
+        <p:nvSpPr>
+          <p:cNvPr id="27" name="Text 25"/>
+          <p:cNvSpPr txBox="1"/>
+          <p:nvPr/>
+        </p:nvSpPr>
+        <p:spPr>
+          <a:xfrm>
+            <a:off x="8961120" y="4169664"/>
+            <a:ext cx="2468880" cy="274320"/>
+          </a:xfrm>
+          <a:prstGeom prst="rect">
+            <a:avLst/>
+          </a:prstGeom>
+          <a:noFill/>
+          <a:ln/>
+        </p:spPr>
+        <p:txBody>
+          <a:bodyPr wrap="square" lIns="0" tIns="0" rIns="0" bIns="0" rtlCol="0" anchor="ctr"/>
+          <a:lstStyle/>
+          <a:p>
+            <a:pPr indent="0" marL="0">
+              <a:buNone/>
+            </a:pPr>
+            <a:r>
+              <a:rPr lang="en-US" sz="1000" dirty="0">
+                <a:solidFill>
+                  <a:srgbClr val="FFFFFF"/>
+                </a:solidFill>
+                <a:latin typeface="Consolas" pitchFamily="34" charset="0"/>
+                <a:ea typeface="Consolas" pitchFamily="34" charset="-122"/>
+                <a:cs typeface="Consolas" pitchFamily="34" charset="-120"/>
+              </a:rPr>
+              <a:t>vector_store/  (.npy + meta)</a:t>
+            </a:r>
+            <a:endParaRPr lang="en-US" sz="1000" dirty="0"/>
+          </a:p>
+        </p:txBody>
+      </p:sp>
+      <p:sp>
+        <p:nvSpPr>
+          <p:cNvPr id="28" name="Text 26"/>
+          <p:cNvSpPr txBox="1"/>
+          <p:nvPr/>
+        </p:nvSpPr>
+        <p:spPr>
+          <a:xfrm>
+            <a:off x="8961120" y="4498848"/>
+            <a:ext cx="2468880" cy="1188720"/>
+          </a:xfrm>
+          <a:prstGeom prst="rect">
+            <a:avLst/>
+          </a:prstGeom>
+          <a:noFill/>
+          <a:ln/>
+        </p:spPr>
+        <p:txBody>
+          <a:bodyPr wrap="square" lIns="0" tIns="0" rIns="0" bIns="0" rtlCol="0" anchor="ctr"/>
+          <a:lstStyle/>
+          <a:p>
+            <a:pPr indent="0" marL="0">
+              <a:lnSpc>
+                <a:spcPct val="105000"/>
+              </a:lnSpc>
+              <a:buNone/>
+            </a:pPr>
+            <a:r>
+              <a:rPr lang="en-US" sz="1050" b="1" dirty="0">
+                <a:solidFill>
+                  <a:srgbClr val="FFFFFF"/>
+                </a:solidFill>
+                <a:latin typeface="Calibri" pitchFamily="34" charset="0"/>
+                <a:ea typeface="Calibri" pitchFamily="34" charset="-122"/>
+                <a:cs typeface="Calibri" pitchFamily="34" charset="-120"/>
+              </a:rPr>
+              <a:t>meaning search</a:t>
+            </a:r>
+            <a:endParaRPr lang="en-US" sz="1050" dirty="0"/>
+          </a:p>
+          <a:p>
+            <a:pPr indent="0" marL="0">
+              <a:lnSpc>
+                <a:spcPct val="105000"/>
+              </a:lnSpc>
+              <a:buNone/>
+            </a:pPr>
+            <a:r>
+              <a:rPr lang="en-US" sz="1050" dirty="0">
+                <a:solidFill>
+                  <a:srgbClr val="E8F3F0"/>
+                </a:solidFill>
+                <a:latin typeface="Calibri" pitchFamily="34" charset="0"/>
+                <a:ea typeface="Calibri" pitchFamily="34" charset="-122"/>
+                <a:cs typeface="Calibri" pitchFamily="34" charset="-120"/>
+              </a:rPr>
+              <a:t>“cozy, family-friendly vibe” → 768-dim vector</a:t>
+            </a:r>
+            <a:endParaRPr lang="en-US" sz="1050" dirty="0"/>
+          </a:p>
+        </p:txBody>
+      </p:sp>
+      <p:sp>
+        <p:nvSpPr>
+          <p:cNvPr id="29" name="Text 27"/>
+          <p:cNvSpPr txBox="1"/>
+          <p:nvPr/>
+        </p:nvSpPr>
+        <p:spPr>
+          <a:xfrm>
+            <a:off x="8229600" y="2194560"/>
+            <a:ext cx="548640" cy="457200"/>
+          </a:xfrm>
+          <a:prstGeom prst="rect">
+            <a:avLst/>
+          </a:prstGeom>
+          <a:noFill/>
+          <a:ln/>
+        </p:spPr>
+        <p:txBody>
+          <a:bodyPr wrap="square" lIns="0" tIns="0" rIns="0" bIns="0" rtlCol="0" anchor="ctr"/>
+          <a:lstStyle/>
+          <a:p>
+            <a:pPr algn="ctr" indent="0" marL="0">
+              <a:buNone/>
+            </a:pPr>
+            <a:r>
+              <a:rPr lang="en-US" sz="2600" b="1" dirty="0">
+                <a:solidFill>
+                  <a:srgbClr val="C9A227"/>
+                </a:solidFill>
+                <a:latin typeface="Cambria" pitchFamily="34" charset="0"/>
+                <a:ea typeface="Cambria" pitchFamily="34" charset="-122"/>
+                <a:cs typeface="Cambria" pitchFamily="34" charset="-120"/>
+              </a:rPr>
+              <a:t>→</a:t>
+            </a:r>
+            <a:endParaRPr lang="en-US" sz="2600" dirty="0"/>
+          </a:p>
+        </p:txBody>
+      </p:sp>
+      <p:sp>
+        <p:nvSpPr>
+          <p:cNvPr id="30" name="Text 28"/>
+          <p:cNvSpPr txBox="1"/>
+          <p:nvPr/>
+        </p:nvSpPr>
+        <p:spPr>
+          <a:xfrm>
+            <a:off x="8229600" y="4480560"/>
+            <a:ext cx="548640" cy="457200"/>
+          </a:xfrm>
+          <a:prstGeom prst="rect">
+            <a:avLst/>
+          </a:prstGeom>
+          <a:noFill/>
+          <a:ln/>
+        </p:spPr>
+        <p:txBody>
+          <a:bodyPr wrap="square" lIns="0" tIns="0" rIns="0" bIns="0" rtlCol="0" anchor="ctr"/>
+          <a:lstStyle/>
+          <a:p>
+            <a:pPr algn="ctr" indent="0" marL="0">
+              <a:buNone/>
+            </a:pPr>
+            <a:r>
+              <a:rPr lang="en-US" sz="2600" b="1" dirty="0">
+                <a:solidFill>
+                  <a:srgbClr val="C9A227"/>
+                </a:solidFill>
+                <a:latin typeface="Cambria" pitchFamily="34" charset="0"/>
+                <a:ea typeface="Cambria" pitchFamily="34" charset="-122"/>
+                <a:cs typeface="Cambria" pitchFamily="34" charset="-120"/>
+              </a:rPr>
+              <a:t>→</a:t>
+            </a:r>
+            <a:endParaRPr lang="en-US" sz="2600" dirty="0"/>
+          </a:p>
+        </p:txBody>
+      </p:sp>
+      <p:sp>
+        <p:nvSpPr>
+          <p:cNvPr id="31" name="Text 29"/>
+          <p:cNvSpPr txBox="1"/>
+          <p:nvPr/>
+        </p:nvSpPr>
+        <p:spPr>
+          <a:xfrm>
+            <a:off x="8732520" y="5989320"/>
+            <a:ext cx="2926080" cy="274320"/>
+          </a:xfrm>
+          <a:prstGeom prst="rect">
+            <a:avLst/>
+          </a:prstGeom>
+          <a:noFill/>
+          <a:ln/>
+        </p:spPr>
+        <p:txBody>
+          <a:bodyPr wrap="square" lIns="0" tIns="0" rIns="0" bIns="0" rtlCol="0" anchor="ctr"/>
+          <a:lstStyle/>
+          <a:p>
+            <a:pPr algn="ctr" indent="0" marL="0">
+              <a:buNone/>
+            </a:pPr>
+            <a:r>
+              <a:rPr lang="en-US" sz="950" i="1" dirty="0">
+                <a:solidFill>
+                  <a:srgbClr val="6B7B77"/>
+                </a:solidFill>
+                <a:latin typeface="Calibri" pitchFamily="34" charset="0"/>
+                <a:ea typeface="Calibri" pitchFamily="34" charset="-122"/>
+                <a:cs typeface="Calibri" pitchFamily="34" charset="-120"/>
+              </a:rPr>
+              <a:t>build KB (regenerable, git-ignored)</a:t>
+            </a:r>
+            <a:endParaRPr lang="en-US" sz="950" dirty="0"/>
+          </a:p>
+        </p:txBody>
+      </p:sp>
+      <p:sp>
+        <p:nvSpPr>
+          <p:cNvPr id="32" name="Shape 30"/>
+          <p:cNvSpPr/>
+          <p:nvPr/>
+        </p:nvSpPr>
+        <p:spPr>
+          <a:xfrm>
+            <a:off x="640080" y="5029200"/>
+            <a:ext cx="7680960" cy="1234440"/>
+          </a:xfrm>
+          <a:prstGeom prst="roundRect">
+            <a:avLst>
+              <a:gd name="adj" fmla="val 5185"/>
+            </a:avLst>
+          </a:prstGeom>
+          <a:solidFill>
+            <a:srgbClr val="F3EEE4"/>
+          </a:solidFill>
+          <a:ln/>
+        </p:spPr>
+      </p:sp>
+      <p:sp>
+        <p:nvSpPr>
+          <p:cNvPr id="33" name="Text 31"/>
+          <p:cNvSpPr txBox="1"/>
+          <p:nvPr/>
+        </p:nvSpPr>
+        <p:spPr>
+          <a:xfrm>
+            <a:off x="868680" y="5138928"/>
+            <a:ext cx="7315200" cy="274320"/>
+          </a:xfrm>
+          <a:prstGeom prst="rect">
+            <a:avLst/>
+          </a:prstGeom>
+          <a:noFill/>
+          <a:ln/>
+        </p:spPr>
+        <p:txBody>
+          <a:bodyPr wrap="square" lIns="0" tIns="0" rIns="0" bIns="0" rtlCol="0" anchor="ctr"/>
+          <a:lstStyle/>
+          <a:p>
+            <a:pPr indent="0" marL="0">
+              <a:buNone/>
+            </a:pPr>
+            <a:r>
+              <a:rPr lang="en-US" sz="1200" b="1" dirty="0">
+                <a:solidFill>
+                  <a:srgbClr val="0E6E63"/>
+                </a:solidFill>
+                <a:latin typeface="Cambria" pitchFamily="34" charset="0"/>
+                <a:ea typeface="Cambria" pitchFamily="34" charset="-122"/>
+                <a:cs typeface="Cambria" pitchFamily="34" charset="-120"/>
+              </a:rPr>
+              <a:t>Entity resolution (between the split and the KB) writes 4 relationship files:</a:t>
+            </a:r>
+            <a:endParaRPr lang="en-US" sz="1200" dirty="0"/>
+          </a:p>
+        </p:txBody>
+      </p:sp>
+      <p:sp>
+        <p:nvSpPr>
+          <p:cNvPr id="34" name="Text 32"/>
+          <p:cNvSpPr txBox="1"/>
+          <p:nvPr/>
+        </p:nvSpPr>
+        <p:spPr>
+          <a:xfrm>
+            <a:off x="868680" y="5440680"/>
+            <a:ext cx="7315200" cy="731520"/>
+          </a:xfrm>
+          <a:prstGeom prst="rect">
+            <a:avLst/>
+          </a:prstGeom>
+          <a:noFill/>
+          <a:ln/>
+        </p:spPr>
+        <p:txBody>
+          <a:bodyPr wrap="square" lIns="0" tIns="0" rIns="0" bIns="0" rtlCol="0" anchor="ctr"/>
+          <a:lstStyle/>
+          <a:p>
+            <a:pPr indent="0" marL="0">
+              <a:lnSpc>
+                <a:spcPct val="115000"/>
+              </a:lnSpc>
+              <a:buNone/>
+            </a:pPr>
+            <a:r>
+              <a:rPr lang="en-US" sz="1100" b="1" dirty="0">
+                <a:solidFill>
+                  <a:srgbClr val="1F2A28"/>
+                </a:solidFill>
+                <a:latin typeface="Calibri" pitchFamily="34" charset="0"/>
+                <a:ea typeface="Calibri" pitchFamily="34" charset="-122"/>
+                <a:cs typeface="Calibri" pitchFamily="34" charset="-120"/>
+              </a:rPr>
+              <a:t>canonical_entities</a:t>
+            </a:r>
+            <a:pPr indent="0" marL="0">
+              <a:lnSpc>
+                <a:spcPct val="115000"/>
+              </a:lnSpc>
+              <a:buNone/>
+            </a:pPr>
+            <a:r>
+              <a:rPr lang="en-US" sz="1100" dirty="0">
+                <a:solidFill>
+                  <a:srgbClr val="6B7B77"/>
+                </a:solidFill>
+                <a:latin typeface="Calibri" pitchFamily="34" charset="0"/>
+                <a:ea typeface="Calibri" pitchFamily="34" charset="-122"/>
+                <a:cs typeface="Calibri" pitchFamily="34" charset="-120"/>
+              </a:rPr>
+              <a:t> (master list)   </a:t>
+            </a:r>
+            <a:pPr indent="0" marL="0">
+              <a:lnSpc>
+                <a:spcPct val="115000"/>
+              </a:lnSpc>
+              <a:buNone/>
+            </a:pPr>
+            <a:r>
+              <a:rPr lang="en-US" sz="1100" b="1" dirty="0">
+                <a:solidFill>
+                  <a:srgbClr val="1F2A28"/>
+                </a:solidFill>
+                <a:latin typeface="Calibri" pitchFamily="34" charset="0"/>
+                <a:ea typeface="Calibri" pitchFamily="34" charset="-122"/>
+                <a:cs typeface="Calibri" pitchFamily="34" charset="-120"/>
+              </a:rPr>
+              <a:t>entity_crosswalk</a:t>
+            </a:r>
+            <a:pPr indent="0" marL="0">
+              <a:lnSpc>
+                <a:spcPct val="115000"/>
+              </a:lnSpc>
+              <a:buNone/>
+            </a:pPr>
+            <a:r>
+              <a:rPr lang="en-US" sz="1100" dirty="0">
+                <a:solidFill>
+                  <a:srgbClr val="6B7B77"/>
+                </a:solidFill>
+                <a:latin typeface="Calibri" pitchFamily="34" charset="0"/>
+                <a:ea typeface="Calibri" pitchFamily="34" charset="-122"/>
+                <a:cs typeface="Calibri" pitchFamily="34" charset="-120"/>
+              </a:rPr>
+              <a:t> (source→canonical join hub)</a:t>
+            </a:r>
+            <a:endParaRPr lang="en-US" sz="1100" dirty="0"/>
+          </a:p>
+          <a:p>
+            <a:pPr indent="0" marL="0">
+              <a:lnSpc>
+                <a:spcPct val="115000"/>
+              </a:lnSpc>
+              <a:buNone/>
+            </a:pPr>
+            <a:r>
+              <a:rPr lang="en-US" sz="1100" b="1" dirty="0">
+                <a:solidFill>
+                  <a:srgbClr val="1F2A28"/>
+                </a:solidFill>
+                <a:latin typeface="Calibri" pitchFamily="34" charset="0"/>
+                <a:ea typeface="Calibri" pitchFamily="34" charset="-122"/>
+                <a:cs typeface="Calibri" pitchFamily="34" charset="-120"/>
+              </a:rPr>
+              <a:t>candidate_links</a:t>
+            </a:r>
+            <a:pPr indent="0" marL="0">
+              <a:lnSpc>
+                <a:spcPct val="115000"/>
+              </a:lnSpc>
+              <a:buNone/>
+            </a:pPr>
+            <a:r>
+              <a:rPr lang="en-US" sz="1100" dirty="0">
+                <a:solidFill>
+                  <a:srgbClr val="6B7B77"/>
+                </a:solidFill>
+                <a:latin typeface="Calibri" pitchFamily="34" charset="0"/>
+                <a:ea typeface="Calibri" pitchFamily="34" charset="-122"/>
+                <a:cs typeface="Calibri" pitchFamily="34" charset="-120"/>
+              </a:rPr>
+              <a:t> (near-matches, not merged)   </a:t>
+            </a:r>
+            <a:pPr indent="0" marL="0">
+              <a:lnSpc>
+                <a:spcPct val="115000"/>
+              </a:lnSpc>
+              <a:buNone/>
+            </a:pPr>
+            <a:r>
+              <a:rPr lang="en-US" sz="1100" b="1" dirty="0">
+                <a:solidFill>
+                  <a:srgbClr val="1F2A28"/>
+                </a:solidFill>
+                <a:latin typeface="Calibri" pitchFamily="34" charset="0"/>
+                <a:ea typeface="Calibri" pitchFamily="34" charset="-122"/>
+                <a:cs typeface="Calibri" pitchFamily="34" charset="-120"/>
+              </a:rPr>
+              <a:t>review_place_links</a:t>
+            </a:r>
+            <a:pPr indent="0" marL="0">
+              <a:lnSpc>
+                <a:spcPct val="115000"/>
+              </a:lnSpc>
+              <a:buNone/>
+            </a:pPr>
+            <a:r>
+              <a:rPr lang="en-US" sz="1100" dirty="0">
+                <a:solidFill>
+                  <a:srgbClr val="6B7B77"/>
+                </a:solidFill>
+                <a:latin typeface="Calibri" pitchFamily="34" charset="0"/>
+                <a:ea typeface="Calibri" pitchFamily="34" charset="-122"/>
+                <a:cs typeface="Calibri" pitchFamily="34" charset="-120"/>
+              </a:rPr>
+              <a:t> (review→place)</a:t>
+            </a:r>
+            <a:endParaRPr lang="en-US" sz="1100" dirty="0"/>
+          </a:p>
+        </p:txBody>
+      </p:sp>
+    </p:spTree>
+  </p:cSld>
+  <p:clrMapOvr>
+    <a:masterClrMapping/>
+  </p:clrMapOvr>
+</p:sld>
+</file>
+
+<file path=ppt/slides/slide11.xml><?xml version="1.0" encoding="utf-8"?>
+<p:sld xmlns:a="http://schemas.openxmlformats.org/drawingml/2006/main" xmlns:r="http://schemas.openxmlformats.org/officeDocument/2006/relationships" xmlns:p="http://schemas.openxmlformats.org/presentationml/2006/main">
+  <p:cSld name="Slide 11">
+    <p:bg>
+      <p:bgPr>
+        <a:solidFill>
           <a:srgbClr val="0B3B36"/>
         </a:solidFill>
       </p:bgPr>
@@ -3308,9 +4780,9 @@
 </p:sld>
 </file>
 
-<file path=ppt/slides/slide11.xml><?xml version="1.0" encoding="utf-8"?>
+<file path=ppt/slides/slide12.xml><?xml version="1.0" encoding="utf-8"?>
 <p:sld xmlns:a="http://schemas.openxmlformats.org/drawingml/2006/main" xmlns:r="http://schemas.openxmlformats.org/officeDocument/2006/relationships" xmlns:p="http://schemas.openxmlformats.org/presentationml/2006/main">
-  <p:cSld name="Slide 11">
+  <p:cSld name="Slide 12">
     <p:bg>
       <p:bgPr>
         <a:solidFill>
@@ -16571,7 +18043,7 @@
         </p:nvSpPr>
         <p:spPr>
           <a:xfrm>
-            <a:off x="640080" y="411480"/>
+            <a:off x="640080" y="320040"/>
             <a:ext cx="10972800" cy="548640"/>
           </a:xfrm>
           <a:prstGeom prst="rect">
@@ -16596,7 +18068,7 @@
                 <a:ea typeface="Cambria" pitchFamily="34" charset="-122"/>
                 <a:cs typeface="Cambria" pitchFamily="34" charset="-120"/>
               </a:rPr>
-              <a:t>The file trail — one café through the pipeline</a:t>
+              <a:t>From raw data to a retrievable knowledge base</a:t>
             </a:r>
             <a:endParaRPr lang="en-US" sz="3000" dirty="0"/>
           </a:p>
@@ -16604,14 +18076,195 @@
       </p:sp>
       <p:sp>
         <p:nvSpPr>
-          <p:cNvPr id="3" name="Text 1"/>
+          <p:cNvPr id="3" name="Shape 1"/>
+          <p:cNvSpPr/>
+          <p:nvPr/>
+        </p:nvSpPr>
+        <p:spPr>
+          <a:xfrm>
+            <a:off x="4539996" y="914400"/>
+            <a:ext cx="3108960" cy="402336"/>
+          </a:xfrm>
+          <a:prstGeom prst="roundRect">
+            <a:avLst>
+              <a:gd name="adj" fmla="val 22727"/>
+            </a:avLst>
+          </a:prstGeom>
+          <a:solidFill>
+            <a:srgbClr val="0B3B36"/>
+          </a:solidFill>
+          <a:ln/>
+        </p:spPr>
+      </p:sp>
+      <p:sp>
+        <p:nvSpPr>
+          <p:cNvPr id="4" name="Text 2"/>
           <p:cNvSpPr txBox="1"/>
           <p:nvPr/>
         </p:nvSpPr>
         <p:spPr>
           <a:xfrm>
-            <a:off x="640080" y="987552"/>
-            <a:ext cx="10972800" cy="320040"/>
+            <a:off x="4539996" y="914400"/>
+            <a:ext cx="3108960" cy="402336"/>
+          </a:xfrm>
+          <a:prstGeom prst="rect">
+            <a:avLst/>
+          </a:prstGeom>
+          <a:noFill/>
+          <a:ln/>
+        </p:spPr>
+        <p:txBody>
+          <a:bodyPr wrap="square" lIns="0" tIns="0" rIns="0" bIns="0" rtlCol="0" anchor="ctr"/>
+          <a:lstStyle/>
+          <a:p>
+            <a:pPr algn="ctr" indent="0" marL="0">
+              <a:buNone/>
+            </a:pPr>
+            <a:r>
+              <a:rPr lang="en-US" sz="1400" b="1" spc="200" kern="0" dirty="0">
+                <a:solidFill>
+                  <a:srgbClr val="FFFFFF"/>
+                </a:solidFill>
+                <a:latin typeface="Cambria" pitchFamily="34" charset="0"/>
+                <a:ea typeface="Cambria" pitchFamily="34" charset="-122"/>
+                <a:cs typeface="Cambria" pitchFamily="34" charset="-120"/>
+              </a:rPr>
+              <a:t>RAW DATA</a:t>
+            </a:r>
+            <a:endParaRPr lang="en-US" sz="1400" dirty="0"/>
+          </a:p>
+        </p:txBody>
+      </p:sp>
+      <p:sp>
+        <p:nvSpPr>
+          <p:cNvPr id="5" name="Text 3"/>
+          <p:cNvSpPr txBox="1"/>
+          <p:nvPr/>
+        </p:nvSpPr>
+        <p:spPr>
+          <a:xfrm>
+            <a:off x="5820156" y="1335024"/>
+            <a:ext cx="548640" cy="274320"/>
+          </a:xfrm>
+          <a:prstGeom prst="rect">
+            <a:avLst/>
+          </a:prstGeom>
+          <a:noFill/>
+          <a:ln/>
+        </p:spPr>
+        <p:txBody>
+          <a:bodyPr wrap="square" lIns="0" tIns="0" rIns="0" bIns="0" rtlCol="0" anchor="ctr"/>
+          <a:lstStyle/>
+          <a:p>
+            <a:pPr algn="ctr" indent="0" marL="0">
+              <a:buNone/>
+            </a:pPr>
+            <a:r>
+              <a:rPr lang="en-US" sz="2000" b="1" dirty="0">
+                <a:solidFill>
+                  <a:srgbClr val="C9A227"/>
+                </a:solidFill>
+                <a:latin typeface="Cambria" pitchFamily="34" charset="0"/>
+                <a:ea typeface="Cambria" pitchFamily="34" charset="-122"/>
+                <a:cs typeface="Cambria" pitchFamily="34" charset="-120"/>
+              </a:rPr>
+              <a:t>↓</a:t>
+            </a:r>
+            <a:endParaRPr lang="en-US" sz="2000" dirty="0"/>
+          </a:p>
+        </p:txBody>
+      </p:sp>
+      <p:sp>
+        <p:nvSpPr>
+          <p:cNvPr id="6" name="Shape 4"/>
+          <p:cNvSpPr/>
+          <p:nvPr/>
+        </p:nvSpPr>
+        <p:spPr>
+          <a:xfrm>
+            <a:off x="3534156" y="1517904"/>
+            <a:ext cx="5120640" cy="512064"/>
+          </a:xfrm>
+          <a:prstGeom prst="roundRect">
+            <a:avLst>
+              <a:gd name="adj" fmla="val 12500"/>
+            </a:avLst>
+          </a:prstGeom>
+          <a:solidFill>
+            <a:srgbClr val="F3EEE4"/>
+          </a:solidFill>
+          <a:ln/>
+        </p:spPr>
+      </p:sp>
+      <p:sp>
+        <p:nvSpPr>
+          <p:cNvPr id="7" name="Shape 5"/>
+          <p:cNvSpPr/>
+          <p:nvPr/>
+        </p:nvSpPr>
+        <p:spPr>
+          <a:xfrm>
+            <a:off x="3680460" y="1581912"/>
+            <a:ext cx="384048" cy="384048"/>
+          </a:xfrm>
+          <a:prstGeom prst="ellipse">
+            <a:avLst/>
+          </a:prstGeom>
+          <a:solidFill>
+            <a:srgbClr val="0E6E63"/>
+          </a:solidFill>
+          <a:ln/>
+        </p:spPr>
+      </p:sp>
+      <p:sp>
+        <p:nvSpPr>
+          <p:cNvPr id="8" name="Text 6"/>
+          <p:cNvSpPr txBox="1"/>
+          <p:nvPr/>
+        </p:nvSpPr>
+        <p:spPr>
+          <a:xfrm>
+            <a:off x="3680460" y="1581912"/>
+            <a:ext cx="384048" cy="384048"/>
+          </a:xfrm>
+          <a:prstGeom prst="rect">
+            <a:avLst/>
+          </a:prstGeom>
+          <a:noFill/>
+          <a:ln/>
+        </p:spPr>
+        <p:txBody>
+          <a:bodyPr wrap="square" lIns="0" tIns="0" rIns="0" bIns="0" rtlCol="0" anchor="ctr"/>
+          <a:lstStyle/>
+          <a:p>
+            <a:pPr algn="ctr" indent="0" marL="0">
+              <a:buNone/>
+            </a:pPr>
+            <a:r>
+              <a:rPr lang="en-US" sz="1800" b="1" dirty="0">
+                <a:solidFill>
+                  <a:srgbClr val="FFFFFF"/>
+                </a:solidFill>
+                <a:latin typeface="Cambria" pitchFamily="34" charset="0"/>
+                <a:ea typeface="Cambria" pitchFamily="34" charset="-122"/>
+                <a:cs typeface="Cambria" pitchFamily="34" charset="-120"/>
+              </a:rPr>
+              <a:t>1</a:t>
+            </a:r>
+            <a:endParaRPr lang="en-US" sz="1800" dirty="0"/>
+          </a:p>
+        </p:txBody>
+      </p:sp>
+      <p:sp>
+        <p:nvSpPr>
+          <p:cNvPr id="9" name="Text 7"/>
+          <p:cNvSpPr txBox="1"/>
+          <p:nvPr/>
+        </p:nvSpPr>
+        <p:spPr>
+          <a:xfrm>
+            <a:off x="4219956" y="1563624"/>
+            <a:ext cx="4297680" cy="256032"/>
           </a:xfrm>
           <a:prstGeom prst="rect">
             <a:avLst/>
@@ -16627,7 +18280,46 @@
               <a:buNone/>
             </a:pPr>
             <a:r>
-              <a:rPr lang="en-US" sz="1400" i="1" dirty="0">
+              <a:rPr lang="en-US" sz="1400" b="1" dirty="0">
+                <a:solidFill>
+                  <a:srgbClr val="1F2A28"/>
+                </a:solidFill>
+                <a:latin typeface="Cambria" pitchFamily="34" charset="0"/>
+                <a:ea typeface="Cambria" pitchFamily="34" charset="-122"/>
+                <a:cs typeface="Cambria" pitchFamily="34" charset="-120"/>
+              </a:rPr>
+              <a:t>Quality Assessment</a:t>
+            </a:r>
+            <a:endParaRPr lang="en-US" sz="1400" dirty="0"/>
+          </a:p>
+        </p:txBody>
+      </p:sp>
+      <p:sp>
+        <p:nvSpPr>
+          <p:cNvPr id="10" name="Text 8"/>
+          <p:cNvSpPr txBox="1"/>
+          <p:nvPr/>
+        </p:nvSpPr>
+        <p:spPr>
+          <a:xfrm>
+            <a:off x="4219956" y="1792224"/>
+            <a:ext cx="4297680" cy="219456"/>
+          </a:xfrm>
+          <a:prstGeom prst="rect">
+            <a:avLst/>
+          </a:prstGeom>
+          <a:noFill/>
+          <a:ln/>
+        </p:spPr>
+        <p:txBody>
+          <a:bodyPr wrap="square" lIns="0" tIns="0" rIns="0" bIns="0" rtlCol="0" anchor="ctr"/>
+          <a:lstStyle/>
+          <a:p>
+            <a:pPr indent="0" marL="0">
+              <a:buNone/>
+            </a:pPr>
+            <a:r>
+              <a:rPr lang="en-US" sz="1100" i="1" dirty="0">
                 <a:solidFill>
                   <a:srgbClr val="6B7B77"/>
                 </a:solidFill>
@@ -16635,26 +18327,65 @@
                 <a:ea typeface="Calibri" pitchFamily="34" charset="-122"/>
                 <a:cs typeface="Calibri" pitchFamily="34" charset="-120"/>
               </a:rPr>
-              <a:t>Each stage writes its own file; standardization splits into two shapes — one per half of the hybrid KB.</a:t>
-            </a:r>
-            <a:endParaRPr lang="en-US" sz="1400" dirty="0"/>
-          </a:p>
-        </p:txBody>
-      </p:sp>
-      <p:sp>
-        <p:nvSpPr>
-          <p:cNvPr id="4" name="Shape 2"/>
+              <a:t>"What problems are here?"</a:t>
+            </a:r>
+            <a:endParaRPr lang="en-US" sz="1100" dirty="0"/>
+          </a:p>
+        </p:txBody>
+      </p:sp>
+      <p:sp>
+        <p:nvSpPr>
+          <p:cNvPr id="11" name="Text 9"/>
+          <p:cNvSpPr txBox="1"/>
+          <p:nvPr/>
+        </p:nvSpPr>
+        <p:spPr>
+          <a:xfrm>
+            <a:off x="5820156" y="2048256"/>
+            <a:ext cx="548640" cy="274320"/>
+          </a:xfrm>
+          <a:prstGeom prst="rect">
+            <a:avLst/>
+          </a:prstGeom>
+          <a:noFill/>
+          <a:ln/>
+        </p:spPr>
+        <p:txBody>
+          <a:bodyPr wrap="square" lIns="0" tIns="0" rIns="0" bIns="0" rtlCol="0" anchor="ctr"/>
+          <a:lstStyle/>
+          <a:p>
+            <a:pPr algn="ctr" indent="0" marL="0">
+              <a:buNone/>
+            </a:pPr>
+            <a:r>
+              <a:rPr lang="en-US" sz="2000" b="1" dirty="0">
+                <a:solidFill>
+                  <a:srgbClr val="C9A227"/>
+                </a:solidFill>
+                <a:latin typeface="Cambria" pitchFamily="34" charset="0"/>
+                <a:ea typeface="Cambria" pitchFamily="34" charset="-122"/>
+                <a:cs typeface="Cambria" pitchFamily="34" charset="-120"/>
+              </a:rPr>
+              <a:t>↓</a:t>
+            </a:r>
+            <a:endParaRPr lang="en-US" sz="2000" dirty="0"/>
+          </a:p>
+        </p:txBody>
+      </p:sp>
+      <p:sp>
+        <p:nvSpPr>
+          <p:cNvPr id="12" name="Shape 10"/>
           <p:cNvSpPr/>
           <p:nvPr/>
         </p:nvSpPr>
         <p:spPr>
           <a:xfrm>
-            <a:off x="2743200" y="1417320"/>
-            <a:ext cx="3566160" cy="749808"/>
+            <a:off x="3534156" y="2176272"/>
+            <a:ext cx="5120640" cy="512064"/>
           </a:xfrm>
           <a:prstGeom prst="roundRect">
             <a:avLst>
-              <a:gd name="adj" fmla="val 7317"/>
+              <a:gd name="adj" fmla="val 12500"/>
             </a:avLst>
           </a:prstGeom>
           <a:solidFill>
@@ -16665,14 +18396,73 @@
       </p:sp>
       <p:sp>
         <p:nvSpPr>
-          <p:cNvPr id="5" name="Text 3"/>
+          <p:cNvPr id="13" name="Shape 11"/>
+          <p:cNvSpPr/>
+          <p:nvPr/>
+        </p:nvSpPr>
+        <p:spPr>
+          <a:xfrm>
+            <a:off x="3680460" y="2240280"/>
+            <a:ext cx="384048" cy="384048"/>
+          </a:xfrm>
+          <a:prstGeom prst="ellipse">
+            <a:avLst/>
+          </a:prstGeom>
+          <a:solidFill>
+            <a:srgbClr val="0E6E63"/>
+          </a:solidFill>
+          <a:ln/>
+        </p:spPr>
+      </p:sp>
+      <p:sp>
+        <p:nvSpPr>
+          <p:cNvPr id="14" name="Text 12"/>
           <p:cNvSpPr txBox="1"/>
           <p:nvPr/>
         </p:nvSpPr>
         <p:spPr>
           <a:xfrm>
-            <a:off x="2907792" y="1527048"/>
-            <a:ext cx="3273552" cy="274320"/>
+            <a:off x="3680460" y="2240280"/>
+            <a:ext cx="384048" cy="384048"/>
+          </a:xfrm>
+          <a:prstGeom prst="rect">
+            <a:avLst/>
+          </a:prstGeom>
+          <a:noFill/>
+          <a:ln/>
+        </p:spPr>
+        <p:txBody>
+          <a:bodyPr wrap="square" lIns="0" tIns="0" rIns="0" bIns="0" rtlCol="0" anchor="ctr"/>
+          <a:lstStyle/>
+          <a:p>
+            <a:pPr algn="ctr" indent="0" marL="0">
+              <a:buNone/>
+            </a:pPr>
+            <a:r>
+              <a:rPr lang="en-US" sz="1800" b="1" dirty="0">
+                <a:solidFill>
+                  <a:srgbClr val="FFFFFF"/>
+                </a:solidFill>
+                <a:latin typeface="Cambria" pitchFamily="34" charset="0"/>
+                <a:ea typeface="Cambria" pitchFamily="34" charset="-122"/>
+                <a:cs typeface="Cambria" pitchFamily="34" charset="-120"/>
+              </a:rPr>
+              <a:t>2</a:t>
+            </a:r>
+            <a:endParaRPr lang="en-US" sz="1800" dirty="0"/>
+          </a:p>
+        </p:txBody>
+      </p:sp>
+      <p:sp>
+        <p:nvSpPr>
+          <p:cNvPr id="15" name="Text 13"/>
+          <p:cNvSpPr txBox="1"/>
+          <p:nvPr/>
+        </p:nvSpPr>
+        <p:spPr>
+          <a:xfrm>
+            <a:off x="4219956" y="2221992"/>
+            <a:ext cx="4297680" cy="256032"/>
           </a:xfrm>
           <a:prstGeom prst="rect">
             <a:avLst/>
@@ -16688,7 +18478,832 @@
               <a:buNone/>
             </a:pPr>
             <a:r>
-              <a:rPr lang="en-US" sz="1150" b="1" dirty="0">
+              <a:rPr lang="en-US" sz="1400" b="1" dirty="0">
+                <a:solidFill>
+                  <a:srgbClr val="1F2A28"/>
+                </a:solidFill>
+                <a:latin typeface="Cambria" pitchFamily="34" charset="0"/>
+                <a:ea typeface="Cambria" pitchFamily="34" charset="-122"/>
+                <a:cs typeface="Cambria" pitchFamily="34" charset="-120"/>
+              </a:rPr>
+              <a:t>Cleaning</a:t>
+            </a:r>
+            <a:endParaRPr lang="en-US" sz="1400" dirty="0"/>
+          </a:p>
+        </p:txBody>
+      </p:sp>
+      <p:sp>
+        <p:nvSpPr>
+          <p:cNvPr id="16" name="Text 14"/>
+          <p:cNvSpPr txBox="1"/>
+          <p:nvPr/>
+        </p:nvSpPr>
+        <p:spPr>
+          <a:xfrm>
+            <a:off x="4219956" y="2450592"/>
+            <a:ext cx="4297680" cy="219456"/>
+          </a:xfrm>
+          <a:prstGeom prst="rect">
+            <a:avLst/>
+          </a:prstGeom>
+          <a:noFill/>
+          <a:ln/>
+        </p:spPr>
+        <p:txBody>
+          <a:bodyPr wrap="square" lIns="0" tIns="0" rIns="0" bIns="0" rtlCol="0" anchor="ctr"/>
+          <a:lstStyle/>
+          <a:p>
+            <a:pPr indent="0" marL="0">
+              <a:buNone/>
+            </a:pPr>
+            <a:r>
+              <a:rPr lang="en-US" sz="1100" i="1" dirty="0">
+                <a:solidFill>
+                  <a:srgbClr val="6B7B77"/>
+                </a:solidFill>
+                <a:latin typeface="Calibri" pitchFamily="34" charset="0"/>
+                <a:ea typeface="Calibri" pitchFamily="34" charset="-122"/>
+                <a:cs typeface="Calibri" pitchFamily="34" charset="-120"/>
+              </a:rPr>
+              <a:t>"Fix the problems."</a:t>
+            </a:r>
+            <a:endParaRPr lang="en-US" sz="1100" dirty="0"/>
+          </a:p>
+        </p:txBody>
+      </p:sp>
+      <p:sp>
+        <p:nvSpPr>
+          <p:cNvPr id="17" name="Text 15"/>
+          <p:cNvSpPr txBox="1"/>
+          <p:nvPr/>
+        </p:nvSpPr>
+        <p:spPr>
+          <a:xfrm>
+            <a:off x="5820156" y="2706624"/>
+            <a:ext cx="548640" cy="274320"/>
+          </a:xfrm>
+          <a:prstGeom prst="rect">
+            <a:avLst/>
+          </a:prstGeom>
+          <a:noFill/>
+          <a:ln/>
+        </p:spPr>
+        <p:txBody>
+          <a:bodyPr wrap="square" lIns="0" tIns="0" rIns="0" bIns="0" rtlCol="0" anchor="ctr"/>
+          <a:lstStyle/>
+          <a:p>
+            <a:pPr algn="ctr" indent="0" marL="0">
+              <a:buNone/>
+            </a:pPr>
+            <a:r>
+              <a:rPr lang="en-US" sz="2000" b="1" dirty="0">
+                <a:solidFill>
+                  <a:srgbClr val="C9A227"/>
+                </a:solidFill>
+                <a:latin typeface="Cambria" pitchFamily="34" charset="0"/>
+                <a:ea typeface="Cambria" pitchFamily="34" charset="-122"/>
+                <a:cs typeface="Cambria" pitchFamily="34" charset="-120"/>
+              </a:rPr>
+              <a:t>↓</a:t>
+            </a:r>
+            <a:endParaRPr lang="en-US" sz="2000" dirty="0"/>
+          </a:p>
+        </p:txBody>
+      </p:sp>
+      <p:sp>
+        <p:nvSpPr>
+          <p:cNvPr id="18" name="Shape 16"/>
+          <p:cNvSpPr/>
+          <p:nvPr/>
+        </p:nvSpPr>
+        <p:spPr>
+          <a:xfrm>
+            <a:off x="3534156" y="2834640"/>
+            <a:ext cx="5120640" cy="512064"/>
+          </a:xfrm>
+          <a:prstGeom prst="roundRect">
+            <a:avLst>
+              <a:gd name="adj" fmla="val 12500"/>
+            </a:avLst>
+          </a:prstGeom>
+          <a:solidFill>
+            <a:srgbClr val="F3EEE4"/>
+          </a:solidFill>
+          <a:ln/>
+        </p:spPr>
+      </p:sp>
+      <p:sp>
+        <p:nvSpPr>
+          <p:cNvPr id="19" name="Shape 17"/>
+          <p:cNvSpPr/>
+          <p:nvPr/>
+        </p:nvSpPr>
+        <p:spPr>
+          <a:xfrm>
+            <a:off x="3680460" y="2898648"/>
+            <a:ext cx="384048" cy="384048"/>
+          </a:xfrm>
+          <a:prstGeom prst="ellipse">
+            <a:avLst/>
+          </a:prstGeom>
+          <a:solidFill>
+            <a:srgbClr val="0E6E63"/>
+          </a:solidFill>
+          <a:ln/>
+        </p:spPr>
+      </p:sp>
+      <p:sp>
+        <p:nvSpPr>
+          <p:cNvPr id="20" name="Text 18"/>
+          <p:cNvSpPr txBox="1"/>
+          <p:nvPr/>
+        </p:nvSpPr>
+        <p:spPr>
+          <a:xfrm>
+            <a:off x="3680460" y="2898648"/>
+            <a:ext cx="384048" cy="384048"/>
+          </a:xfrm>
+          <a:prstGeom prst="rect">
+            <a:avLst/>
+          </a:prstGeom>
+          <a:noFill/>
+          <a:ln/>
+        </p:spPr>
+        <p:txBody>
+          <a:bodyPr wrap="square" lIns="0" tIns="0" rIns="0" bIns="0" rtlCol="0" anchor="ctr"/>
+          <a:lstStyle/>
+          <a:p>
+            <a:pPr algn="ctr" indent="0" marL="0">
+              <a:buNone/>
+            </a:pPr>
+            <a:r>
+              <a:rPr lang="en-US" sz="1800" b="1" dirty="0">
+                <a:solidFill>
+                  <a:srgbClr val="FFFFFF"/>
+                </a:solidFill>
+                <a:latin typeface="Cambria" pitchFamily="34" charset="0"/>
+                <a:ea typeface="Cambria" pitchFamily="34" charset="-122"/>
+                <a:cs typeface="Cambria" pitchFamily="34" charset="-120"/>
+              </a:rPr>
+              <a:t>3</a:t>
+            </a:r>
+            <a:endParaRPr lang="en-US" sz="1800" dirty="0"/>
+          </a:p>
+        </p:txBody>
+      </p:sp>
+      <p:sp>
+        <p:nvSpPr>
+          <p:cNvPr id="21" name="Text 19"/>
+          <p:cNvSpPr txBox="1"/>
+          <p:nvPr/>
+        </p:nvSpPr>
+        <p:spPr>
+          <a:xfrm>
+            <a:off x="4219956" y="2880360"/>
+            <a:ext cx="4297680" cy="256032"/>
+          </a:xfrm>
+          <a:prstGeom prst="rect">
+            <a:avLst/>
+          </a:prstGeom>
+          <a:noFill/>
+          <a:ln/>
+        </p:spPr>
+        <p:txBody>
+          <a:bodyPr wrap="square" lIns="0" tIns="0" rIns="0" bIns="0" rtlCol="0" anchor="ctr"/>
+          <a:lstStyle/>
+          <a:p>
+            <a:pPr indent="0" marL="0">
+              <a:buNone/>
+            </a:pPr>
+            <a:r>
+              <a:rPr lang="en-US" sz="1400" b="1" dirty="0">
+                <a:solidFill>
+                  <a:srgbClr val="1F2A28"/>
+                </a:solidFill>
+                <a:latin typeface="Cambria" pitchFamily="34" charset="0"/>
+                <a:ea typeface="Cambria" pitchFamily="34" charset="-122"/>
+                <a:cs typeface="Cambria" pitchFamily="34" charset="-120"/>
+              </a:rPr>
+              <a:t>Standardization</a:t>
+            </a:r>
+            <a:endParaRPr lang="en-US" sz="1400" dirty="0"/>
+          </a:p>
+        </p:txBody>
+      </p:sp>
+      <p:sp>
+        <p:nvSpPr>
+          <p:cNvPr id="22" name="Text 20"/>
+          <p:cNvSpPr txBox="1"/>
+          <p:nvPr/>
+        </p:nvSpPr>
+        <p:spPr>
+          <a:xfrm>
+            <a:off x="4219956" y="3108960"/>
+            <a:ext cx="4297680" cy="219456"/>
+          </a:xfrm>
+          <a:prstGeom prst="rect">
+            <a:avLst/>
+          </a:prstGeom>
+          <a:noFill/>
+          <a:ln/>
+        </p:spPr>
+        <p:txBody>
+          <a:bodyPr wrap="square" lIns="0" tIns="0" rIns="0" bIns="0" rtlCol="0" anchor="ctr"/>
+          <a:lstStyle/>
+          <a:p>
+            <a:pPr indent="0" marL="0">
+              <a:buNone/>
+            </a:pPr>
+            <a:r>
+              <a:rPr lang="en-US" sz="1100" i="1" dirty="0">
+                <a:solidFill>
+                  <a:srgbClr val="6B7B77"/>
+                </a:solidFill>
+                <a:latin typeface="Calibri" pitchFamily="34" charset="0"/>
+                <a:ea typeface="Calibri" pitchFamily="34" charset="-122"/>
+                <a:cs typeface="Calibri" pitchFamily="34" charset="-120"/>
+              </a:rPr>
+              <a:t>"Make all datasets use compatible structures."</a:t>
+            </a:r>
+            <a:endParaRPr lang="en-US" sz="1100" dirty="0"/>
+          </a:p>
+        </p:txBody>
+      </p:sp>
+      <p:sp>
+        <p:nvSpPr>
+          <p:cNvPr id="23" name="Text 21"/>
+          <p:cNvSpPr txBox="1"/>
+          <p:nvPr/>
+        </p:nvSpPr>
+        <p:spPr>
+          <a:xfrm>
+            <a:off x="5820156" y="3364992"/>
+            <a:ext cx="548640" cy="274320"/>
+          </a:xfrm>
+          <a:prstGeom prst="rect">
+            <a:avLst/>
+          </a:prstGeom>
+          <a:noFill/>
+          <a:ln/>
+        </p:spPr>
+        <p:txBody>
+          <a:bodyPr wrap="square" lIns="0" tIns="0" rIns="0" bIns="0" rtlCol="0" anchor="ctr"/>
+          <a:lstStyle/>
+          <a:p>
+            <a:pPr algn="ctr" indent="0" marL="0">
+              <a:buNone/>
+            </a:pPr>
+            <a:r>
+              <a:rPr lang="en-US" sz="2000" b="1" dirty="0">
+                <a:solidFill>
+                  <a:srgbClr val="C9A227"/>
+                </a:solidFill>
+                <a:latin typeface="Cambria" pitchFamily="34" charset="0"/>
+                <a:ea typeface="Cambria" pitchFamily="34" charset="-122"/>
+                <a:cs typeface="Cambria" pitchFamily="34" charset="-120"/>
+              </a:rPr>
+              <a:t>↓</a:t>
+            </a:r>
+            <a:endParaRPr lang="en-US" sz="2000" dirty="0"/>
+          </a:p>
+        </p:txBody>
+      </p:sp>
+      <p:sp>
+        <p:nvSpPr>
+          <p:cNvPr id="24" name="Shape 22"/>
+          <p:cNvSpPr/>
+          <p:nvPr/>
+        </p:nvSpPr>
+        <p:spPr>
+          <a:xfrm>
+            <a:off x="3534156" y="3493008"/>
+            <a:ext cx="5120640" cy="512064"/>
+          </a:xfrm>
+          <a:prstGeom prst="roundRect">
+            <a:avLst>
+              <a:gd name="adj" fmla="val 12500"/>
+            </a:avLst>
+          </a:prstGeom>
+          <a:solidFill>
+            <a:srgbClr val="F3EEE4"/>
+          </a:solidFill>
+          <a:ln/>
+        </p:spPr>
+      </p:sp>
+      <p:sp>
+        <p:nvSpPr>
+          <p:cNvPr id="25" name="Shape 23"/>
+          <p:cNvSpPr/>
+          <p:nvPr/>
+        </p:nvSpPr>
+        <p:spPr>
+          <a:xfrm>
+            <a:off x="3680460" y="3557016"/>
+            <a:ext cx="384048" cy="384048"/>
+          </a:xfrm>
+          <a:prstGeom prst="ellipse">
+            <a:avLst/>
+          </a:prstGeom>
+          <a:solidFill>
+            <a:srgbClr val="0E6E63"/>
+          </a:solidFill>
+          <a:ln/>
+        </p:spPr>
+      </p:sp>
+      <p:sp>
+        <p:nvSpPr>
+          <p:cNvPr id="26" name="Text 24"/>
+          <p:cNvSpPr txBox="1"/>
+          <p:nvPr/>
+        </p:nvSpPr>
+        <p:spPr>
+          <a:xfrm>
+            <a:off x="3680460" y="3557016"/>
+            <a:ext cx="384048" cy="384048"/>
+          </a:xfrm>
+          <a:prstGeom prst="rect">
+            <a:avLst/>
+          </a:prstGeom>
+          <a:noFill/>
+          <a:ln/>
+        </p:spPr>
+        <p:txBody>
+          <a:bodyPr wrap="square" lIns="0" tIns="0" rIns="0" bIns="0" rtlCol="0" anchor="ctr"/>
+          <a:lstStyle/>
+          <a:p>
+            <a:pPr algn="ctr" indent="0" marL="0">
+              <a:buNone/>
+            </a:pPr>
+            <a:r>
+              <a:rPr lang="en-US" sz="1800" b="1" dirty="0">
+                <a:solidFill>
+                  <a:srgbClr val="FFFFFF"/>
+                </a:solidFill>
+                <a:latin typeface="Cambria" pitchFamily="34" charset="0"/>
+                <a:ea typeface="Cambria" pitchFamily="34" charset="-122"/>
+                <a:cs typeface="Cambria" pitchFamily="34" charset="-120"/>
+              </a:rPr>
+              <a:t>4</a:t>
+            </a:r>
+            <a:endParaRPr lang="en-US" sz="1800" dirty="0"/>
+          </a:p>
+        </p:txBody>
+      </p:sp>
+      <p:sp>
+        <p:nvSpPr>
+          <p:cNvPr id="27" name="Text 25"/>
+          <p:cNvSpPr txBox="1"/>
+          <p:nvPr/>
+        </p:nvSpPr>
+        <p:spPr>
+          <a:xfrm>
+            <a:off x="4219956" y="3538728"/>
+            <a:ext cx="4297680" cy="256032"/>
+          </a:xfrm>
+          <a:prstGeom prst="rect">
+            <a:avLst/>
+          </a:prstGeom>
+          <a:noFill/>
+          <a:ln/>
+        </p:spPr>
+        <p:txBody>
+          <a:bodyPr wrap="square" lIns="0" tIns="0" rIns="0" bIns="0" rtlCol="0" anchor="ctr"/>
+          <a:lstStyle/>
+          <a:p>
+            <a:pPr indent="0" marL="0">
+              <a:buNone/>
+            </a:pPr>
+            <a:r>
+              <a:rPr lang="en-US" sz="1400" b="1" dirty="0">
+                <a:solidFill>
+                  <a:srgbClr val="1F2A28"/>
+                </a:solidFill>
+                <a:latin typeface="Cambria" pitchFamily="34" charset="0"/>
+                <a:ea typeface="Cambria" pitchFamily="34" charset="-122"/>
+                <a:cs typeface="Cambria" pitchFamily="34" charset="-120"/>
+              </a:rPr>
+              <a:t>Entity Resolution</a:t>
+            </a:r>
+            <a:endParaRPr lang="en-US" sz="1400" dirty="0"/>
+          </a:p>
+        </p:txBody>
+      </p:sp>
+      <p:sp>
+        <p:nvSpPr>
+          <p:cNvPr id="28" name="Text 26"/>
+          <p:cNvSpPr txBox="1"/>
+          <p:nvPr/>
+        </p:nvSpPr>
+        <p:spPr>
+          <a:xfrm>
+            <a:off x="4219956" y="3767328"/>
+            <a:ext cx="4297680" cy="219456"/>
+          </a:xfrm>
+          <a:prstGeom prst="rect">
+            <a:avLst/>
+          </a:prstGeom>
+          <a:noFill/>
+          <a:ln/>
+        </p:spPr>
+        <p:txBody>
+          <a:bodyPr wrap="square" lIns="0" tIns="0" rIns="0" bIns="0" rtlCol="0" anchor="ctr"/>
+          <a:lstStyle/>
+          <a:p>
+            <a:pPr indent="0" marL="0">
+              <a:buNone/>
+            </a:pPr>
+            <a:r>
+              <a:rPr lang="en-US" sz="1100" i="1" dirty="0">
+                <a:solidFill>
+                  <a:srgbClr val="6B7B77"/>
+                </a:solidFill>
+                <a:latin typeface="Calibri" pitchFamily="34" charset="0"/>
+                <a:ea typeface="Calibri" pitchFamily="34" charset="-122"/>
+                <a:cs typeface="Calibri" pitchFamily="34" charset="-120"/>
+              </a:rPr>
+              <a:t>"Which records refer to the same real-world thing?"</a:t>
+            </a:r>
+            <a:endParaRPr lang="en-US" sz="1100" dirty="0"/>
+          </a:p>
+        </p:txBody>
+      </p:sp>
+      <p:sp>
+        <p:nvSpPr>
+          <p:cNvPr id="29" name="Text 27"/>
+          <p:cNvSpPr txBox="1"/>
+          <p:nvPr/>
+        </p:nvSpPr>
+        <p:spPr>
+          <a:xfrm>
+            <a:off x="5820156" y="4023360"/>
+            <a:ext cx="548640" cy="274320"/>
+          </a:xfrm>
+          <a:prstGeom prst="rect">
+            <a:avLst/>
+          </a:prstGeom>
+          <a:noFill/>
+          <a:ln/>
+        </p:spPr>
+        <p:txBody>
+          <a:bodyPr wrap="square" lIns="0" tIns="0" rIns="0" bIns="0" rtlCol="0" anchor="ctr"/>
+          <a:lstStyle/>
+          <a:p>
+            <a:pPr algn="ctr" indent="0" marL="0">
+              <a:buNone/>
+            </a:pPr>
+            <a:r>
+              <a:rPr lang="en-US" sz="2000" b="1" dirty="0">
+                <a:solidFill>
+                  <a:srgbClr val="C9A227"/>
+                </a:solidFill>
+                <a:latin typeface="Cambria" pitchFamily="34" charset="0"/>
+                <a:ea typeface="Cambria" pitchFamily="34" charset="-122"/>
+                <a:cs typeface="Cambria" pitchFamily="34" charset="-120"/>
+              </a:rPr>
+              <a:t>↓</a:t>
+            </a:r>
+            <a:endParaRPr lang="en-US" sz="2000" dirty="0"/>
+          </a:p>
+        </p:txBody>
+      </p:sp>
+      <p:sp>
+        <p:nvSpPr>
+          <p:cNvPr id="30" name="Shape 28"/>
+          <p:cNvSpPr/>
+          <p:nvPr/>
+        </p:nvSpPr>
+        <p:spPr>
+          <a:xfrm>
+            <a:off x="3534156" y="4151376"/>
+            <a:ext cx="5120640" cy="512064"/>
+          </a:xfrm>
+          <a:prstGeom prst="roundRect">
+            <a:avLst>
+              <a:gd name="adj" fmla="val 12500"/>
+            </a:avLst>
+          </a:prstGeom>
+          <a:solidFill>
+            <a:srgbClr val="0E6E63"/>
+          </a:solidFill>
+          <a:ln/>
+        </p:spPr>
+      </p:sp>
+      <p:sp>
+        <p:nvSpPr>
+          <p:cNvPr id="31" name="Shape 29"/>
+          <p:cNvSpPr/>
+          <p:nvPr/>
+        </p:nvSpPr>
+        <p:spPr>
+          <a:xfrm>
+            <a:off x="3680460" y="4215384"/>
+            <a:ext cx="384048" cy="384048"/>
+          </a:xfrm>
+          <a:prstGeom prst="ellipse">
+            <a:avLst/>
+          </a:prstGeom>
+          <a:solidFill>
+            <a:srgbClr val="C9A227"/>
+          </a:solidFill>
+          <a:ln/>
+        </p:spPr>
+      </p:sp>
+      <p:sp>
+        <p:nvSpPr>
+          <p:cNvPr id="32" name="Text 30"/>
+          <p:cNvSpPr txBox="1"/>
+          <p:nvPr/>
+        </p:nvSpPr>
+        <p:spPr>
+          <a:xfrm>
+            <a:off x="3680460" y="4215384"/>
+            <a:ext cx="384048" cy="384048"/>
+          </a:xfrm>
+          <a:prstGeom prst="rect">
+            <a:avLst/>
+          </a:prstGeom>
+          <a:noFill/>
+          <a:ln/>
+        </p:spPr>
+        <p:txBody>
+          <a:bodyPr wrap="square" lIns="0" tIns="0" rIns="0" bIns="0" rtlCol="0" anchor="ctr"/>
+          <a:lstStyle/>
+          <a:p>
+            <a:pPr algn="ctr" indent="0" marL="0">
+              <a:buNone/>
+            </a:pPr>
+            <a:r>
+              <a:rPr lang="en-US" sz="1800" b="1" dirty="0">
+                <a:solidFill>
+                  <a:srgbClr val="0B3B36"/>
+                </a:solidFill>
+                <a:latin typeface="Cambria" pitchFamily="34" charset="0"/>
+                <a:ea typeface="Cambria" pitchFamily="34" charset="-122"/>
+                <a:cs typeface="Cambria" pitchFamily="34" charset="-120"/>
+              </a:rPr>
+              <a:t>5</a:t>
+            </a:r>
+            <a:endParaRPr lang="en-US" sz="1800" dirty="0"/>
+          </a:p>
+        </p:txBody>
+      </p:sp>
+      <p:sp>
+        <p:nvSpPr>
+          <p:cNvPr id="33" name="Text 31"/>
+          <p:cNvSpPr txBox="1"/>
+          <p:nvPr/>
+        </p:nvSpPr>
+        <p:spPr>
+          <a:xfrm>
+            <a:off x="4219956" y="4197096"/>
+            <a:ext cx="4297680" cy="256032"/>
+          </a:xfrm>
+          <a:prstGeom prst="rect">
+            <a:avLst/>
+          </a:prstGeom>
+          <a:noFill/>
+          <a:ln/>
+        </p:spPr>
+        <p:txBody>
+          <a:bodyPr wrap="square" lIns="0" tIns="0" rIns="0" bIns="0" rtlCol="0" anchor="ctr"/>
+          <a:lstStyle/>
+          <a:p>
+            <a:pPr indent="0" marL="0">
+              <a:buNone/>
+            </a:pPr>
+            <a:r>
+              <a:rPr lang="en-US" sz="1400" b="1" dirty="0">
+                <a:solidFill>
+                  <a:srgbClr val="FFFFFF"/>
+                </a:solidFill>
+                <a:latin typeface="Cambria" pitchFamily="34" charset="0"/>
+                <a:ea typeface="Cambria" pitchFamily="34" charset="-122"/>
+                <a:cs typeface="Cambria" pitchFamily="34" charset="-120"/>
+              </a:rPr>
+              <a:t>Knowledge Base</a:t>
+            </a:r>
+            <a:endParaRPr lang="en-US" sz="1400" dirty="0"/>
+          </a:p>
+        </p:txBody>
+      </p:sp>
+      <p:sp>
+        <p:nvSpPr>
+          <p:cNvPr id="34" name="Text 32"/>
+          <p:cNvSpPr txBox="1"/>
+          <p:nvPr/>
+        </p:nvSpPr>
+        <p:spPr>
+          <a:xfrm>
+            <a:off x="4219956" y="4425696"/>
+            <a:ext cx="4297680" cy="219456"/>
+          </a:xfrm>
+          <a:prstGeom prst="rect">
+            <a:avLst/>
+          </a:prstGeom>
+          <a:noFill/>
+          <a:ln/>
+        </p:spPr>
+        <p:txBody>
+          <a:bodyPr wrap="square" lIns="0" tIns="0" rIns="0" bIns="0" rtlCol="0" anchor="ctr"/>
+          <a:lstStyle/>
+          <a:p>
+            <a:pPr indent="0" marL="0">
+              <a:buNone/>
+            </a:pPr>
+            <a:r>
+              <a:rPr lang="en-US" sz="1100" i="1" dirty="0">
+                <a:solidFill>
+                  <a:srgbClr val="E8F3F0"/>
+                </a:solidFill>
+                <a:latin typeface="Calibri" pitchFamily="34" charset="0"/>
+                <a:ea typeface="Calibri" pitchFamily="34" charset="-122"/>
+                <a:cs typeface="Calibri" pitchFamily="34" charset="-120"/>
+              </a:rPr>
+              <a:t>"Store it so the AI can retrieve it."</a:t>
+            </a:r>
+            <a:endParaRPr lang="en-US" sz="1100" dirty="0"/>
+          </a:p>
+        </p:txBody>
+      </p:sp>
+      <p:sp>
+        <p:nvSpPr>
+          <p:cNvPr id="35" name="Shape 33"/>
+          <p:cNvSpPr/>
+          <p:nvPr/>
+        </p:nvSpPr>
+        <p:spPr>
+          <a:xfrm>
+            <a:off x="6094476" y="4663440"/>
+            <a:ext cx="0" cy="146304"/>
+          </a:xfrm>
+          <a:prstGeom prst="line">
+            <a:avLst/>
+          </a:prstGeom>
+          <a:noFill/>
+          <a:ln w="25400">
+            <a:solidFill>
+              <a:srgbClr val="C9A227"/>
+            </a:solidFill>
+            <a:prstDash val="solid"/>
+          </a:ln>
+        </p:spPr>
+      </p:sp>
+      <p:sp>
+        <p:nvSpPr>
+          <p:cNvPr id="36" name="Shape 34"/>
+          <p:cNvSpPr/>
+          <p:nvPr/>
+        </p:nvSpPr>
+        <p:spPr>
+          <a:xfrm>
+            <a:off x="3794760" y="4809744"/>
+            <a:ext cx="4572000" cy="0"/>
+          </a:xfrm>
+          <a:prstGeom prst="line">
+            <a:avLst/>
+          </a:prstGeom>
+          <a:noFill/>
+          <a:ln w="25400">
+            <a:solidFill>
+              <a:srgbClr val="C9A227"/>
+            </a:solidFill>
+            <a:prstDash val="solid"/>
+          </a:ln>
+        </p:spPr>
+      </p:sp>
+      <p:sp>
+        <p:nvSpPr>
+          <p:cNvPr id="37" name="Shape 35"/>
+          <p:cNvSpPr/>
+          <p:nvPr/>
+        </p:nvSpPr>
+        <p:spPr>
+          <a:xfrm>
+            <a:off x="3794760" y="4809744"/>
+            <a:ext cx="0" cy="182880"/>
+          </a:xfrm>
+          <a:prstGeom prst="line">
+            <a:avLst/>
+          </a:prstGeom>
+          <a:noFill/>
+          <a:ln w="25400">
+            <a:solidFill>
+              <a:srgbClr val="C9A227"/>
+            </a:solidFill>
+            <a:prstDash val="solid"/>
+          </a:ln>
+        </p:spPr>
+      </p:sp>
+      <p:sp>
+        <p:nvSpPr>
+          <p:cNvPr id="38" name="Shape 36"/>
+          <p:cNvSpPr/>
+          <p:nvPr/>
+        </p:nvSpPr>
+        <p:spPr>
+          <a:xfrm>
+            <a:off x="8366760" y="4809744"/>
+            <a:ext cx="0" cy="182880"/>
+          </a:xfrm>
+          <a:prstGeom prst="line">
+            <a:avLst/>
+          </a:prstGeom>
+          <a:noFill/>
+          <a:ln w="25400">
+            <a:solidFill>
+              <a:srgbClr val="C9A227"/>
+            </a:solidFill>
+            <a:prstDash val="solid"/>
+          </a:ln>
+        </p:spPr>
+      </p:sp>
+      <p:sp>
+        <p:nvSpPr>
+          <p:cNvPr id="39" name="Shape 37"/>
+          <p:cNvSpPr/>
+          <p:nvPr/>
+        </p:nvSpPr>
+        <p:spPr>
+          <a:xfrm>
+            <a:off x="2011680" y="5029200"/>
+            <a:ext cx="3566160" cy="1600200"/>
+          </a:xfrm>
+          <a:prstGeom prst="roundRect">
+            <a:avLst>
+              <a:gd name="adj" fmla="val 4571"/>
+            </a:avLst>
+          </a:prstGeom>
+          <a:solidFill>
+            <a:srgbClr val="E9F2F0"/>
+          </a:solidFill>
+          <a:ln/>
+        </p:spPr>
+      </p:sp>
+      <p:sp>
+        <p:nvSpPr>
+          <p:cNvPr id="40" name="Text 38"/>
+          <p:cNvSpPr txBox="1"/>
+          <p:nvPr/>
+        </p:nvSpPr>
+        <p:spPr>
+          <a:xfrm>
+            <a:off x="2267712" y="5157216"/>
+            <a:ext cx="3108960" cy="292608"/>
+          </a:xfrm>
+          <a:prstGeom prst="rect">
+            <a:avLst/>
+          </a:prstGeom>
+          <a:noFill/>
+          <a:ln/>
+        </p:spPr>
+        <p:txBody>
+          <a:bodyPr wrap="square" lIns="0" tIns="0" rIns="0" bIns="0" rtlCol="0" anchor="ctr"/>
+          <a:lstStyle/>
+          <a:p>
+            <a:pPr indent="0" marL="0">
+              <a:buNone/>
+            </a:pPr>
+            <a:r>
+              <a:rPr lang="en-US" sz="1600" b="1" dirty="0">
+                <a:solidFill>
+                  <a:srgbClr val="0E6E63"/>
+                </a:solidFill>
+                <a:latin typeface="Cambria" pitchFamily="34" charset="0"/>
+                <a:ea typeface="Cambria" pitchFamily="34" charset="-122"/>
+                <a:cs typeface="Cambria" pitchFamily="34" charset="-120"/>
+              </a:rPr>
+              <a:t>Structured</a:t>
+            </a:r>
+            <a:endParaRPr lang="en-US" sz="1600" dirty="0"/>
+          </a:p>
+        </p:txBody>
+      </p:sp>
+      <p:sp>
+        <p:nvSpPr>
+          <p:cNvPr id="41" name="Text 39"/>
+          <p:cNvSpPr txBox="1"/>
+          <p:nvPr/>
+        </p:nvSpPr>
+        <p:spPr>
+          <a:xfrm>
+            <a:off x="2267712" y="5449824"/>
+            <a:ext cx="3108960" cy="256032"/>
+          </a:xfrm>
+          <a:prstGeom prst="rect">
+            <a:avLst/>
+          </a:prstGeom>
+          <a:noFill/>
+          <a:ln/>
+        </p:spPr>
+        <p:txBody>
+          <a:bodyPr wrap="square" lIns="0" tIns="0" rIns="0" bIns="0" rtlCol="0" anchor="ctr"/>
+          <a:lstStyle/>
+          <a:p>
+            <a:pPr indent="0" marL="0">
+              <a:buNone/>
+            </a:pPr>
+            <a:r>
+              <a:rPr lang="en-US" sz="1150" dirty="0">
                 <a:solidFill>
                   <a:srgbClr val="1F2A28"/>
                 </a:solidFill>
@@ -16696,7 +19311,7 @@
                 <a:ea typeface="Consolas" pitchFamily="34" charset="-122"/>
                 <a:cs typeface="Consolas" pitchFamily="34" charset="-120"/>
               </a:rPr>
-              <a:t>raw/places.csv</a:t>
+              <a:t>SQLite</a:t>
             </a:r>
             <a:endParaRPr lang="en-US" sz="1150" dirty="0"/>
           </a:p>
@@ -16704,14 +19319,14 @@
       </p:sp>
       <p:sp>
         <p:nvSpPr>
-          <p:cNvPr id="6" name="Text 4"/>
+          <p:cNvPr id="42" name="Text 40"/>
           <p:cNvSpPr txBox="1"/>
           <p:nvPr/>
         </p:nvSpPr>
         <p:spPr>
           <a:xfrm>
-            <a:off x="2907792" y="1819656"/>
-            <a:ext cx="3273552" cy="292608"/>
+            <a:off x="2267712" y="5705856"/>
+            <a:ext cx="3108960" cy="256032"/>
           </a:xfrm>
           <a:prstGeom prst="rect">
             <a:avLst/>
@@ -16724,75 +19339,173 @@
           <a:lstStyle/>
           <a:p>
             <a:pPr indent="0" marL="0">
+              <a:buNone/>
+            </a:pPr>
+            <a:r>
+              <a:rPr lang="en-US" sz="1250" b="1" dirty="0">
+                <a:solidFill>
+                  <a:srgbClr val="1F2A28"/>
+                </a:solidFill>
+                <a:latin typeface="Cambria" pitchFamily="34" charset="0"/>
+                <a:ea typeface="Cambria" pitchFamily="34" charset="-122"/>
+                <a:cs typeface="Cambria" pitchFamily="34" charset="-120"/>
+              </a:rPr>
+              <a:t>Exact facts</a:t>
+            </a:r>
+            <a:endParaRPr lang="en-US" sz="1250" dirty="0"/>
+          </a:p>
+        </p:txBody>
+      </p:sp>
+      <p:sp>
+        <p:nvSpPr>
+          <p:cNvPr id="43" name="Text 41"/>
+          <p:cNvSpPr txBox="1"/>
+          <p:nvPr/>
+        </p:nvSpPr>
+        <p:spPr>
+          <a:xfrm>
+            <a:off x="2304288" y="5980176"/>
+            <a:ext cx="3017520" cy="594360"/>
+          </a:xfrm>
+          <a:prstGeom prst="rect">
+            <a:avLst/>
+          </a:prstGeom>
+          <a:noFill/>
+          <a:ln/>
+        </p:spPr>
+        <p:txBody>
+          <a:bodyPr wrap="square" lIns="0" tIns="0" rIns="0" bIns="0" rtlCol="0" anchor="ctr"/>
+          <a:lstStyle/>
+          <a:p>
+            <a:pPr marL="127000" indent="-127000">
               <a:lnSpc>
                 <a:spcPct val="95000"/>
               </a:lnSpc>
-              <a:buNone/>
-            </a:pPr>
-            <a:r>
-              <a:rPr lang="en-US" sz="1000" dirty="0">
-                <a:solidFill>
-                  <a:srgbClr val="6B7B77"/>
+              <a:spcAft>
+                <a:spcPts val="200"/>
+              </a:spcAft>
+              <a:buSzPct val="100000"/>
+              <a:buChar char="•"/>
+            </a:pPr>
+            <a:r>
+              <a:rPr lang="en-US" sz="1100" dirty="0">
+                <a:solidFill>
+                  <a:srgbClr val="1F2A28"/>
                 </a:solidFill>
                 <a:latin typeface="Calibri" pitchFamily="34" charset="0"/>
                 <a:ea typeface="Calibri" pitchFamily="34" charset="-122"/>
                 <a:cs typeface="Calibri" pitchFamily="34" charset="-120"/>
               </a:rPr>
-              <a:t>2 messy rows · rating=0 · "Riyadh, Saudi Arabia"</a:t>
-            </a:r>
-            <a:endParaRPr lang="en-US" sz="1000" dirty="0"/>
-          </a:p>
-        </p:txBody>
-      </p:sp>
-      <p:sp>
-        <p:nvSpPr>
-          <p:cNvPr id="7" name="Text 5"/>
-          <p:cNvSpPr txBox="1"/>
-          <p:nvPr/>
-        </p:nvSpPr>
-        <p:spPr>
-          <a:xfrm>
-            <a:off x="6446520" y="1554480"/>
-            <a:ext cx="1463040" cy="274320"/>
-          </a:xfrm>
-          <a:prstGeom prst="rect">
-            <a:avLst/>
-          </a:prstGeom>
-          <a:noFill/>
-          <a:ln/>
-        </p:spPr>
-        <p:txBody>
-          <a:bodyPr wrap="square" lIns="0" tIns="0" rIns="0" bIns="0" rtlCol="0" anchor="ctr"/>
-          <a:lstStyle/>
-          <a:p>
-            <a:pPr indent="0" marL="0">
-              <a:buNone/>
-            </a:pPr>
-            <a:r>
-              <a:rPr lang="en-US" sz="1000" i="1" dirty="0">
-                <a:solidFill>
-                  <a:srgbClr val="6B7B77"/>
+              <a:t>dates</a:t>
+            </a:r>
+            <a:endParaRPr lang="en-US" sz="1100" dirty="0"/>
+          </a:p>
+          <a:p>
+            <a:pPr marL="127000" indent="-127000">
+              <a:lnSpc>
+                <a:spcPct val="95000"/>
+              </a:lnSpc>
+              <a:spcAft>
+                <a:spcPts val="200"/>
+              </a:spcAft>
+              <a:buSzPct val="100000"/>
+              <a:buChar char="•"/>
+            </a:pPr>
+            <a:r>
+              <a:rPr lang="en-US" sz="1100" dirty="0">
+                <a:solidFill>
+                  <a:srgbClr val="1F2A28"/>
                 </a:solidFill>
                 <a:latin typeface="Calibri" pitchFamily="34" charset="0"/>
                 <a:ea typeface="Calibri" pitchFamily="34" charset="-122"/>
                 <a:cs typeface="Calibri" pitchFamily="34" charset="-120"/>
               </a:rPr>
-              <a:t>collect</a:t>
-            </a:r>
-            <a:endParaRPr lang="en-US" sz="1000" dirty="0"/>
-          </a:p>
-        </p:txBody>
-      </p:sp>
-      <p:sp>
-        <p:nvSpPr>
-          <p:cNvPr id="8" name="Text 6"/>
+              <a:t>prices</a:t>
+            </a:r>
+            <a:endParaRPr lang="en-US" sz="1100" dirty="0"/>
+          </a:p>
+          <a:p>
+            <a:pPr marL="127000" indent="-127000">
+              <a:lnSpc>
+                <a:spcPct val="95000"/>
+              </a:lnSpc>
+              <a:spcAft>
+                <a:spcPts val="200"/>
+              </a:spcAft>
+              <a:buSzPct val="100000"/>
+              <a:buChar char="•"/>
+            </a:pPr>
+            <a:r>
+              <a:rPr lang="en-US" sz="1100" dirty="0">
+                <a:solidFill>
+                  <a:srgbClr val="1F2A28"/>
+                </a:solidFill>
+                <a:latin typeface="Calibri" pitchFamily="34" charset="0"/>
+                <a:ea typeface="Calibri" pitchFamily="34" charset="-122"/>
+                <a:cs typeface="Calibri" pitchFamily="34" charset="-120"/>
+              </a:rPr>
+              <a:t>ratings</a:t>
+            </a:r>
+            <a:endParaRPr lang="en-US" sz="1100" dirty="0"/>
+          </a:p>
+          <a:p>
+            <a:pPr marL="127000" indent="-127000">
+              <a:lnSpc>
+                <a:spcPct val="95000"/>
+              </a:lnSpc>
+              <a:spcAft>
+                <a:spcPts val="200"/>
+              </a:spcAft>
+              <a:buSzPct val="100000"/>
+              <a:buChar char="•"/>
+            </a:pPr>
+            <a:r>
+              <a:rPr lang="en-US" sz="1100" dirty="0">
+                <a:solidFill>
+                  <a:srgbClr val="1F2A28"/>
+                </a:solidFill>
+                <a:latin typeface="Calibri" pitchFamily="34" charset="0"/>
+                <a:ea typeface="Calibri" pitchFamily="34" charset="-122"/>
+                <a:cs typeface="Calibri" pitchFamily="34" charset="-120"/>
+              </a:rPr>
+              <a:t>coordinates</a:t>
+            </a:r>
+            <a:endParaRPr lang="en-US" sz="1100" dirty="0"/>
+          </a:p>
+        </p:txBody>
+      </p:sp>
+      <p:sp>
+        <p:nvSpPr>
+          <p:cNvPr id="44" name="Shape 42"/>
+          <p:cNvSpPr/>
+          <p:nvPr/>
+        </p:nvSpPr>
+        <p:spPr>
+          <a:xfrm>
+            <a:off x="6583680" y="5029200"/>
+            <a:ext cx="3566160" cy="1600200"/>
+          </a:xfrm>
+          <a:prstGeom prst="roundRect">
+            <a:avLst>
+              <a:gd name="adj" fmla="val 4571"/>
+            </a:avLst>
+          </a:prstGeom>
+          <a:solidFill>
+            <a:srgbClr val="0E6E63"/>
+          </a:solidFill>
+          <a:ln/>
+        </p:spPr>
+      </p:sp>
+      <p:sp>
+        <p:nvSpPr>
+          <p:cNvPr id="45" name="Text 43"/>
           <p:cNvSpPr txBox="1"/>
           <p:nvPr/>
         </p:nvSpPr>
         <p:spPr>
           <a:xfrm>
-            <a:off x="4251960" y="2194560"/>
-            <a:ext cx="548640" cy="320040"/>
+            <a:off x="6839712" y="5157216"/>
+            <a:ext cx="3108960" cy="292608"/>
           </a:xfrm>
           <a:prstGeom prst="rect">
             <a:avLst/>
@@ -16804,56 +19517,34 @@
           <a:bodyPr wrap="square" lIns="0" tIns="0" rIns="0" bIns="0" rtlCol="0" anchor="ctr"/>
           <a:lstStyle/>
           <a:p>
-            <a:pPr algn="ctr" indent="0" marL="0">
+            <a:pPr indent="0" marL="0">
               <a:buNone/>
             </a:pPr>
             <a:r>
-              <a:rPr lang="en-US" sz="2000" b="1" dirty="0">
-                <a:solidFill>
-                  <a:srgbClr val="C9A227"/>
+              <a:rPr lang="en-US" sz="1600" b="1" dirty="0">
+                <a:solidFill>
+                  <a:srgbClr val="FFF3CC"/>
                 </a:solidFill>
                 <a:latin typeface="Cambria" pitchFamily="34" charset="0"/>
                 <a:ea typeface="Cambria" pitchFamily="34" charset="-122"/>
                 <a:cs typeface="Cambria" pitchFamily="34" charset="-120"/>
               </a:rPr>
-              <a:t>↓</a:t>
-            </a:r>
-            <a:endParaRPr lang="en-US" sz="2000" dirty="0"/>
-          </a:p>
-        </p:txBody>
-      </p:sp>
-      <p:sp>
-        <p:nvSpPr>
-          <p:cNvPr id="9" name="Shape 7"/>
-          <p:cNvSpPr/>
-          <p:nvPr/>
-        </p:nvSpPr>
-        <p:spPr>
-          <a:xfrm>
-            <a:off x="2743200" y="2487168"/>
-            <a:ext cx="3566160" cy="749808"/>
-          </a:xfrm>
-          <a:prstGeom prst="roundRect">
-            <a:avLst>
-              <a:gd name="adj" fmla="val 7317"/>
-            </a:avLst>
-          </a:prstGeom>
-          <a:solidFill>
-            <a:srgbClr val="F3EEE4"/>
-          </a:solidFill>
-          <a:ln/>
-        </p:spPr>
-      </p:sp>
-      <p:sp>
-        <p:nvSpPr>
-          <p:cNvPr id="10" name="Text 8"/>
+              <a:t>Semantic</a:t>
+            </a:r>
+            <a:endParaRPr lang="en-US" sz="1600" dirty="0"/>
+          </a:p>
+        </p:txBody>
+      </p:sp>
+      <p:sp>
+        <p:nvSpPr>
+          <p:cNvPr id="46" name="Text 44"/>
           <p:cNvSpPr txBox="1"/>
           <p:nvPr/>
         </p:nvSpPr>
         <p:spPr>
           <a:xfrm>
-            <a:off x="2907792" y="2596896"/>
-            <a:ext cx="3273552" cy="274320"/>
+            <a:off x="6839712" y="5449824"/>
+            <a:ext cx="3108960" cy="256032"/>
           </a:xfrm>
           <a:prstGeom prst="rect">
             <a:avLst/>
@@ -16869,15 +19560,15 @@
               <a:buNone/>
             </a:pPr>
             <a:r>
-              <a:rPr lang="en-US" sz="1150" b="1" dirty="0">
-                <a:solidFill>
-                  <a:srgbClr val="1F2A28"/>
+              <a:rPr lang="en-US" sz="1150" dirty="0">
+                <a:solidFill>
+                  <a:srgbClr val="EAF6F2"/>
                 </a:solidFill>
                 <a:latin typeface="Consolas" pitchFamily="34" charset="0"/>
                 <a:ea typeface="Consolas" pitchFamily="34" charset="-122"/>
                 <a:cs typeface="Consolas" pitchFamily="34" charset="-120"/>
               </a:rPr>
-              <a:t>processed/places_clean.csv</a:t>
+              <a:t>Vector Store</a:t>
             </a:r>
             <a:endParaRPr lang="en-US" sz="1150" dirty="0"/>
           </a:p>
@@ -16885,14 +19576,14 @@
       </p:sp>
       <p:sp>
         <p:nvSpPr>
-          <p:cNvPr id="11" name="Text 9"/>
+          <p:cNvPr id="47" name="Text 45"/>
           <p:cNvSpPr txBox="1"/>
           <p:nvPr/>
         </p:nvSpPr>
         <p:spPr>
           <a:xfrm>
-            <a:off x="2907792" y="2889504"/>
-            <a:ext cx="3273552" cy="292608"/>
+            <a:off x="6839712" y="5705856"/>
+            <a:ext cx="3108960" cy="256032"/>
           </a:xfrm>
           <a:prstGeom prst="rect">
             <a:avLst/>
@@ -16905,1010 +19596,136 @@
           <a:lstStyle/>
           <a:p>
             <a:pPr indent="0" marL="0">
+              <a:buNone/>
+            </a:pPr>
+            <a:r>
+              <a:rPr lang="en-US" sz="1250" b="1" dirty="0">
+                <a:solidFill>
+                  <a:srgbClr val="FFFFFF"/>
+                </a:solidFill>
+                <a:latin typeface="Cambria" pitchFamily="34" charset="0"/>
+                <a:ea typeface="Cambria" pitchFamily="34" charset="-122"/>
+                <a:cs typeface="Cambria" pitchFamily="34" charset="-120"/>
+              </a:rPr>
+              <a:t>Meaning / evidence</a:t>
+            </a:r>
+            <a:endParaRPr lang="en-US" sz="1250" dirty="0"/>
+          </a:p>
+        </p:txBody>
+      </p:sp>
+      <p:sp>
+        <p:nvSpPr>
+          <p:cNvPr id="48" name="Text 46"/>
+          <p:cNvSpPr txBox="1"/>
+          <p:nvPr/>
+        </p:nvSpPr>
+        <p:spPr>
+          <a:xfrm>
+            <a:off x="6876288" y="5980176"/>
+            <a:ext cx="3017520" cy="594360"/>
+          </a:xfrm>
+          <a:prstGeom prst="rect">
+            <a:avLst/>
+          </a:prstGeom>
+          <a:noFill/>
+          <a:ln/>
+        </p:spPr>
+        <p:txBody>
+          <a:bodyPr wrap="square" lIns="0" tIns="0" rIns="0" bIns="0" rtlCol="0" anchor="ctr"/>
+          <a:lstStyle/>
+          <a:p>
+            <a:pPr marL="127000" indent="-127000">
               <a:lnSpc>
                 <a:spcPct val="95000"/>
               </a:lnSpc>
-              <a:buNone/>
-            </a:pPr>
-            <a:r>
-              <a:rPr lang="en-US" sz="1000" dirty="0">
-                <a:solidFill>
-                  <a:srgbClr val="6B7B77"/>
+              <a:spcAft>
+                <a:spcPts val="200"/>
+              </a:spcAft>
+              <a:buSzPct val="100000"/>
+              <a:buChar char="•"/>
+            </a:pPr>
+            <a:r>
+              <a:rPr lang="en-US" sz="1100" dirty="0">
+                <a:solidFill>
+                  <a:srgbClr val="FFFFFF"/>
                 </a:solidFill>
                 <a:latin typeface="Calibri" pitchFamily="34" charset="0"/>
                 <a:ea typeface="Calibri" pitchFamily="34" charset="-122"/>
                 <a:cs typeface="Calibri" pitchFamily="34" charset="-120"/>
               </a:rPr>
-              <a:t>rating 0→null · city→Riyadh/Riyadh</a:t>
-            </a:r>
-            <a:endParaRPr lang="en-US" sz="1000" dirty="0"/>
-          </a:p>
-        </p:txBody>
-      </p:sp>
-      <p:sp>
-        <p:nvSpPr>
-          <p:cNvPr id="12" name="Text 10"/>
-          <p:cNvSpPr txBox="1"/>
-          <p:nvPr/>
-        </p:nvSpPr>
-        <p:spPr>
-          <a:xfrm>
-            <a:off x="6446520" y="2624328"/>
-            <a:ext cx="1463040" cy="274320"/>
-          </a:xfrm>
-          <a:prstGeom prst="rect">
-            <a:avLst/>
-          </a:prstGeom>
-          <a:noFill/>
-          <a:ln/>
-        </p:spPr>
-        <p:txBody>
-          <a:bodyPr wrap="square" lIns="0" tIns="0" rIns="0" bIns="0" rtlCol="0" anchor="ctr"/>
-          <a:lstStyle/>
-          <a:p>
-            <a:pPr indent="0" marL="0">
-              <a:buNone/>
-            </a:pPr>
-            <a:r>
-              <a:rPr lang="en-US" sz="1000" i="1" dirty="0">
-                <a:solidFill>
-                  <a:srgbClr val="6B7B77"/>
+              <a:t>reviews</a:t>
+            </a:r>
+            <a:endParaRPr lang="en-US" sz="1100" dirty="0"/>
+          </a:p>
+          <a:p>
+            <a:pPr marL="127000" indent="-127000">
+              <a:lnSpc>
+                <a:spcPct val="95000"/>
+              </a:lnSpc>
+              <a:spcAft>
+                <a:spcPts val="200"/>
+              </a:spcAft>
+              <a:buSzPct val="100000"/>
+              <a:buChar char="•"/>
+            </a:pPr>
+            <a:r>
+              <a:rPr lang="en-US" sz="1100" dirty="0">
+                <a:solidFill>
+                  <a:srgbClr val="FFFFFF"/>
                 </a:solidFill>
                 <a:latin typeface="Calibri" pitchFamily="34" charset="0"/>
                 <a:ea typeface="Calibri" pitchFamily="34" charset="-122"/>
                 <a:cs typeface="Calibri" pitchFamily="34" charset="-120"/>
               </a:rPr>
-              <a:t>clean</a:t>
-            </a:r>
-            <a:endParaRPr lang="en-US" sz="1000" dirty="0"/>
-          </a:p>
-        </p:txBody>
-      </p:sp>
-      <p:sp>
-        <p:nvSpPr>
-          <p:cNvPr id="13" name="Text 11"/>
-          <p:cNvSpPr txBox="1"/>
-          <p:nvPr/>
-        </p:nvSpPr>
-        <p:spPr>
-          <a:xfrm>
-            <a:off x="4251960" y="3264408"/>
-            <a:ext cx="548640" cy="320040"/>
-          </a:xfrm>
-          <a:prstGeom prst="rect">
-            <a:avLst/>
-          </a:prstGeom>
-          <a:noFill/>
-          <a:ln/>
-        </p:spPr>
-        <p:txBody>
-          <a:bodyPr wrap="square" lIns="0" tIns="0" rIns="0" bIns="0" rtlCol="0" anchor="ctr"/>
-          <a:lstStyle/>
-          <a:p>
-            <a:pPr algn="ctr" indent="0" marL="0">
-              <a:buNone/>
-            </a:pPr>
-            <a:r>
-              <a:rPr lang="en-US" sz="2000" b="1" dirty="0">
-                <a:solidFill>
-                  <a:srgbClr val="C9A227"/>
-                </a:solidFill>
-                <a:latin typeface="Cambria" pitchFamily="34" charset="0"/>
-                <a:ea typeface="Cambria" pitchFamily="34" charset="-122"/>
-                <a:cs typeface="Cambria" pitchFamily="34" charset="-120"/>
-              </a:rPr>
-              <a:t>↓</a:t>
-            </a:r>
-            <a:endParaRPr lang="en-US" sz="2000" dirty="0"/>
-          </a:p>
-        </p:txBody>
-      </p:sp>
-      <p:sp>
-        <p:nvSpPr>
-          <p:cNvPr id="14" name="Text 12"/>
-          <p:cNvSpPr txBox="1"/>
-          <p:nvPr/>
-        </p:nvSpPr>
-        <p:spPr>
-          <a:xfrm>
-            <a:off x="1463040" y="3566160"/>
-            <a:ext cx="6126480" cy="274320"/>
-          </a:xfrm>
-          <a:prstGeom prst="rect">
-            <a:avLst/>
-          </a:prstGeom>
-          <a:noFill/>
-          <a:ln/>
-        </p:spPr>
-        <p:txBody>
-          <a:bodyPr wrap="square" lIns="0" tIns="0" rIns="0" bIns="0" rtlCol="0" anchor="ctr"/>
-          <a:lstStyle/>
-          <a:p>
-            <a:pPr algn="ctr" indent="0" marL="0">
-              <a:buNone/>
-            </a:pPr>
-            <a:r>
-              <a:rPr lang="en-US" sz="1200" b="1" dirty="0">
-                <a:solidFill>
-                  <a:srgbClr val="0E6E63"/>
-                </a:solidFill>
-                <a:latin typeface="Cambria" pitchFamily="34" charset="0"/>
-                <a:ea typeface="Cambria" pitchFamily="34" charset="-122"/>
-                <a:cs typeface="Cambria" pitchFamily="34" charset="-120"/>
-              </a:rPr>
-              <a:t>standardize → splits into two shapes</a:t>
-            </a:r>
-            <a:endParaRPr lang="en-US" sz="1200" dirty="0"/>
-          </a:p>
-        </p:txBody>
-      </p:sp>
-      <p:sp>
-        <p:nvSpPr>
-          <p:cNvPr id="15" name="Shape 13"/>
-          <p:cNvSpPr/>
-          <p:nvPr/>
-        </p:nvSpPr>
-        <p:spPr>
-          <a:xfrm>
-            <a:off x="640080" y="3913632"/>
-            <a:ext cx="3703320" cy="749808"/>
-          </a:xfrm>
-          <a:prstGeom prst="roundRect">
-            <a:avLst>
-              <a:gd name="adj" fmla="val 7317"/>
-            </a:avLst>
-          </a:prstGeom>
-          <a:solidFill>
-            <a:srgbClr val="E9F2F0"/>
-          </a:solidFill>
-          <a:ln/>
-        </p:spPr>
-      </p:sp>
-      <p:sp>
-        <p:nvSpPr>
-          <p:cNvPr id="16" name="Text 14"/>
-          <p:cNvSpPr txBox="1"/>
-          <p:nvPr/>
-        </p:nvSpPr>
-        <p:spPr>
-          <a:xfrm>
-            <a:off x="804672" y="4023360"/>
-            <a:ext cx="3410712" cy="274320"/>
-          </a:xfrm>
-          <a:prstGeom prst="rect">
-            <a:avLst/>
-          </a:prstGeom>
-          <a:noFill/>
-          <a:ln/>
-        </p:spPr>
-        <p:txBody>
-          <a:bodyPr wrap="square" lIns="0" tIns="0" rIns="0" bIns="0" rtlCol="0" anchor="ctr"/>
-          <a:lstStyle/>
-          <a:p>
-            <a:pPr indent="0" marL="0">
-              <a:buNone/>
-            </a:pPr>
-            <a:r>
-              <a:rPr lang="en-US" sz="1150" b="1" dirty="0">
-                <a:solidFill>
-                  <a:srgbClr val="1F2A28"/>
-                </a:solidFill>
-                <a:latin typeface="Consolas" pitchFamily="34" charset="0"/>
-                <a:ea typeface="Consolas" pitchFamily="34" charset="-122"/>
-                <a:cs typeface="Consolas" pitchFamily="34" charset="-120"/>
-              </a:rPr>
-              <a:t>entities_core.csv</a:t>
-            </a:r>
-            <a:endParaRPr lang="en-US" sz="1150" dirty="0"/>
-          </a:p>
-        </p:txBody>
-      </p:sp>
-      <p:sp>
-        <p:nvSpPr>
-          <p:cNvPr id="17" name="Text 15"/>
-          <p:cNvSpPr txBox="1"/>
-          <p:nvPr/>
-        </p:nvSpPr>
-        <p:spPr>
-          <a:xfrm>
-            <a:off x="804672" y="4315968"/>
-            <a:ext cx="3410712" cy="292608"/>
-          </a:xfrm>
-          <a:prstGeom prst="rect">
-            <a:avLst/>
-          </a:prstGeom>
-          <a:noFill/>
-          <a:ln/>
-        </p:spPr>
-        <p:txBody>
-          <a:bodyPr wrap="square" lIns="0" tIns="0" rIns="0" bIns="0" rtlCol="0" anchor="ctr"/>
-          <a:lstStyle/>
-          <a:p>
-            <a:pPr indent="0" marL="0">
+              <a:t>descriptions</a:t>
+            </a:r>
+            <a:endParaRPr lang="en-US" sz="1100" dirty="0"/>
+          </a:p>
+          <a:p>
+            <a:pPr marL="127000" indent="-127000">
               <a:lnSpc>
                 <a:spcPct val="95000"/>
               </a:lnSpc>
-              <a:buNone/>
-            </a:pPr>
-            <a:r>
-              <a:rPr lang="en-US" sz="1000" dirty="0">
-                <a:solidFill>
-                  <a:srgbClr val="6B7B77"/>
+              <a:spcAft>
+                <a:spcPts val="200"/>
+              </a:spcAft>
+              <a:buSzPct val="100000"/>
+              <a:buChar char="•"/>
+            </a:pPr>
+            <a:r>
+              <a:rPr lang="en-US" sz="1100" dirty="0">
+                <a:solidFill>
+                  <a:srgbClr val="FFFFFF"/>
                 </a:solidFill>
                 <a:latin typeface="Calibri" pitchFamily="34" charset="0"/>
                 <a:ea typeface="Calibri" pitchFamily="34" charset="-122"/>
                 <a:cs typeface="Calibri" pitchFamily="34" charset="-120"/>
               </a:rPr>
-              <a:t>facts to FILTER · rating_norm 0.8 · city · price</a:t>
-            </a:r>
-            <a:endParaRPr lang="en-US" sz="1000" dirty="0"/>
-          </a:p>
-        </p:txBody>
-      </p:sp>
-      <p:sp>
-        <p:nvSpPr>
-          <p:cNvPr id="18" name="Shape 16"/>
-          <p:cNvSpPr/>
-          <p:nvPr/>
-        </p:nvSpPr>
-        <p:spPr>
-          <a:xfrm>
-            <a:off x="4617720" y="3913632"/>
-            <a:ext cx="3703320" cy="749808"/>
-          </a:xfrm>
-          <a:prstGeom prst="roundRect">
-            <a:avLst>
-              <a:gd name="adj" fmla="val 7317"/>
-            </a:avLst>
-          </a:prstGeom>
-          <a:solidFill>
-            <a:srgbClr val="FBF4DD"/>
-          </a:solidFill>
-          <a:ln/>
-        </p:spPr>
-      </p:sp>
-      <p:sp>
-        <p:nvSpPr>
-          <p:cNvPr id="19" name="Text 17"/>
-          <p:cNvSpPr txBox="1"/>
-          <p:nvPr/>
-        </p:nvSpPr>
-        <p:spPr>
-          <a:xfrm>
-            <a:off x="4782312" y="4023360"/>
-            <a:ext cx="3410712" cy="274320"/>
-          </a:xfrm>
-          <a:prstGeom prst="rect">
-            <a:avLst/>
-          </a:prstGeom>
-          <a:noFill/>
-          <a:ln/>
-        </p:spPr>
-        <p:txBody>
-          <a:bodyPr wrap="square" lIns="0" tIns="0" rIns="0" bIns="0" rtlCol="0" anchor="ctr"/>
-          <a:lstStyle/>
-          <a:p>
-            <a:pPr indent="0" marL="0">
-              <a:buNone/>
-            </a:pPr>
-            <a:r>
-              <a:rPr lang="en-US" sz="1150" b="1" dirty="0">
-                <a:solidFill>
-                  <a:srgbClr val="1F2A28"/>
-                </a:solidFill>
-                <a:latin typeface="Consolas" pitchFamily="34" charset="0"/>
-                <a:ea typeface="Consolas" pitchFamily="34" charset="-122"/>
-                <a:cs typeface="Consolas" pitchFamily="34" charset="-120"/>
-              </a:rPr>
-              <a:t>kb_documents.csv</a:t>
-            </a:r>
-            <a:endParaRPr lang="en-US" sz="1150" dirty="0"/>
-          </a:p>
-        </p:txBody>
-      </p:sp>
-      <p:sp>
-        <p:nvSpPr>
-          <p:cNvPr id="20" name="Text 18"/>
-          <p:cNvSpPr txBox="1"/>
-          <p:nvPr/>
-        </p:nvSpPr>
-        <p:spPr>
-          <a:xfrm>
-            <a:off x="4782312" y="4315968"/>
-            <a:ext cx="3410712" cy="292608"/>
-          </a:xfrm>
-          <a:prstGeom prst="rect">
-            <a:avLst/>
-          </a:prstGeom>
-          <a:noFill/>
-          <a:ln/>
-        </p:spPr>
-        <p:txBody>
-          <a:bodyPr wrap="square" lIns="0" tIns="0" rIns="0" bIns="0" rtlCol="0" anchor="ctr"/>
-          <a:lstStyle/>
-          <a:p>
-            <a:pPr indent="0" marL="0">
+              <a:t>preferences</a:t>
+            </a:r>
+            <a:endParaRPr lang="en-US" sz="1100" dirty="0"/>
+          </a:p>
+          <a:p>
+            <a:pPr marL="127000" indent="-127000">
               <a:lnSpc>
                 <a:spcPct val="95000"/>
               </a:lnSpc>
-              <a:buNone/>
-            </a:pPr>
-            <a:r>
-              <a:rPr lang="en-US" sz="1000" dirty="0">
-                <a:solidFill>
-                  <a:srgbClr val="6B7B77"/>
+              <a:spcAft>
+                <a:spcPts val="200"/>
+              </a:spcAft>
+              <a:buSzPct val="100000"/>
+              <a:buChar char="•"/>
+            </a:pPr>
+            <a:r>
+              <a:rPr lang="en-US" sz="1100" dirty="0">
+                <a:solidFill>
+                  <a:srgbClr val="FFFFFF"/>
                 </a:solidFill>
                 <a:latin typeface="Calibri" pitchFamily="34" charset="0"/>
                 <a:ea typeface="Calibri" pitchFamily="34" charset="-122"/>
                 <a:cs typeface="Calibri" pitchFamily="34" charset="-120"/>
               </a:rPr>
-              <a:t>TEXT to embed + embed flag · language</a:t>
-            </a:r>
-            <a:endParaRPr lang="en-US" sz="1000" dirty="0"/>
-          </a:p>
-        </p:txBody>
-      </p:sp>
-      <p:sp>
-        <p:nvSpPr>
-          <p:cNvPr id="21" name="Shape 19"/>
-          <p:cNvSpPr/>
-          <p:nvPr/>
-        </p:nvSpPr>
-        <p:spPr>
-          <a:xfrm>
-            <a:off x="8732520" y="1417320"/>
-            <a:ext cx="2880360" cy="2148840"/>
-          </a:xfrm>
-          <a:prstGeom prst="roundRect">
-            <a:avLst>
-              <a:gd name="adj" fmla="val 3404"/>
-            </a:avLst>
-          </a:prstGeom>
-          <a:solidFill>
-            <a:srgbClr val="0B3B36"/>
-          </a:solidFill>
-          <a:ln/>
-        </p:spPr>
-      </p:sp>
-      <p:sp>
-        <p:nvSpPr>
-          <p:cNvPr id="22" name="Text 20"/>
-          <p:cNvSpPr txBox="1"/>
-          <p:nvPr/>
-        </p:nvSpPr>
-        <p:spPr>
-          <a:xfrm>
-            <a:off x="8961120" y="1572768"/>
-            <a:ext cx="2468880" cy="274320"/>
-          </a:xfrm>
-          <a:prstGeom prst="rect">
-            <a:avLst/>
-          </a:prstGeom>
-          <a:noFill/>
-          <a:ln/>
-        </p:spPr>
-        <p:txBody>
-          <a:bodyPr wrap="square" lIns="0" tIns="0" rIns="0" bIns="0" rtlCol="0" anchor="ctr"/>
-          <a:lstStyle/>
-          <a:p>
-            <a:pPr indent="0" marL="0">
-              <a:buNone/>
-            </a:pPr>
-            <a:r>
-              <a:rPr lang="en-US" sz="1300" b="1" dirty="0">
-                <a:solidFill>
-                  <a:srgbClr val="C9A227"/>
-                </a:solidFill>
-                <a:latin typeface="Cambria" pitchFamily="34" charset="0"/>
-                <a:ea typeface="Cambria" pitchFamily="34" charset="-122"/>
-                <a:cs typeface="Cambria" pitchFamily="34" charset="-120"/>
-              </a:rPr>
-              <a:t>Structured layer</a:t>
-            </a:r>
-            <a:endParaRPr lang="en-US" sz="1300" dirty="0"/>
-          </a:p>
-        </p:txBody>
-      </p:sp>
-      <p:sp>
-        <p:nvSpPr>
-          <p:cNvPr id="23" name="Text 21"/>
-          <p:cNvSpPr txBox="1"/>
-          <p:nvPr/>
-        </p:nvSpPr>
-        <p:spPr>
-          <a:xfrm>
-            <a:off x="8961120" y="1883664"/>
-            <a:ext cx="2468880" cy="274320"/>
-          </a:xfrm>
-          <a:prstGeom prst="rect">
-            <a:avLst/>
-          </a:prstGeom>
-          <a:noFill/>
-          <a:ln/>
-        </p:spPr>
-        <p:txBody>
-          <a:bodyPr wrap="square" lIns="0" tIns="0" rIns="0" bIns="0" rtlCol="0" anchor="ctr"/>
-          <a:lstStyle/>
-          <a:p>
-            <a:pPr indent="0" marL="0">
-              <a:buNone/>
-            </a:pPr>
-            <a:r>
-              <a:rPr lang="en-US" sz="1050" dirty="0">
-                <a:solidFill>
-                  <a:srgbClr val="FFFFFF"/>
-                </a:solidFill>
-                <a:latin typeface="Consolas" pitchFamily="34" charset="0"/>
-                <a:ea typeface="Consolas" pitchFamily="34" charset="-122"/>
-                <a:cs typeface="Consolas" pitchFamily="34" charset="-120"/>
-              </a:rPr>
-              <a:t>knowledge_base.sqlite</a:t>
-            </a:r>
-            <a:endParaRPr lang="en-US" sz="1050" dirty="0"/>
-          </a:p>
-        </p:txBody>
-      </p:sp>
-      <p:sp>
-        <p:nvSpPr>
-          <p:cNvPr id="24" name="Text 22"/>
-          <p:cNvSpPr txBox="1"/>
-          <p:nvPr/>
-        </p:nvSpPr>
-        <p:spPr>
-          <a:xfrm>
-            <a:off x="8961120" y="2212848"/>
-            <a:ext cx="2468880" cy="1188720"/>
-          </a:xfrm>
-          <a:prstGeom prst="rect">
-            <a:avLst/>
-          </a:prstGeom>
-          <a:noFill/>
-          <a:ln/>
-        </p:spPr>
-        <p:txBody>
-          <a:bodyPr wrap="square" lIns="0" tIns="0" rIns="0" bIns="0" rtlCol="0" anchor="ctr"/>
-          <a:lstStyle/>
-          <a:p>
-            <a:pPr indent="0" marL="0">
-              <a:lnSpc>
-                <a:spcPct val="105000"/>
-              </a:lnSpc>
-              <a:buNone/>
-            </a:pPr>
-            <a:r>
-              <a:rPr lang="en-US" sz="1050" b="1" dirty="0">
-                <a:solidFill>
-                  <a:srgbClr val="E8F3F0"/>
-                </a:solidFill>
-                <a:latin typeface="Calibri" pitchFamily="34" charset="0"/>
-                <a:ea typeface="Calibri" pitchFamily="34" charset="-122"/>
-                <a:cs typeface="Calibri" pitchFamily="34" charset="-120"/>
-              </a:rPr>
-              <a:t>exact filters</a:t>
-            </a:r>
-            <a:endParaRPr lang="en-US" sz="1050" dirty="0"/>
-          </a:p>
-          <a:p>
-            <a:pPr indent="0" marL="0">
-              <a:lnSpc>
-                <a:spcPct val="105000"/>
-              </a:lnSpc>
-              <a:buNone/>
-            </a:pPr>
-            <a:r>
-              <a:rPr lang="en-US" sz="1050" dirty="0">
-                <a:solidFill>
-                  <a:srgbClr val="BFE0DA"/>
-                </a:solidFill>
-                <a:latin typeface="Calibri" pitchFamily="34" charset="0"/>
-                <a:ea typeface="Calibri" pitchFamily="34" charset="-122"/>
-                <a:cs typeface="Calibri" pitchFamily="34" charset="-120"/>
-              </a:rPr>
-              <a:t>city = Riyadh AND rating_norm ≥ 0.8 AND price ≤ 50</a:t>
-            </a:r>
-            <a:endParaRPr lang="en-US" sz="1050" dirty="0"/>
-          </a:p>
-        </p:txBody>
-      </p:sp>
-      <p:sp>
-        <p:nvSpPr>
-          <p:cNvPr id="25" name="Shape 23"/>
-          <p:cNvSpPr/>
-          <p:nvPr/>
-        </p:nvSpPr>
-        <p:spPr>
-          <a:xfrm>
-            <a:off x="8732520" y="3703320"/>
-            <a:ext cx="2880360" cy="2560320"/>
-          </a:xfrm>
-          <a:prstGeom prst="roundRect">
-            <a:avLst>
-              <a:gd name="adj" fmla="val 2857"/>
-            </a:avLst>
-          </a:prstGeom>
-          <a:solidFill>
-            <a:srgbClr val="0E6E63"/>
-          </a:solidFill>
-          <a:ln/>
-        </p:spPr>
-      </p:sp>
-      <p:sp>
-        <p:nvSpPr>
-          <p:cNvPr id="26" name="Text 24"/>
-          <p:cNvSpPr txBox="1"/>
-          <p:nvPr/>
-        </p:nvSpPr>
-        <p:spPr>
-          <a:xfrm>
-            <a:off x="8961120" y="3858768"/>
-            <a:ext cx="2468880" cy="274320"/>
-          </a:xfrm>
-          <a:prstGeom prst="rect">
-            <a:avLst/>
-          </a:prstGeom>
-          <a:noFill/>
-          <a:ln/>
-        </p:spPr>
-        <p:txBody>
-          <a:bodyPr wrap="square" lIns="0" tIns="0" rIns="0" bIns="0" rtlCol="0" anchor="ctr"/>
-          <a:lstStyle/>
-          <a:p>
-            <a:pPr indent="0" marL="0">
-              <a:buNone/>
-            </a:pPr>
-            <a:r>
-              <a:rPr lang="en-US" sz="1300" b="1" dirty="0">
-                <a:solidFill>
-                  <a:srgbClr val="FFF3CC"/>
-                </a:solidFill>
-                <a:latin typeface="Cambria" pitchFamily="34" charset="0"/>
-                <a:ea typeface="Cambria" pitchFamily="34" charset="-122"/>
-                <a:cs typeface="Cambria" pitchFamily="34" charset="-120"/>
-              </a:rPr>
-              <a:t>Semantic layer</a:t>
-            </a:r>
-            <a:endParaRPr lang="en-US" sz="1300" dirty="0"/>
-          </a:p>
-        </p:txBody>
-      </p:sp>
-      <p:sp>
-        <p:nvSpPr>
-          <p:cNvPr id="27" name="Text 25"/>
-          <p:cNvSpPr txBox="1"/>
-          <p:nvPr/>
-        </p:nvSpPr>
-        <p:spPr>
-          <a:xfrm>
-            <a:off x="8961120" y="4169664"/>
-            <a:ext cx="2468880" cy="274320"/>
-          </a:xfrm>
-          <a:prstGeom prst="rect">
-            <a:avLst/>
-          </a:prstGeom>
-          <a:noFill/>
-          <a:ln/>
-        </p:spPr>
-        <p:txBody>
-          <a:bodyPr wrap="square" lIns="0" tIns="0" rIns="0" bIns="0" rtlCol="0" anchor="ctr"/>
-          <a:lstStyle/>
-          <a:p>
-            <a:pPr indent="0" marL="0">
-              <a:buNone/>
-            </a:pPr>
-            <a:r>
-              <a:rPr lang="en-US" sz="1000" dirty="0">
-                <a:solidFill>
-                  <a:srgbClr val="FFFFFF"/>
-                </a:solidFill>
-                <a:latin typeface="Consolas" pitchFamily="34" charset="0"/>
-                <a:ea typeface="Consolas" pitchFamily="34" charset="-122"/>
-                <a:cs typeface="Consolas" pitchFamily="34" charset="-120"/>
-              </a:rPr>
-              <a:t>vector_store/  (.npy + meta)</a:t>
-            </a:r>
-            <a:endParaRPr lang="en-US" sz="1000" dirty="0"/>
-          </a:p>
-        </p:txBody>
-      </p:sp>
-      <p:sp>
-        <p:nvSpPr>
-          <p:cNvPr id="28" name="Text 26"/>
-          <p:cNvSpPr txBox="1"/>
-          <p:nvPr/>
-        </p:nvSpPr>
-        <p:spPr>
-          <a:xfrm>
-            <a:off x="8961120" y="4498848"/>
-            <a:ext cx="2468880" cy="1188720"/>
-          </a:xfrm>
-          <a:prstGeom prst="rect">
-            <a:avLst/>
-          </a:prstGeom>
-          <a:noFill/>
-          <a:ln/>
-        </p:spPr>
-        <p:txBody>
-          <a:bodyPr wrap="square" lIns="0" tIns="0" rIns="0" bIns="0" rtlCol="0" anchor="ctr"/>
-          <a:lstStyle/>
-          <a:p>
-            <a:pPr indent="0" marL="0">
-              <a:lnSpc>
-                <a:spcPct val="105000"/>
-              </a:lnSpc>
-              <a:buNone/>
-            </a:pPr>
-            <a:r>
-              <a:rPr lang="en-US" sz="1050" b="1" dirty="0">
-                <a:solidFill>
-                  <a:srgbClr val="FFFFFF"/>
-                </a:solidFill>
-                <a:latin typeface="Calibri" pitchFamily="34" charset="0"/>
-                <a:ea typeface="Calibri" pitchFamily="34" charset="-122"/>
-                <a:cs typeface="Calibri" pitchFamily="34" charset="-120"/>
-              </a:rPr>
-              <a:t>meaning search</a:t>
-            </a:r>
-            <a:endParaRPr lang="en-US" sz="1050" dirty="0"/>
-          </a:p>
-          <a:p>
-            <a:pPr indent="0" marL="0">
-              <a:lnSpc>
-                <a:spcPct val="105000"/>
-              </a:lnSpc>
-              <a:buNone/>
-            </a:pPr>
-            <a:r>
-              <a:rPr lang="en-US" sz="1050" dirty="0">
-                <a:solidFill>
-                  <a:srgbClr val="E8F3F0"/>
-                </a:solidFill>
-                <a:latin typeface="Calibri" pitchFamily="34" charset="0"/>
-                <a:ea typeface="Calibri" pitchFamily="34" charset="-122"/>
-                <a:cs typeface="Calibri" pitchFamily="34" charset="-120"/>
-              </a:rPr>
-              <a:t>“cozy, family-friendly vibe” → 768-dim vector</a:t>
-            </a:r>
-            <a:endParaRPr lang="en-US" sz="1050" dirty="0"/>
-          </a:p>
-        </p:txBody>
-      </p:sp>
-      <p:sp>
-        <p:nvSpPr>
-          <p:cNvPr id="29" name="Text 27"/>
-          <p:cNvSpPr txBox="1"/>
-          <p:nvPr/>
-        </p:nvSpPr>
-        <p:spPr>
-          <a:xfrm>
-            <a:off x="8229600" y="2194560"/>
-            <a:ext cx="548640" cy="457200"/>
-          </a:xfrm>
-          <a:prstGeom prst="rect">
-            <a:avLst/>
-          </a:prstGeom>
-          <a:noFill/>
-          <a:ln/>
-        </p:spPr>
-        <p:txBody>
-          <a:bodyPr wrap="square" lIns="0" tIns="0" rIns="0" bIns="0" rtlCol="0" anchor="ctr"/>
-          <a:lstStyle/>
-          <a:p>
-            <a:pPr algn="ctr" indent="0" marL="0">
-              <a:buNone/>
-            </a:pPr>
-            <a:r>
-              <a:rPr lang="en-US" sz="2600" b="1" dirty="0">
-                <a:solidFill>
-                  <a:srgbClr val="C9A227"/>
-                </a:solidFill>
-                <a:latin typeface="Cambria" pitchFamily="34" charset="0"/>
-                <a:ea typeface="Cambria" pitchFamily="34" charset="-122"/>
-                <a:cs typeface="Cambria" pitchFamily="34" charset="-120"/>
-              </a:rPr>
-              <a:t>→</a:t>
-            </a:r>
-            <a:endParaRPr lang="en-US" sz="2600" dirty="0"/>
-          </a:p>
-        </p:txBody>
-      </p:sp>
-      <p:sp>
-        <p:nvSpPr>
-          <p:cNvPr id="30" name="Text 28"/>
-          <p:cNvSpPr txBox="1"/>
-          <p:nvPr/>
-        </p:nvSpPr>
-        <p:spPr>
-          <a:xfrm>
-            <a:off x="8229600" y="4480560"/>
-            <a:ext cx="548640" cy="457200"/>
-          </a:xfrm>
-          <a:prstGeom prst="rect">
-            <a:avLst/>
-          </a:prstGeom>
-          <a:noFill/>
-          <a:ln/>
-        </p:spPr>
-        <p:txBody>
-          <a:bodyPr wrap="square" lIns="0" tIns="0" rIns="0" bIns="0" rtlCol="0" anchor="ctr"/>
-          <a:lstStyle/>
-          <a:p>
-            <a:pPr algn="ctr" indent="0" marL="0">
-              <a:buNone/>
-            </a:pPr>
-            <a:r>
-              <a:rPr lang="en-US" sz="2600" b="1" dirty="0">
-                <a:solidFill>
-                  <a:srgbClr val="C9A227"/>
-                </a:solidFill>
-                <a:latin typeface="Cambria" pitchFamily="34" charset="0"/>
-                <a:ea typeface="Cambria" pitchFamily="34" charset="-122"/>
-                <a:cs typeface="Cambria" pitchFamily="34" charset="-120"/>
-              </a:rPr>
-              <a:t>→</a:t>
-            </a:r>
-            <a:endParaRPr lang="en-US" sz="2600" dirty="0"/>
-          </a:p>
-        </p:txBody>
-      </p:sp>
-      <p:sp>
-        <p:nvSpPr>
-          <p:cNvPr id="31" name="Text 29"/>
-          <p:cNvSpPr txBox="1"/>
-          <p:nvPr/>
-        </p:nvSpPr>
-        <p:spPr>
-          <a:xfrm>
-            <a:off x="8732520" y="5989320"/>
-            <a:ext cx="2926080" cy="274320"/>
-          </a:xfrm>
-          <a:prstGeom prst="rect">
-            <a:avLst/>
-          </a:prstGeom>
-          <a:noFill/>
-          <a:ln/>
-        </p:spPr>
-        <p:txBody>
-          <a:bodyPr wrap="square" lIns="0" tIns="0" rIns="0" bIns="0" rtlCol="0" anchor="ctr"/>
-          <a:lstStyle/>
-          <a:p>
-            <a:pPr algn="ctr" indent="0" marL="0">
-              <a:buNone/>
-            </a:pPr>
-            <a:r>
-              <a:rPr lang="en-US" sz="950" i="1" dirty="0">
-                <a:solidFill>
-                  <a:srgbClr val="6B7B77"/>
-                </a:solidFill>
-                <a:latin typeface="Calibri" pitchFamily="34" charset="0"/>
-                <a:ea typeface="Calibri" pitchFamily="34" charset="-122"/>
-                <a:cs typeface="Calibri" pitchFamily="34" charset="-120"/>
-              </a:rPr>
-              <a:t>build KB (regenerable, git-ignored)</a:t>
-            </a:r>
-            <a:endParaRPr lang="en-US" sz="950" dirty="0"/>
-          </a:p>
-        </p:txBody>
-      </p:sp>
-      <p:sp>
-        <p:nvSpPr>
-          <p:cNvPr id="32" name="Shape 30"/>
-          <p:cNvSpPr/>
-          <p:nvPr/>
-        </p:nvSpPr>
-        <p:spPr>
-          <a:xfrm>
-            <a:off x="640080" y="5029200"/>
-            <a:ext cx="7680960" cy="1234440"/>
-          </a:xfrm>
-          <a:prstGeom prst="roundRect">
-            <a:avLst>
-              <a:gd name="adj" fmla="val 5185"/>
-            </a:avLst>
-          </a:prstGeom>
-          <a:solidFill>
-            <a:srgbClr val="F3EEE4"/>
-          </a:solidFill>
-          <a:ln/>
-        </p:spPr>
-      </p:sp>
-      <p:sp>
-        <p:nvSpPr>
-          <p:cNvPr id="33" name="Text 31"/>
-          <p:cNvSpPr txBox="1"/>
-          <p:nvPr/>
-        </p:nvSpPr>
-        <p:spPr>
-          <a:xfrm>
-            <a:off x="868680" y="5138928"/>
-            <a:ext cx="7315200" cy="274320"/>
-          </a:xfrm>
-          <a:prstGeom prst="rect">
-            <a:avLst/>
-          </a:prstGeom>
-          <a:noFill/>
-          <a:ln/>
-        </p:spPr>
-        <p:txBody>
-          <a:bodyPr wrap="square" lIns="0" tIns="0" rIns="0" bIns="0" rtlCol="0" anchor="ctr"/>
-          <a:lstStyle/>
-          <a:p>
-            <a:pPr indent="0" marL="0">
-              <a:buNone/>
-            </a:pPr>
-            <a:r>
-              <a:rPr lang="en-US" sz="1200" b="1" dirty="0">
-                <a:solidFill>
-                  <a:srgbClr val="0E6E63"/>
-                </a:solidFill>
-                <a:latin typeface="Cambria" pitchFamily="34" charset="0"/>
-                <a:ea typeface="Cambria" pitchFamily="34" charset="-122"/>
-                <a:cs typeface="Cambria" pitchFamily="34" charset="-120"/>
-              </a:rPr>
-              <a:t>Entity resolution (between the split and the KB) writes 4 relationship files:</a:t>
-            </a:r>
-            <a:endParaRPr lang="en-US" sz="1200" dirty="0"/>
-          </a:p>
-        </p:txBody>
-      </p:sp>
-      <p:sp>
-        <p:nvSpPr>
-          <p:cNvPr id="34" name="Text 32"/>
-          <p:cNvSpPr txBox="1"/>
-          <p:nvPr/>
-        </p:nvSpPr>
-        <p:spPr>
-          <a:xfrm>
-            <a:off x="868680" y="5440680"/>
-            <a:ext cx="7315200" cy="731520"/>
-          </a:xfrm>
-          <a:prstGeom prst="rect">
-            <a:avLst/>
-          </a:prstGeom>
-          <a:noFill/>
-          <a:ln/>
-        </p:spPr>
-        <p:txBody>
-          <a:bodyPr wrap="square" lIns="0" tIns="0" rIns="0" bIns="0" rtlCol="0" anchor="ctr"/>
-          <a:lstStyle/>
-          <a:p>
-            <a:pPr indent="0" marL="0">
-              <a:lnSpc>
-                <a:spcPct val="115000"/>
-              </a:lnSpc>
-              <a:buNone/>
-            </a:pPr>
-            <a:r>
-              <a:rPr lang="en-US" sz="1100" b="1" dirty="0">
-                <a:solidFill>
-                  <a:srgbClr val="1F2A28"/>
-                </a:solidFill>
-                <a:latin typeface="Calibri" pitchFamily="34" charset="0"/>
-                <a:ea typeface="Calibri" pitchFamily="34" charset="-122"/>
-                <a:cs typeface="Calibri" pitchFamily="34" charset="-120"/>
-              </a:rPr>
-              <a:t>canonical_entities</a:t>
-            </a:r>
-            <a:pPr indent="0" marL="0">
-              <a:lnSpc>
-                <a:spcPct val="115000"/>
-              </a:lnSpc>
-              <a:buNone/>
-            </a:pPr>
-            <a:r>
-              <a:rPr lang="en-US" sz="1100" dirty="0">
-                <a:solidFill>
-                  <a:srgbClr val="6B7B77"/>
-                </a:solidFill>
-                <a:latin typeface="Calibri" pitchFamily="34" charset="0"/>
-                <a:ea typeface="Calibri" pitchFamily="34" charset="-122"/>
-                <a:cs typeface="Calibri" pitchFamily="34" charset="-120"/>
-              </a:rPr>
-              <a:t> (master list)   </a:t>
-            </a:r>
-            <a:pPr indent="0" marL="0">
-              <a:lnSpc>
-                <a:spcPct val="115000"/>
-              </a:lnSpc>
-              <a:buNone/>
-            </a:pPr>
-            <a:r>
-              <a:rPr lang="en-US" sz="1100" b="1" dirty="0">
-                <a:solidFill>
-                  <a:srgbClr val="1F2A28"/>
-                </a:solidFill>
-                <a:latin typeface="Calibri" pitchFamily="34" charset="0"/>
-                <a:ea typeface="Calibri" pitchFamily="34" charset="-122"/>
-                <a:cs typeface="Calibri" pitchFamily="34" charset="-120"/>
-              </a:rPr>
-              <a:t>entity_crosswalk</a:t>
-            </a:r>
-            <a:pPr indent="0" marL="0">
-              <a:lnSpc>
-                <a:spcPct val="115000"/>
-              </a:lnSpc>
-              <a:buNone/>
-            </a:pPr>
-            <a:r>
-              <a:rPr lang="en-US" sz="1100" dirty="0">
-                <a:solidFill>
-                  <a:srgbClr val="6B7B77"/>
-                </a:solidFill>
-                <a:latin typeface="Calibri" pitchFamily="34" charset="0"/>
-                <a:ea typeface="Calibri" pitchFamily="34" charset="-122"/>
-                <a:cs typeface="Calibri" pitchFamily="34" charset="-120"/>
-              </a:rPr>
-              <a:t> (source→canonical join hub)</a:t>
-            </a:r>
-            <a:endParaRPr lang="en-US" sz="1100" dirty="0"/>
-          </a:p>
-          <a:p>
-            <a:pPr indent="0" marL="0">
-              <a:lnSpc>
-                <a:spcPct val="115000"/>
-              </a:lnSpc>
-              <a:buNone/>
-            </a:pPr>
-            <a:r>
-              <a:rPr lang="en-US" sz="1100" b="1" dirty="0">
-                <a:solidFill>
-                  <a:srgbClr val="1F2A28"/>
-                </a:solidFill>
-                <a:latin typeface="Calibri" pitchFamily="34" charset="0"/>
-                <a:ea typeface="Calibri" pitchFamily="34" charset="-122"/>
-                <a:cs typeface="Calibri" pitchFamily="34" charset="-120"/>
-              </a:rPr>
-              <a:t>candidate_links</a:t>
-            </a:r>
-            <a:pPr indent="0" marL="0">
-              <a:lnSpc>
-                <a:spcPct val="115000"/>
-              </a:lnSpc>
-              <a:buNone/>
-            </a:pPr>
-            <a:r>
-              <a:rPr lang="en-US" sz="1100" dirty="0">
-                <a:solidFill>
-                  <a:srgbClr val="6B7B77"/>
-                </a:solidFill>
-                <a:latin typeface="Calibri" pitchFamily="34" charset="0"/>
-                <a:ea typeface="Calibri" pitchFamily="34" charset="-122"/>
-                <a:cs typeface="Calibri" pitchFamily="34" charset="-120"/>
-              </a:rPr>
-              <a:t> (near-matches, not merged)   </a:t>
-            </a:r>
-            <a:pPr indent="0" marL="0">
-              <a:lnSpc>
-                <a:spcPct val="115000"/>
-              </a:lnSpc>
-              <a:buNone/>
-            </a:pPr>
-            <a:r>
-              <a:rPr lang="en-US" sz="1100" b="1" dirty="0">
-                <a:solidFill>
-                  <a:srgbClr val="1F2A28"/>
-                </a:solidFill>
-                <a:latin typeface="Calibri" pitchFamily="34" charset="0"/>
-                <a:ea typeface="Calibri" pitchFamily="34" charset="-122"/>
-                <a:cs typeface="Calibri" pitchFamily="34" charset="-120"/>
-              </a:rPr>
-              <a:t>review_place_links</a:t>
-            </a:r>
-            <a:pPr indent="0" marL="0">
-              <a:lnSpc>
-                <a:spcPct val="115000"/>
-              </a:lnSpc>
-              <a:buNone/>
-            </a:pPr>
-            <a:r>
-              <a:rPr lang="en-US" sz="1100" dirty="0">
-                <a:solidFill>
-                  <a:srgbClr val="6B7B77"/>
-                </a:solidFill>
-                <a:latin typeface="Calibri" pitchFamily="34" charset="0"/>
-                <a:ea typeface="Calibri" pitchFamily="34" charset="-122"/>
-                <a:cs typeface="Calibri" pitchFamily="34" charset="-120"/>
-              </a:rPr>
-              <a:t> (review→place)</a:t>
+              <a:t>contextual text</a:t>
             </a:r>
             <a:endParaRPr lang="en-US" sz="1100" dirty="0"/>
           </a:p>

</xml_diff>